<commit_message>
Presidente do conselho com termo, tela de Pessoas, e-mail por SMTP e login com Google
Atualiza personas, arquitetura e a apresentação: a presidente do conselho também assina o
termo de confidencialidade antes de ver tudo; registra a tela de Pessoas, o envio de e-mail
por SMTP e o login com Google como feitos.

Co-Authored-By: Claude Opus 5.5 <noreply@anthropic.com>
Claude-Session: https://claude.ai/code/session_011tahMqXyefoFBNBfHuxSSe
</commit_message>
<xml_diff>
--- a/apresentacoes/Personas-e-perfis-de-acesso.pptx
+++ b/apresentacoes/Personas-e-perfis-de-acesso.pptx
@@ -119,18 +119,18 @@
   <p:extLst>
     <p:ext uri="{521415D9-36F7-43E2-AB2F-B90AF26B5E84}">
       <p14:sectionLst xmlns:p14="http://schemas.microsoft.com/office/powerpoint/2010/main">
-        <p14:section name="Abertura" id="{e9705095-a59f-4aa4-4c56-fe1f71272e75}">
+        <p14:section name="Abertura" id="{37d84776-2c46-e6a7-b846-f5cde78e2c22}">
           <p14:sldIdLst>
             <p14:sldId id="256"/>
             <p14:sldId id="257"/>
           </p14:sldIdLst>
         </p14:section>
-        <p14:section name="Perfis de acesso" id="{fdedcf5a-b545-1a9d-92c4-ebd8f9b3de22}">
+        <p14:section name="Perfis de acesso" id="{ef0caf76-629a-ba6a-f905-e1c0cfa54395}">
           <p14:sldIdLst>
             <p14:sldId id="258"/>
           </p14:sldIdLst>
         </p14:section>
-        <p14:section name="Personas" id="{216a4c32-53f7-a582-f282-a0a637c47858}">
+        <p14:section name="Personas" id="{56c51697-6052-1a16-d70e-cd48115da196}">
           <p14:sldIdLst>
             <p14:sldId id="259"/>
             <p14:sldId id="260"/>
@@ -138,24 +138,24 @@
             <p14:sldId id="262"/>
           </p14:sldIdLst>
         </p14:section>
-        <p14:section name="De → para" id="{b891550d-335a-9a07-a886-ff2918d19243}">
+        <p14:section name="De → para" id="{6db29f53-71df-b228-80ac-a2e471ffb243}">
           <p14:sldIdLst>
             <p14:sldId id="263"/>
           </p14:sldIdLst>
         </p14:section>
-        <p14:section name="O que cada um acessa" id="{fd54fa8d-7745-2741-b923-9719e8c75e54}">
+        <p14:section name="O que cada um acessa" id="{d8235263-3fa2-2ee3-e6e6-44548aa185a9}">
           <p14:sldIdLst>
             <p14:sldId id="264"/>
             <p14:sldId id="265"/>
           </p14:sldIdLst>
         </p14:section>
-        <p14:section name="Privacidade e princípios" id="{62fb017b-f097-fac2-42c1-99411df4e58e}">
+        <p14:section name="Privacidade e princípios" id="{34e3011d-1882-9dd2-61c1-2bbc21de0a7e}">
           <p14:sldIdLst>
             <p14:sldId id="266"/>
             <p14:sldId id="267"/>
           </p14:sldIdLst>
         </p14:section>
-        <p14:section name="Encerramento" id="{bc38fe22-07b1-9cb7-4292-cdb1c13dda16}">
+        <p14:section name="Encerramento" id="{49c5f57a-9b6b-b5f2-4904-fe0cd77a7fe2}">
           <p14:sldIdLst>
             <p14:sldId id="268"/>
           </p14:sldIdLst>
@@ -652,7 +652,7 @@
           <a:p>
             <a:r>
               <a:rPr lang="en-US" dirty="0"/>
-              <a:t>Segundo quadro: as ferramentas de gestão. O síndico e o administrador do site com o termo de confidencialidade assinado têm os mesmos poderes. A presidente do conselho vê tudo e responde denúncias, mas não aprova moradores, não atribui cargos nem configura. Os demais membros do conselho veem as denúncias só em números e o registro sem identificar as pessoas.</a:t>
+              <a:t>Segundo quadro: as ferramentas de gestão. O síndico e o administrador do site com o termo de confidencialidade assinado têm os mesmos poderes. A presidente do conselho, também com o termo assinado, vê tudo e responde denúncias, mas não aprova moradores, não atribui cargos nem configura. Os demais membros do conselho veem as denúncias só em números e o registro sem identificar as pessoas.</a:t>
             </a:r>
             <a:endParaRPr lang="en-US" dirty="0"/>
           </a:p>
@@ -1268,7 +1268,7 @@
           <a:p>
             <a:r>
               <a:rPr lang="en-US" dirty="0"/>
-              <a:t>Carlos e Sueli tocam o dia a dia. A Helena preside o conselho e vê tudo para fiscalizar, sem aprovar moradores, atribuir cargos ou configurar. O Otávio, membro do conselho, acompanha números e andamento sem identificar os moradores.</a:t>
+              <a:t>Carlos e Sueli tocam o dia a dia. A Helena preside o conselho e, depois de assinar o termo de confidencialidade, vê tudo para fiscalizar, sem aprovar moradores, atribuir cargos ou configurar. O Otávio, membro do conselho, acompanha números e andamento sem identificar os moradores.</a:t>
             </a:r>
             <a:endParaRPr lang="en-US" dirty="0"/>
           </a:p>
@@ -2975,7 +2975,7 @@
                           <a:ea typeface="Arial" pitchFamily="34" charset="-122"/>
                           <a:cs typeface="Arial" pitchFamily="34" charset="-120"/>
                         </a:rPr>
-                        <a:t>do conselho</a:t>
+                        <a:t>com o termo</a:t>
                       </a:r>
                       <a:endParaRPr lang="en-US" sz="1100" dirty="0">
                         <a:latin typeface="Arial" charset="0"/>
@@ -8493,7 +8493,7 @@
                 <a:ea typeface="Calibri" pitchFamily="34" charset="-122"/>
                 <a:cs typeface="Calibri" pitchFamily="34" charset="-120"/>
               </a:rPr>
-              <a:t>Sem nomes: código no lugar do nome, sem casa, e-mail, motivo ou IP. Se configurado: só se o síndico ligar a opção. O administrador do site sem o termo assinado só cadastra casas, envia convites e configura o site, sem dados pessoais (registro sem nomes).</a:t>
+              <a:t>Sem nomes: código no lugar do nome, sem casa, e-mail, motivo ou IP. Se configurado: só se o síndico ligar a opção. Sem o termo assinado, o presidente do conselho vê como os membros do conselho, e o administrador do site só cadastra casas, envia convites e configura o site, sem dados pessoais.</a:t>
             </a:r>
             <a:endParaRPr lang="en-US" sz="1200" dirty="0"/>
           </a:p>
@@ -8756,7 +8756,7 @@
                 <a:ea typeface="Calibri" pitchFamily="34" charset="-122"/>
                 <a:cs typeface="Calibri" pitchFamily="34" charset="-120"/>
               </a:rPr>
-              <a:t>Denúncias só em números e registro com códigos. A presidência do conselho vê tudo.</a:t>
+              <a:t>Denúncias só em números e registro com códigos. A presidência do conselho vê tudo, com o termo.</a:t>
             </a:r>
             <a:endParaRPr lang="en-US" sz="1400" dirty="0"/>
           </a:p>
@@ -8905,7 +8905,7 @@
                 <a:ea typeface="Calibri" pitchFamily="34" charset="-122"/>
                 <a:cs typeface="Calibri" pitchFamily="34" charset="-120"/>
               </a:rPr>
-              <a:t>O administrador do site só vê e usa tudo depois de assinar o termo de confidencialidade.</a:t>
+              <a:t>Administrador do site e presidente do conselho só veem tudo depois de assinar o termo de confidencialidade.</a:t>
             </a:r>
             <a:endParaRPr lang="en-US" sz="1400" dirty="0"/>
           </a:p>
@@ -10329,7 +10329,7 @@
                 <a:ea typeface="Calibri" pitchFamily="34" charset="-122"/>
                 <a:cs typeface="Calibri" pitchFamily="34" charset="-120"/>
               </a:rPr>
-              <a:t>Presidente do conselho: vê tudo e responde denúncias, sem aprovar moradores, atribuir cargos ou configurar.</a:t>
+              <a:t>Presidente do conselho: assina o termo e vê tudo, sem aprovar moradores, atribuir cargos ou configurar.</a:t>
             </a:r>
             <a:endParaRPr lang="en-US" sz="1800" dirty="0"/>
           </a:p>
@@ -13965,7 +13965,7 @@
                 <a:ea typeface="Calibri" pitchFamily="34" charset="-122"/>
                 <a:cs typeface="Calibri" pitchFamily="34" charset="-120"/>
               </a:rPr>
-              <a:t>“O conselho responde aos moradores. Preciso ver tudo para fiscalizar de verdade.”</a:t>
+              <a:t>“O conselho responde aos moradores. Assinei o termo para ver tudo e fiscalizar de verdade.”</a:t>
             </a:r>
             <a:endParaRPr lang="en-US" sz="1400" dirty="0"/>
           </a:p>
@@ -14018,7 +14018,7 @@
                 <a:ea typeface="Calibri" pitchFamily="34" charset="-122"/>
                 <a:cs typeface="Calibri" pitchFamily="34" charset="-120"/>
               </a:rPr>
-              <a:t>Dados completos e registro fácil de filtrar; saber quem pode fazer o que ela não faz.</a:t>
+              <a:t>Assinar o termo no portal; depois, dados completos e registro fácil de filtrar.</a:t>
             </a:r>
             <a:endParaRPr lang="en-US" sz="1300" dirty="0"/>
           </a:p>
@@ -15148,7 +15148,7 @@
                 <a:ea typeface="Calibri" pitchFamily="34" charset="-122"/>
                 <a:cs typeface="Calibri" pitchFamily="34" charset="-120"/>
               </a:rPr>
-              <a:t>o administrador do site cuida do funcionamento do portal, sem ver dados pessoais.</a:t>
+              <a:t>o administrador do site cuida do funcionamento do portal, sem ver dados pessoais; a presidente do conselho vê como o conselho.</a:t>
             </a:r>
             <a:endParaRPr lang="en-US" sz="1400" dirty="0"/>
           </a:p>
@@ -15185,7 +15185,7 @@
                 <a:ea typeface="Calibri" pitchFamily="34" charset="-122"/>
                 <a:cs typeface="Calibri" pitchFamily="34" charset="-120"/>
               </a:rPr>
-              <a:t>tem os mesmos poderes do síndico e vê e usa tudo.</a:t>
+              <a:t>o administrador do site tem os poderes do síndico; a presidente do conselho vê tudo.</a:t>
             </a:r>
             <a:endParaRPr lang="en-US" sz="1400" dirty="0"/>
           </a:p>
@@ -17661,7 +17661,7 @@
                           <a:ea typeface="Calibri" pitchFamily="34" charset="-122"/>
                           <a:cs typeface="Calibri" pitchFamily="34" charset="-120"/>
                         </a:rPr>
-                        <a:t>Vê tudo, como o síndico, e responde denúncias; não aprova moradores, não atribui cargos nem configura</a:t>
+                        <a:t>Com o termo assinado: vê tudo e responde denúncias, sem aprovar, atribuir cargos ou configurar. Sem o termo: como o conselho</a:t>
                       </a:r>
                       <a:endParaRPr lang="en-US" sz="1300" dirty="0">
                         <a:latin typeface="Calibri" charset="0"/>

</xml_diff>

<commit_message>
Ajustes de usabilidade do Início e do ecoponto
Início por perfil (blocos reordenáveis por configuração, avisos sempre
primeiro), Hero compacto no DS e ecoponto com mapa do Google Maps
(MapEmbed), incluindo os horários e avisos do ecoponto. O presidente do
conselho deixa de precisar assinar o termo de confidencialidade: passa
a ter a mesma visão do síndico e do subsíndico pelo próprio cargo.

Co-Authored-By: Claude Sonnet 5 <noreply@anthropic.com>
</commit_message>
<xml_diff>
--- a/apresentacoes/Personas-e-perfis-de-acesso.pptx
+++ b/apresentacoes/Personas-e-perfis-de-acesso.pptx
@@ -652,7 +652,7 @@
           <a:p>
             <a:r>
               <a:rPr lang="en-US" dirty="0"/>
-              <a:t>Segundo quadro: as ferramentas de gestão. O síndico e o administrador do site com o termo de confidencialidade assinado têm os mesmos poderes. A presidente do conselho, também com o termo assinado, vê tudo e responde denúncias, mas não aprova moradores, não atribui cargos nem configura. Os demais membros do conselho veem as denúncias só em números e o registro sem identificar as pessoas.</a:t>
+              <a:t>Segundo quadro: as ferramentas de gestão. O síndico e o administrador do site com o termo de confidencialidade assinado têm os mesmos poderes. A presidente do conselho, sem precisar do termo, vê tudo e responde denúncias, mas não aprova moradores, não atribui cargos nem configura. Os demais membros do conselho veem as denúncias só em números e o registro sem identificar as pessoas.</a:t>
             </a:r>
             <a:endParaRPr lang="en-US" dirty="0"/>
           </a:p>
@@ -916,7 +916,7 @@
           <a:p>
             <a:r>
               <a:rPr lang="en-US" dirty="0"/>
-              <a:t>Pontos para o conselho validar. O termo de confidencialidade e o cargo de presidente do conselho já estão no portal; o texto do termo é um modelo e deve passar pelo jurídico.</a:t>
+              <a:t>Pontos para o conselho validar. O termo de confidencialidade (administrador do site e administradora) e o cargo de presidente do conselho (sem termo) já estão no portal; o texto do termo é um modelo e deve passar pelo jurídico.</a:t>
             </a:r>
             <a:endParaRPr lang="en-US" dirty="0"/>
           </a:p>
@@ -1268,7 +1268,7 @@
           <a:p>
             <a:r>
               <a:rPr lang="en-US" dirty="0"/>
-              <a:t>Carlos e Sueli tocam o dia a dia. A Helena preside o conselho e, depois de assinar o termo de confidencialidade, vê tudo para fiscalizar, sem aprovar moradores, atribuir cargos ou configurar. O Otávio, membro do conselho, acompanha números e andamento sem identificar os moradores.</a:t>
+              <a:t>Carlos e Sueli tocam o dia a dia. A Helena preside o conselho e vê tudo, como o síndico e o subsíndico, sem precisar do termo de confidencialidade (decisão de 28/10/2026), para fiscalizar, sem aprovar moradores, atribuir cargos ou configurar. O Otávio, membro do conselho, acompanha números e andamento sem identificar os moradores.</a:t>
             </a:r>
             <a:endParaRPr lang="en-US" dirty="0"/>
           </a:p>
@@ -2975,7 +2975,7 @@
                           <a:ea typeface="Arial" pitchFamily="34" charset="-122"/>
                           <a:cs typeface="Arial" pitchFamily="34" charset="-120"/>
                         </a:rPr>
-                        <a:t>com o termo</a:t>
+                        <a:t>do conselho</a:t>
                       </a:r>
                       <a:endParaRPr lang="en-US" sz="1100" dirty="0">
                         <a:latin typeface="Arial" charset="0"/>
@@ -8493,7 +8493,7 @@
                 <a:ea typeface="Calibri" pitchFamily="34" charset="-122"/>
                 <a:cs typeface="Calibri" pitchFamily="34" charset="-120"/>
               </a:rPr>
-              <a:t>Sem nomes: código no lugar do nome, sem casa, e-mail, motivo ou IP. Se configurado: só se o síndico ligar a opção. Sem o termo assinado, o presidente do conselho vê como os membros do conselho, e o administrador do site só cadastra casas, envia convites e configura o site, sem dados pessoais.</a:t>
+              <a:t>Sem nomes: código no lugar do nome, sem casa, e-mail, motivo ou IP. Se configurado: só se o síndico ligar a opção. O presidente do conselho não assina o termo. Sem o termo assinado, o administrador do site só cadastra casas, envia convites e configura o site, sem dados pessoais.</a:t>
             </a:r>
             <a:endParaRPr lang="en-US" sz="1200" dirty="0"/>
           </a:p>
@@ -8756,7 +8756,7 @@
                 <a:ea typeface="Calibri" pitchFamily="34" charset="-122"/>
                 <a:cs typeface="Calibri" pitchFamily="34" charset="-120"/>
               </a:rPr>
-              <a:t>Denúncias só em números e registro com códigos. A presidência do conselho vê tudo, com o termo.</a:t>
+              <a:t>Denúncias só em números e registro com códigos. A presidência do conselho vê tudo, como o síndico.</a:t>
             </a:r>
             <a:endParaRPr lang="en-US" sz="1400" dirty="0"/>
           </a:p>
@@ -8905,7 +8905,7 @@
                 <a:ea typeface="Calibri" pitchFamily="34" charset="-122"/>
                 <a:cs typeface="Calibri" pitchFamily="34" charset="-120"/>
               </a:rPr>
-              <a:t>Administrador do site e presidente do conselho só veem tudo depois de assinar o termo de confidencialidade.</a:t>
+              <a:t>Administrador do site e administradora só veem os dados depois de assinar o termo de confidencialidade.</a:t>
             </a:r>
             <a:endParaRPr lang="en-US" sz="1400" dirty="0"/>
           </a:p>
@@ -9456,7 +9456,7 @@
                 <a:ea typeface="Calibri" pitchFamily="34" charset="-122"/>
                 <a:cs typeface="Calibri" pitchFamily="34" charset="-120"/>
               </a:rPr>
-              <a:t>As telas são feitas para o morador; a gestão entra sobre essa base.</a:t>
+              <a:t>Telas feitas para o morador; no Início, cada perfil vê primeiro o que mais usa.</a:t>
             </a:r>
             <a:endParaRPr lang="en-US" sz="1400" dirty="0"/>
           </a:p>
@@ -10329,7 +10329,7 @@
                 <a:ea typeface="Calibri" pitchFamily="34" charset="-122"/>
                 <a:cs typeface="Calibri" pitchFamily="34" charset="-120"/>
               </a:rPr>
-              <a:t>Presidente do conselho: assina o termo e vê tudo, sem aprovar moradores, atribuir cargos ou configurar.</a:t>
+              <a:t>Presidente do conselho: vê tudo, sem assinar o termo, e não aprova moradores, atribui cargos nem configura.</a:t>
             </a:r>
             <a:endParaRPr lang="en-US" sz="1800" dirty="0"/>
           </a:p>
@@ -10396,6 +10396,27 @@
             </a:r>
             <a:endParaRPr lang="en-US" sz="1800" dirty="0"/>
           </a:p>
+          <a:p>
+            <a:pPr marL="342900" indent="-342900">
+              <a:spcAft>
+                <a:spcPts val="600"/>
+              </a:spcAft>
+              <a:buSzPct val="100000"/>
+              <a:buChar char="•"/>
+            </a:pPr>
+            <a:r>
+              <a:rPr lang="en-US" sz="1800" dirty="0">
+                <a:solidFill>
+                  <a:srgbClr val="B9CDDC"/>
+                </a:solidFill>
+                <a:latin typeface="Calibri" pitchFamily="34" charset="0"/>
+                <a:ea typeface="Calibri" pitchFamily="34" charset="-122"/>
+                <a:cs typeface="Calibri" pitchFamily="34" charset="-120"/>
+              </a:rPr>
+              <a:t>O que cada perfil vê primeiro no Início (hoje: avisos primeiro para todos).</a:t>
+            </a:r>
+            <a:endParaRPr lang="en-US" sz="1800" dirty="0"/>
+          </a:p>
         </p:txBody>
       </p:sp>
       <p:sp>
@@ -13965,7 +13986,7 @@
                 <a:ea typeface="Calibri" pitchFamily="34" charset="-122"/>
                 <a:cs typeface="Calibri" pitchFamily="34" charset="-120"/>
               </a:rPr>
-              <a:t>“O conselho responde aos moradores. Assinei o termo para ver tudo e fiscalizar de verdade.”</a:t>
+              <a:t>“O conselho responde aos moradores. Preciso ver o que o síndico vê para fiscalizar de verdade.”</a:t>
             </a:r>
             <a:endParaRPr lang="en-US" sz="1400" dirty="0"/>
           </a:p>
@@ -14018,7 +14039,7 @@
                 <a:ea typeface="Calibri" pitchFamily="34" charset="-122"/>
                 <a:cs typeface="Calibri" pitchFamily="34" charset="-120"/>
               </a:rPr>
-              <a:t>Assinar o termo no portal; depois, dados completos e registro fácil de filtrar.</a:t>
+              <a:t>Dados completos, como o síndico, sem termo; registro fácil de filtrar.</a:t>
             </a:r>
             <a:endParaRPr lang="en-US" sz="1300" dirty="0"/>
           </a:p>
@@ -15089,7 +15110,7 @@
                 <a:ea typeface="Arial" pitchFamily="34" charset="-122"/>
                 <a:cs typeface="Arial" pitchFamily="34" charset="-120"/>
               </a:rPr>
-              <a:t>Termo de confidencialidade (decisão de 18/10/2026)</a:t>
+              <a:t>Termo de confidencialidade (decisões de 18/10 e 28/10/2026)</a:t>
             </a:r>
             <a:endParaRPr lang="en-US" sz="1800" dirty="0"/>
           </a:p>
@@ -15148,7 +15169,7 @@
                 <a:ea typeface="Calibri" pitchFamily="34" charset="-122"/>
                 <a:cs typeface="Calibri" pitchFamily="34" charset="-120"/>
               </a:rPr>
-              <a:t>o administrador do site cuida do funcionamento do portal, sem ver dados pessoais; a presidente do conselho vê como o conselho.</a:t>
+              <a:t>o administrador do site cuida do funcionamento do portal, sem ver dados pessoais.</a:t>
             </a:r>
             <a:endParaRPr lang="en-US" sz="1400" dirty="0"/>
           </a:p>
@@ -15185,7 +15206,7 @@
                 <a:ea typeface="Calibri" pitchFamily="34" charset="-122"/>
                 <a:cs typeface="Calibri" pitchFamily="34" charset="-120"/>
               </a:rPr>
-              <a:t>o administrador do site tem os poderes do síndico; a presidente do conselho vê tudo.</a:t>
+              <a:t>o administrador do site tem os poderes do síndico. A presidente do conselho não assina: vê como o síndico.</a:t>
             </a:r>
             <a:endParaRPr lang="en-US" sz="1400" dirty="0"/>
           </a:p>
@@ -17661,7 +17682,7 @@
                           <a:ea typeface="Calibri" pitchFamily="34" charset="-122"/>
                           <a:cs typeface="Calibri" pitchFamily="34" charset="-120"/>
                         </a:rPr>
-                        <a:t>Com o termo assinado: vê tudo e responde denúncias, sem aprovar, atribuir cargos ou configurar. Sem o termo: como o conselho</a:t>
+                        <a:t>Vê tudo e responde denúncias, como o síndico e o subsíndico, sem termo; não aprova, não atribui cargos nem configura</a:t>
                       </a:r>
                       <a:endParaRPr lang="en-US" sz="1300" dirty="0">
                         <a:latin typeface="Calibri" charset="0"/>

</xml_diff>

<commit_message>
Alinha a documentação, o protótipo e a apresentação ao que foi feito
- arquitetura-mvp.md: modelo de dados com as tabelas e campos reais
  (ofertas_servico, adesões, adiamentos, leituras, cálculo da água),
  chaves de configuração certas, backend FastAPI e React+Vite escolhidos,
  fluxos de serviços e água atualizados, Fase 2 com merge, convenções
  de interface (menu da conta, Início do síndico, badges) e o protótipo.
- decisoes-gestao.md: leitura e cálculo da água, serviços com adesão e
  a ordem do Início do síndico.
- para-publicar.md: arquivos a guardar e aviso sobre dados_ficticios.py.
- personas.md: "oferta de serviço" no lugar de "chamada".
- design-system/README.md: menu da conta, gestão das ofertas, exportação
  e blocos do Início.
- Apresentação: slide novo "Serviços e conta de água: quem faz o quê" e
  pontos novos para o conselho confirmar.

Co-Authored-By: Claude Opus 5.5 <noreply@anthropic.com>
Claude-Session: https://claude.ai/code/session_01WMuJZBNVY5w6pDizGVPh75
</commit_message>
<xml_diff>
--- a/apresentacoes/Personas-e-perfis-de-acesso.pptx
+++ b/apresentacoes/Personas-e-perfis-de-acesso.pptx
@@ -15,6 +15,7 @@
     <p:sldId id="263" r:id="rId9"/>
     <p:sldId id="264" r:id="rId10"/>
     <p:sldId id="265" r:id="rId11"/>
+    <p:sldId id="269" r:id="rId20"/>
     <p:sldId id="266" r:id="rId12"/>
     <p:sldId id="267" r:id="rId13"/>
     <p:sldId id="268" r:id="rId14"/>
@@ -9251,7 +9252,7 @@
             <a:pPr algn="r"/>
             <a:fld id="{F7021451-1387-4CA6-816F-3879F97B5CBC}" type="slidenum">
               <a:rPr b="0" lang="en-US"/>
-              <a:t>11</a:t>
+              <a:t>12</a:t>
             </a:fld>
             <a:endParaRPr lang="en-US"/>
           </a:p>
@@ -10199,7 +10200,7 @@
             <a:pPr algn="r"/>
             <a:fld id="{F7021451-1387-4CA6-816F-3879F97B5CBC}" type="slidenum">
               <a:rPr b="0" lang="en-US"/>
-              <a:t>12</a:t>
+              <a:t>13</a:t>
             </a:fld>
             <a:endParaRPr lang="en-US"/>
           </a:p>
@@ -10240,7 +10241,7 @@
         </p:nvSpPr>
         <p:spPr>
           <a:xfrm>
-            <a:off x="548640" y="2011680"/>
+            <a:off x="548640" y="1280160"/>
             <a:ext cx="6583680" cy="1737360"/>
           </a:xfrm>
           <a:prstGeom prst="rect">
@@ -10279,7 +10280,7 @@
         </p:nvSpPr>
         <p:spPr>
           <a:xfrm>
-            <a:off x="548640" y="3931920"/>
+            <a:off x="548640" y="3200400"/>
             <a:ext cx="10789920" cy="2468880"/>
           </a:xfrm>
           <a:prstGeom prst="rect">
@@ -10413,7 +10414,49 @@
                 <a:ea typeface="Calibri" pitchFamily="34" charset="-122"/>
                 <a:cs typeface="Calibri" pitchFamily="34" charset="-120"/>
               </a:rPr>
-              <a:t>O que cada perfil vê primeiro no Início (hoje: avisos primeiro para todos).</a:t>
+              <a:t>O que cada perfil vê primeiro no Início (hoje: avisos primeiro; para o síndico, a gestão no alto).</a:t>
+            </a:r>
+            <a:endParaRPr lang="en-US" sz="1800" dirty="0"/>
+          </a:p>
+          <a:p>
+            <a:pPr marL="342900" indent="-342900">
+              <a:spcAft>
+                <a:spcPts val="600"/>
+              </a:spcAft>
+              <a:buSzPct val="100000"/>
+              <a:buChar char="•"/>
+            </a:pPr>
+            <a:r>
+              <a:rPr lang="en-US" sz="1800" dirty="0">
+                <a:solidFill>
+                  <a:srgbClr val="B9CDDC"/>
+                </a:solidFill>
+                <a:latin typeface="Calibri" pitchFamily="34" charset="0"/>
+                <a:ea typeface="Calibri" pitchFamily="34" charset="-122"/>
+                <a:cs typeface="Calibri" pitchFamily="34" charset="-120"/>
+              </a:rPr>
+              <a:t>Serviços com adesão: só o síndico abre as ofertas; prazo sugerido de 2 dias antes.</a:t>
+            </a:r>
+            <a:endParaRPr lang="en-US" sz="1800" dirty="0"/>
+          </a:p>
+          <a:p>
+            <a:pPr marL="342900" indent="-342900">
+              <a:spcAft>
+                <a:spcPts val="600"/>
+              </a:spcAft>
+              <a:buSzPct val="100000"/>
+              <a:buChar char="•"/>
+            </a:pPr>
+            <a:r>
+              <a:rPr lang="en-US" sz="1800" dirty="0">
+                <a:solidFill>
+                  <a:srgbClr val="B9CDDC"/>
+                </a:solidFill>
+                <a:latin typeface="Calibri" pitchFamily="34" charset="0"/>
+                <a:ea typeface="Calibri" pitchFamily="34" charset="-122"/>
+                <a:cs typeface="Calibri" pitchFamily="34" charset="-120"/>
+              </a:rPr>
+              <a:t>Água: forma de cálculo (valor do m³ ou rateio) e casa sem leitura pela média.</a:t>
             </a:r>
             <a:endParaRPr lang="en-US" sz="1800" dirty="0"/>
           </a:p>
@@ -10429,7 +10472,7 @@
         </p:nvSpPr>
         <p:spPr>
           <a:xfrm>
-            <a:off x="548640" y="3931920"/>
+            <a:off x="548640" y="3200400"/>
             <a:ext cx="6583680" cy="1097280"/>
           </a:xfrm>
           <a:prstGeom prst="rect">
@@ -10446,6 +10489,3131 @@
               <a:buNone/>
             </a:pPr>
             <a:endParaRPr lang="en-US" sz="2000" dirty="0"/>
+          </a:p>
+        </p:txBody>
+      </p:sp>
+    </p:spTree>
+  </p:cSld>
+  <p:clrMapOvr>
+    <a:masterClrMapping/>
+  </p:clrMapOvr>
+</p:sld>
+</file>
+
+<file path=ppt/slides/slide14.xml><?xml version="1.0" encoding="utf-8"?>
+<p:sld xmlns:a="http://schemas.openxmlformats.org/drawingml/2006/main" xmlns:r="http://schemas.openxmlformats.org/officeDocument/2006/relationships" xmlns:p="http://schemas.openxmlformats.org/presentationml/2006/main">
+  <p:cSld name="Slide 10">
+    <p:spTree>
+      <p:nvGrpSpPr>
+        <p:cNvPr id="1" name=""/>
+        <p:cNvGrpSpPr/>
+        <p:nvPr/>
+      </p:nvGrpSpPr>
+      <p:grpSpPr>
+        <a:xfrm>
+          <a:off x="0" y="0"/>
+          <a:ext cx="0" cy="0"/>
+          <a:chOff x="0" y="0"/>
+          <a:chExt cx="0" cy="0"/>
+        </a:xfrm>
+      </p:grpSpPr>
+      <p:sp>
+        <p:nvSpPr>
+          <p:cNvPr id="2" name="Text 0"/>
+          <p:cNvSpPr/>
+          <p:nvPr>
+            <p:ph idx="100" type="title" hasCustomPrompt="1"/>
+          </p:nvPr>
+        </p:nvSpPr>
+        <p:spPr>
+          <a:xfrm>
+            <a:off x="548640" y="365760"/>
+            <a:ext cx="11094415" cy="731520"/>
+          </a:xfrm>
+          <a:prstGeom prst="rect">
+            <a:avLst/>
+          </a:prstGeom>
+          <a:noFill/>
+          <a:ln/>
+        </p:spPr>
+        <p:txBody>
+          <a:bodyPr wrap="square" lIns="0" tIns="0" rIns="0" bIns="0" rtlCol="0" anchor="ctr"/>
+          <a:lstStyle/>
+          <a:p>
+            <a:pPr algn="l" indent="0" marL="0">
+              <a:buNone/>
+            </a:pPr>
+            <a:r>
+              <a:rPr lang="en-US" sz="3200" b="1" dirty="0">
+                <a:solidFill>
+                  <a:srgbClr val="2B1E1C"/>
+                </a:solidFill>
+                <a:latin typeface="Arial" pitchFamily="34" charset="0"/>
+                <a:ea typeface="Arial" pitchFamily="34" charset="-122"/>
+                <a:cs typeface="Arial" pitchFamily="34" charset="-120"/>
+              </a:rPr>
+              <a:t>Serviços e conta de água: quem faz o quê</a:t>
+            </a:r>
+            <a:endParaRPr lang="en-US" sz="3200" dirty="0"/>
+          </a:p>
+        </p:txBody>
+      </p:sp>
+      <p:graphicFrame>
+        <p:nvGraphicFramePr>
+          <p:cNvPr id="11" name="Table 0"/>
+          <p:cNvGraphicFramePr>
+            <a:graphicFrameLocks noGrp="1"/>
+          </p:cNvGraphicFramePr>
+          <p:nvPr>
+            <p:extLst>
+              <p:ext uri="{D42A27DB-BD31-4B8C-83A1-F6EECF244321}">
+                <p14:modId xmlns:p14="http://schemas.microsoft.com/office/powerpoint/2010/main" val="1579011935"/>
+              </p:ext>
+            </p:extLst>
+          </p:nvPr>
+        </p:nvGraphicFramePr>
+        <p:xfrm>
+          <a:off x="548640" y="1234440"/>
+          <a:ext cx="11094415" cy="914400"/>
+        </p:xfrm>
+        <a:graphic>
+          <a:graphicData uri="http://schemas.openxmlformats.org/drawingml/2006/table">
+            <a:tbl>
+              <a:tblPr/>
+              <a:tblGrid>
+                <a:gridCol w="3520440"/>
+                <a:gridCol w="1188720"/>
+                <a:gridCol w="1188720"/>
+                <a:gridCol w="1280160"/>
+                <a:gridCol w="1280160"/>
+                <a:gridCol w="1188720"/>
+                <a:gridCol w="1444752"/>
+              </a:tblGrid>
+              <a:tr h="502920">
+                <a:tc>
+                  <a:txBody>
+                    <a:bodyPr/>
+                    <a:lstStyle/>
+                    <a:p>
+                      <a:pPr indent="0" marL="0">
+                        <a:buNone/>
+                      </a:pPr>
+                      <a:r>
+                        <a:rPr lang="en-US" sz="1200" b="1" dirty="0">
+                          <a:solidFill>
+                            <a:srgbClr val="FFFFFF"/>
+                          </a:solidFill>
+                          <a:latin typeface="Arial" pitchFamily="34" charset="0"/>
+                          <a:ea typeface="Arial" pitchFamily="34" charset="-122"/>
+                          <a:cs typeface="Arial" pitchFamily="34" charset="-120"/>
+                        </a:rPr>
+                        <a:t>Serviços e conta de água</a:t>
+                      </a:r>
+                      <a:endParaRPr lang="en-US" sz="1200" dirty="0">
+                        <a:latin typeface="Arial" charset="0"/>
+                        <a:ea typeface="Arial" charset="0"/>
+                        <a:cs typeface="Arial" charset="0"/>
+                      </a:endParaRPr>
+                    </a:p>
+                  </a:txBody>
+                  <a:tcPr marL="73152" marR="73152" marT="18288" marB="18288" anchor="ctr">
+                    <a:lnL w="6350" cap="flat" cmpd="sng" algn="ctr">
+                      <a:solidFill>
+                        <a:srgbClr val="EBE7E3"/>
+                      </a:solidFill>
+                      <a:prstDash val="solid"/>
+                      <a:round/>
+                      <a:headEnd type="none" w="med" len="med"/>
+                      <a:tailEnd type="none" w="med" len="med"/>
+                    </a:lnL>
+                    <a:lnR w="6350" cap="flat" cmpd="sng" algn="ctr">
+                      <a:solidFill>
+                        <a:srgbClr val="EBE7E3"/>
+                      </a:solidFill>
+                      <a:prstDash val="solid"/>
+                      <a:round/>
+                      <a:headEnd type="none" w="med" len="med"/>
+                      <a:tailEnd type="none" w="med" len="med"/>
+                    </a:lnR>
+                    <a:lnT w="6350" cap="flat" cmpd="sng" algn="ctr">
+                      <a:solidFill>
+                        <a:srgbClr val="EBE7E3"/>
+                      </a:solidFill>
+                      <a:prstDash val="solid"/>
+                      <a:round/>
+                      <a:headEnd type="none" w="med" len="med"/>
+                      <a:tailEnd type="none" w="med" len="med"/>
+                    </a:lnT>
+                    <a:lnB w="6350" cap="flat" cmpd="sng" algn="ctr">
+                      <a:solidFill>
+                        <a:srgbClr val="EBE7E3"/>
+                      </a:solidFill>
+                      <a:prstDash val="solid"/>
+                      <a:round/>
+                      <a:headEnd type="none" w="med" len="med"/>
+                      <a:tailEnd type="none" w="med" len="med"/>
+                    </a:lnB>
+                    <a:solidFill>
+                      <a:srgbClr val="264B65"/>
+                    </a:solidFill>
+                  </a:tcPr>
+                </a:tc>
+                <a:tc>
+                  <a:txBody>
+                    <a:bodyPr/>
+                    <a:lstStyle/>
+                    <a:p>
+                      <a:pPr algn="ctr" indent="0" marL="0">
+                        <a:buNone/>
+                      </a:pPr>
+                      <a:r>
+                        <a:rPr lang="en-US" sz="1100" b="1" dirty="0">
+                          <a:solidFill>
+                            <a:srgbClr val="FFFFFF"/>
+                          </a:solidFill>
+                          <a:latin typeface="Arial" pitchFamily="34" charset="0"/>
+                          <a:ea typeface="Arial" pitchFamily="34" charset="-122"/>
+                          <a:cs typeface="Arial" pitchFamily="34" charset="-120"/>
+                        </a:rPr>
+                        <a:t>Síndico</a:t>
+                      </a:r>
+                      <a:endParaRPr lang="en-US" sz="1100" dirty="0">
+                        <a:latin typeface="Arial" charset="0"/>
+                        <a:ea typeface="Arial" charset="0"/>
+                        <a:cs typeface="Arial" charset="0"/>
+                      </a:endParaRPr>
+                    </a:p>
+                  </a:txBody>
+                  <a:tcPr marL="73152" marR="73152" marT="18288" marB="18288" anchor="ctr">
+                    <a:lnL w="6350" cap="flat" cmpd="sng" algn="ctr">
+                      <a:solidFill>
+                        <a:srgbClr val="EBE7E3"/>
+                      </a:solidFill>
+                      <a:prstDash val="solid"/>
+                      <a:round/>
+                      <a:headEnd type="none" w="med" len="med"/>
+                      <a:tailEnd type="none" w="med" len="med"/>
+                    </a:lnL>
+                    <a:lnR w="6350" cap="flat" cmpd="sng" algn="ctr">
+                      <a:solidFill>
+                        <a:srgbClr val="EBE7E3"/>
+                      </a:solidFill>
+                      <a:prstDash val="solid"/>
+                      <a:round/>
+                      <a:headEnd type="none" w="med" len="med"/>
+                      <a:tailEnd type="none" w="med" len="med"/>
+                    </a:lnR>
+                    <a:lnT w="6350" cap="flat" cmpd="sng" algn="ctr">
+                      <a:solidFill>
+                        <a:srgbClr val="EBE7E3"/>
+                      </a:solidFill>
+                      <a:prstDash val="solid"/>
+                      <a:round/>
+                      <a:headEnd type="none" w="med" len="med"/>
+                      <a:tailEnd type="none" w="med" len="med"/>
+                    </a:lnT>
+                    <a:lnB w="6350" cap="flat" cmpd="sng" algn="ctr">
+                      <a:solidFill>
+                        <a:srgbClr val="EBE7E3"/>
+                      </a:solidFill>
+                      <a:prstDash val="solid"/>
+                      <a:round/>
+                      <a:headEnd type="none" w="med" len="med"/>
+                      <a:tailEnd type="none" w="med" len="med"/>
+                    </a:lnB>
+                    <a:solidFill>
+                      <a:srgbClr val="264B65"/>
+                    </a:solidFill>
+                  </a:tcPr>
+                </a:tc>
+                <a:tc>
+                  <a:txBody>
+                    <a:bodyPr/>
+                    <a:lstStyle/>
+                    <a:p>
+                      <a:pPr algn="ctr" indent="0" marL="0">
+                        <a:buNone/>
+                      </a:pPr>
+                      <a:r>
+                        <a:rPr lang="en-US" sz="1100" b="1" dirty="0">
+                          <a:solidFill>
+                            <a:srgbClr val="FFFFFF"/>
+                          </a:solidFill>
+                          <a:latin typeface="Arial" pitchFamily="34" charset="0"/>
+                          <a:ea typeface="Arial" pitchFamily="34" charset="-122"/>
+                          <a:cs typeface="Arial" pitchFamily="34" charset="-120"/>
+                        </a:rPr>
+                        <a:t>Subsíndico</a:t>
+                      </a:r>
+                      <a:endParaRPr lang="en-US" sz="1100" dirty="0">
+                        <a:latin typeface="Arial" charset="0"/>
+                        <a:ea typeface="Arial" charset="0"/>
+                        <a:cs typeface="Arial" charset="0"/>
+                      </a:endParaRPr>
+                    </a:p>
+                  </a:txBody>
+                  <a:tcPr marL="73152" marR="73152" marT="18288" marB="18288" anchor="ctr">
+                    <a:lnL w="6350" cap="flat" cmpd="sng" algn="ctr">
+                      <a:solidFill>
+                        <a:srgbClr val="EBE7E3"/>
+                      </a:solidFill>
+                      <a:prstDash val="solid"/>
+                      <a:round/>
+                      <a:headEnd type="none" w="med" len="med"/>
+                      <a:tailEnd type="none" w="med" len="med"/>
+                    </a:lnL>
+                    <a:lnR w="6350" cap="flat" cmpd="sng" algn="ctr">
+                      <a:solidFill>
+                        <a:srgbClr val="EBE7E3"/>
+                      </a:solidFill>
+                      <a:prstDash val="solid"/>
+                      <a:round/>
+                      <a:headEnd type="none" w="med" len="med"/>
+                      <a:tailEnd type="none" w="med" len="med"/>
+                    </a:lnR>
+                    <a:lnT w="6350" cap="flat" cmpd="sng" algn="ctr">
+                      <a:solidFill>
+                        <a:srgbClr val="EBE7E3"/>
+                      </a:solidFill>
+                      <a:prstDash val="solid"/>
+                      <a:round/>
+                      <a:headEnd type="none" w="med" len="med"/>
+                      <a:tailEnd type="none" w="med" len="med"/>
+                    </a:lnT>
+                    <a:lnB w="6350" cap="flat" cmpd="sng" algn="ctr">
+                      <a:solidFill>
+                        <a:srgbClr val="EBE7E3"/>
+                      </a:solidFill>
+                      <a:prstDash val="solid"/>
+                      <a:round/>
+                      <a:headEnd type="none" w="med" len="med"/>
+                      <a:tailEnd type="none" w="med" len="med"/>
+                    </a:lnB>
+                    <a:solidFill>
+                      <a:srgbClr val="264B65"/>
+                    </a:solidFill>
+                  </a:tcPr>
+                </a:tc>
+                <a:tc>
+                  <a:txBody>
+                    <a:bodyPr/>
+                    <a:lstStyle/>
+                    <a:p>
+                      <a:pPr algn="ctr" indent="0" marL="0">
+                        <a:buNone/>
+                      </a:pPr>
+                      <a:r>
+                        <a:rPr lang="en-US" sz="1100" b="1" dirty="0">
+                          <a:solidFill>
+                            <a:srgbClr val="FFFFFF"/>
+                          </a:solidFill>
+                          <a:latin typeface="Arial" pitchFamily="34" charset="0"/>
+                          <a:ea typeface="Arial" pitchFamily="34" charset="-122"/>
+                          <a:cs typeface="Arial" pitchFamily="34" charset="-120"/>
+                        </a:rPr>
+                        <a:t>Presidente</a:t>
+                      </a:r>
+                      <a:endParaRPr lang="en-US" sz="1100" dirty="0">
+                        <a:latin typeface="Arial" charset="0"/>
+                        <a:ea typeface="Arial" charset="0"/>
+                        <a:cs typeface="Arial" charset="0"/>
+                      </a:endParaRPr>
+                    </a:p>
+                    <a:p>
+                      <a:pPr algn="ctr" indent="0" marL="0">
+                        <a:buNone/>
+                      </a:pPr>
+                      <a:r>
+                        <a:rPr lang="en-US" sz="1100" b="1" dirty="0">
+                          <a:solidFill>
+                            <a:srgbClr val="FFFFFF"/>
+                          </a:solidFill>
+                          <a:latin typeface="Arial" pitchFamily="34" charset="0"/>
+                          <a:ea typeface="Arial" pitchFamily="34" charset="-122"/>
+                          <a:cs typeface="Arial" pitchFamily="34" charset="-120"/>
+                        </a:rPr>
+                        <a:t>do conselho</a:t>
+                      </a:r>
+                      <a:endParaRPr lang="en-US" sz="1100" dirty="0">
+                        <a:latin typeface="Arial" charset="0"/>
+                        <a:ea typeface="Arial" charset="0"/>
+                        <a:cs typeface="Arial" charset="0"/>
+                      </a:endParaRPr>
+                    </a:p>
+                  </a:txBody>
+                  <a:tcPr marL="73152" marR="73152" marT="18288" marB="18288" anchor="ctr">
+                    <a:lnL w="6350" cap="flat" cmpd="sng" algn="ctr">
+                      <a:solidFill>
+                        <a:srgbClr val="EBE7E3"/>
+                      </a:solidFill>
+                      <a:prstDash val="solid"/>
+                      <a:round/>
+                      <a:headEnd type="none" w="med" len="med"/>
+                      <a:tailEnd type="none" w="med" len="med"/>
+                    </a:lnL>
+                    <a:lnR w="6350" cap="flat" cmpd="sng" algn="ctr">
+                      <a:solidFill>
+                        <a:srgbClr val="EBE7E3"/>
+                      </a:solidFill>
+                      <a:prstDash val="solid"/>
+                      <a:round/>
+                      <a:headEnd type="none" w="med" len="med"/>
+                      <a:tailEnd type="none" w="med" len="med"/>
+                    </a:lnR>
+                    <a:lnT w="6350" cap="flat" cmpd="sng" algn="ctr">
+                      <a:solidFill>
+                        <a:srgbClr val="EBE7E3"/>
+                      </a:solidFill>
+                      <a:prstDash val="solid"/>
+                      <a:round/>
+                      <a:headEnd type="none" w="med" len="med"/>
+                      <a:tailEnd type="none" w="med" len="med"/>
+                    </a:lnT>
+                    <a:lnB w="6350" cap="flat" cmpd="sng" algn="ctr">
+                      <a:solidFill>
+                        <a:srgbClr val="EBE7E3"/>
+                      </a:solidFill>
+                      <a:prstDash val="solid"/>
+                      <a:round/>
+                      <a:headEnd type="none" w="med" len="med"/>
+                      <a:tailEnd type="none" w="med" len="med"/>
+                    </a:lnB>
+                    <a:solidFill>
+                      <a:srgbClr val="264B65"/>
+                    </a:solidFill>
+                  </a:tcPr>
+                </a:tc>
+                <a:tc>
+                  <a:txBody>
+                    <a:bodyPr/>
+                    <a:lstStyle/>
+                    <a:p>
+                      <a:pPr algn="ctr" indent="0" marL="0">
+                        <a:buNone/>
+                      </a:pPr>
+                      <a:r>
+                        <a:rPr lang="en-US" sz="1100" b="1" dirty="0">
+                          <a:solidFill>
+                            <a:srgbClr val="FFFFFF"/>
+                          </a:solidFill>
+                          <a:latin typeface="Arial" pitchFamily="34" charset="0"/>
+                          <a:ea typeface="Arial" pitchFamily="34" charset="-122"/>
+                          <a:cs typeface="Arial" pitchFamily="34" charset="-120"/>
+                        </a:rPr>
+                        <a:t>Membros do</a:t>
+                      </a:r>
+                      <a:endParaRPr lang="en-US" sz="1100" dirty="0">
+                        <a:latin typeface="Arial" charset="0"/>
+                        <a:ea typeface="Arial" charset="0"/>
+                        <a:cs typeface="Arial" charset="0"/>
+                      </a:endParaRPr>
+                    </a:p>
+                    <a:p>
+                      <a:pPr algn="ctr" indent="0" marL="0">
+                        <a:buNone/>
+                      </a:pPr>
+                      <a:r>
+                        <a:rPr lang="en-US" sz="1100" b="1" dirty="0">
+                          <a:solidFill>
+                            <a:srgbClr val="FFFFFF"/>
+                          </a:solidFill>
+                          <a:latin typeface="Arial" pitchFamily="34" charset="0"/>
+                          <a:ea typeface="Arial" pitchFamily="34" charset="-122"/>
+                          <a:cs typeface="Arial" pitchFamily="34" charset="-120"/>
+                        </a:rPr>
+                        <a:t>conselho</a:t>
+                      </a:r>
+                      <a:endParaRPr lang="en-US" sz="1100" dirty="0">
+                        <a:latin typeface="Arial" charset="0"/>
+                        <a:ea typeface="Arial" charset="0"/>
+                        <a:cs typeface="Arial" charset="0"/>
+                      </a:endParaRPr>
+                    </a:p>
+                  </a:txBody>
+                  <a:tcPr marL="73152" marR="73152" marT="18288" marB="18288" anchor="ctr">
+                    <a:lnL w="6350" cap="flat" cmpd="sng" algn="ctr">
+                      <a:solidFill>
+                        <a:srgbClr val="EBE7E3"/>
+                      </a:solidFill>
+                      <a:prstDash val="solid"/>
+                      <a:round/>
+                      <a:headEnd type="none" w="med" len="med"/>
+                      <a:tailEnd type="none" w="med" len="med"/>
+                    </a:lnL>
+                    <a:lnR w="6350" cap="flat" cmpd="sng" algn="ctr">
+                      <a:solidFill>
+                        <a:srgbClr val="EBE7E3"/>
+                      </a:solidFill>
+                      <a:prstDash val="solid"/>
+                      <a:round/>
+                      <a:headEnd type="none" w="med" len="med"/>
+                      <a:tailEnd type="none" w="med" len="med"/>
+                    </a:lnR>
+                    <a:lnT w="6350" cap="flat" cmpd="sng" algn="ctr">
+                      <a:solidFill>
+                        <a:srgbClr val="EBE7E3"/>
+                      </a:solidFill>
+                      <a:prstDash val="solid"/>
+                      <a:round/>
+                      <a:headEnd type="none" w="med" len="med"/>
+                      <a:tailEnd type="none" w="med" len="med"/>
+                    </a:lnT>
+                    <a:lnB w="6350" cap="flat" cmpd="sng" algn="ctr">
+                      <a:solidFill>
+                        <a:srgbClr val="EBE7E3"/>
+                      </a:solidFill>
+                      <a:prstDash val="solid"/>
+                      <a:round/>
+                      <a:headEnd type="none" w="med" len="med"/>
+                      <a:tailEnd type="none" w="med" len="med"/>
+                    </a:lnB>
+                    <a:solidFill>
+                      <a:srgbClr val="264B65"/>
+                    </a:solidFill>
+                  </a:tcPr>
+                </a:tc>
+                <a:tc>
+                  <a:txBody>
+                    <a:bodyPr/>
+                    <a:lstStyle/>
+                    <a:p>
+                      <a:pPr algn="ctr" indent="0" marL="0">
+                        <a:buNone/>
+                      </a:pPr>
+                      <a:r>
+                        <a:rPr lang="en-US" sz="1100" b="1" dirty="0">
+                          <a:solidFill>
+                            <a:srgbClr val="FFFFFF"/>
+                          </a:solidFill>
+                          <a:latin typeface="Arial" pitchFamily="34" charset="0"/>
+                          <a:ea typeface="Arial" pitchFamily="34" charset="-122"/>
+                          <a:cs typeface="Arial" pitchFamily="34" charset="-120"/>
+                        </a:rPr>
+                        <a:t>Adminis-</a:t>
+                      </a:r>
+                      <a:endParaRPr lang="en-US" sz="1100" dirty="0">
+                        <a:latin typeface="Arial" charset="0"/>
+                        <a:ea typeface="Arial" charset="0"/>
+                        <a:cs typeface="Arial" charset="0"/>
+                      </a:endParaRPr>
+                    </a:p>
+                    <a:p>
+                      <a:pPr algn="ctr" indent="0" marL="0">
+                        <a:buNone/>
+                      </a:pPr>
+                      <a:r>
+                        <a:rPr lang="en-US" sz="1100" b="1" dirty="0">
+                          <a:solidFill>
+                            <a:srgbClr val="FFFFFF"/>
+                          </a:solidFill>
+                          <a:latin typeface="Arial" pitchFamily="34" charset="0"/>
+                          <a:ea typeface="Arial" pitchFamily="34" charset="-122"/>
+                          <a:cs typeface="Arial" pitchFamily="34" charset="-120"/>
+                        </a:rPr>
+                        <a:t>tradora</a:t>
+                      </a:r>
+                      <a:endParaRPr lang="en-US" sz="1100" dirty="0">
+                        <a:latin typeface="Arial" charset="0"/>
+                        <a:ea typeface="Arial" charset="0"/>
+                        <a:cs typeface="Arial" charset="0"/>
+                      </a:endParaRPr>
+                    </a:p>
+                  </a:txBody>
+                  <a:tcPr marL="73152" marR="73152" marT="18288" marB="18288" anchor="ctr">
+                    <a:lnL w="6350" cap="flat" cmpd="sng" algn="ctr">
+                      <a:solidFill>
+                        <a:srgbClr val="EBE7E3"/>
+                      </a:solidFill>
+                      <a:prstDash val="solid"/>
+                      <a:round/>
+                      <a:headEnd type="none" w="med" len="med"/>
+                      <a:tailEnd type="none" w="med" len="med"/>
+                    </a:lnL>
+                    <a:lnR w="6350" cap="flat" cmpd="sng" algn="ctr">
+                      <a:solidFill>
+                        <a:srgbClr val="EBE7E3"/>
+                      </a:solidFill>
+                      <a:prstDash val="solid"/>
+                      <a:round/>
+                      <a:headEnd type="none" w="med" len="med"/>
+                      <a:tailEnd type="none" w="med" len="med"/>
+                    </a:lnR>
+                    <a:lnT w="6350" cap="flat" cmpd="sng" algn="ctr">
+                      <a:solidFill>
+                        <a:srgbClr val="EBE7E3"/>
+                      </a:solidFill>
+                      <a:prstDash val="solid"/>
+                      <a:round/>
+                      <a:headEnd type="none" w="med" len="med"/>
+                      <a:tailEnd type="none" w="med" len="med"/>
+                    </a:lnT>
+                    <a:lnB w="6350" cap="flat" cmpd="sng" algn="ctr">
+                      <a:solidFill>
+                        <a:srgbClr val="EBE7E3"/>
+                      </a:solidFill>
+                      <a:prstDash val="solid"/>
+                      <a:round/>
+                      <a:headEnd type="none" w="med" len="med"/>
+                      <a:tailEnd type="none" w="med" len="med"/>
+                    </a:lnB>
+                    <a:solidFill>
+                      <a:srgbClr val="264B65"/>
+                    </a:solidFill>
+                  </a:tcPr>
+                </a:tc>
+                <a:tc>
+                  <a:txBody>
+                    <a:bodyPr/>
+                    <a:lstStyle/>
+                    <a:p>
+                      <a:pPr algn="ctr" indent="0" marL="0">
+                        <a:buNone/>
+                      </a:pPr>
+                      <a:r>
+                        <a:rPr lang="en-US" sz="1100" b="1" dirty="0">
+                          <a:solidFill>
+                            <a:srgbClr val="FFFFFF"/>
+                          </a:solidFill>
+                          <a:latin typeface="Arial" pitchFamily="34" charset="0"/>
+                          <a:ea typeface="Arial" pitchFamily="34" charset="-122"/>
+                          <a:cs typeface="Arial" pitchFamily="34" charset="-120"/>
+                        </a:rPr>
+                        <a:t>Admin. do site</a:t>
+                      </a:r>
+                      <a:endParaRPr lang="en-US" sz="1100" dirty="0">
+                        <a:latin typeface="Arial" charset="0"/>
+                        <a:ea typeface="Arial" charset="0"/>
+                        <a:cs typeface="Arial" charset="0"/>
+                      </a:endParaRPr>
+                    </a:p>
+                    <a:p>
+                      <a:pPr algn="ctr" indent="0" marL="0">
+                        <a:buNone/>
+                      </a:pPr>
+                      <a:r>
+                        <a:rPr lang="en-US" sz="1100" b="1" dirty="0">
+                          <a:solidFill>
+                            <a:srgbClr val="FFFFFF"/>
+                          </a:solidFill>
+                          <a:latin typeface="Arial" pitchFamily="34" charset="0"/>
+                          <a:ea typeface="Arial" pitchFamily="34" charset="-122"/>
+                          <a:cs typeface="Arial" pitchFamily="34" charset="-120"/>
+                        </a:rPr>
+                        <a:t>com o termo</a:t>
+                      </a:r>
+                      <a:endParaRPr lang="en-US" sz="1100" dirty="0">
+                        <a:latin typeface="Arial" charset="0"/>
+                        <a:ea typeface="Arial" charset="0"/>
+                        <a:cs typeface="Arial" charset="0"/>
+                      </a:endParaRPr>
+                    </a:p>
+                  </a:txBody>
+                  <a:tcPr marL="73152" marR="73152" marT="18288" marB="18288" anchor="ctr">
+                    <a:lnL w="6350" cap="flat" cmpd="sng" algn="ctr">
+                      <a:solidFill>
+                        <a:srgbClr val="EBE7E3"/>
+                      </a:solidFill>
+                      <a:prstDash val="solid"/>
+                      <a:round/>
+                      <a:headEnd type="none" w="med" len="med"/>
+                      <a:tailEnd type="none" w="med" len="med"/>
+                    </a:lnL>
+                    <a:lnR w="6350" cap="flat" cmpd="sng" algn="ctr">
+                      <a:solidFill>
+                        <a:srgbClr val="EBE7E3"/>
+                      </a:solidFill>
+                      <a:prstDash val="solid"/>
+                      <a:round/>
+                      <a:headEnd type="none" w="med" len="med"/>
+                      <a:tailEnd type="none" w="med" len="med"/>
+                    </a:lnR>
+                    <a:lnT w="6350" cap="flat" cmpd="sng" algn="ctr">
+                      <a:solidFill>
+                        <a:srgbClr val="EBE7E3"/>
+                      </a:solidFill>
+                      <a:prstDash val="solid"/>
+                      <a:round/>
+                      <a:headEnd type="none" w="med" len="med"/>
+                      <a:tailEnd type="none" w="med" len="med"/>
+                    </a:lnT>
+                    <a:lnB w="6350" cap="flat" cmpd="sng" algn="ctr">
+                      <a:solidFill>
+                        <a:srgbClr val="EBE7E3"/>
+                      </a:solidFill>
+                      <a:prstDash val="solid"/>
+                      <a:round/>
+                      <a:headEnd type="none" w="med" len="med"/>
+                      <a:tailEnd type="none" w="med" len="med"/>
+                    </a:lnB>
+                    <a:solidFill>
+                      <a:srgbClr val="264B65"/>
+                    </a:solidFill>
+                  </a:tcPr>
+                </a:tc>
+              </a:tr>
+              <a:tr h="347472">
+                <a:tc>
+                  <a:txBody>
+                    <a:bodyPr/>
+                    <a:lstStyle/>
+                    <a:p>
+                      <a:pPr indent="0" marL="0">
+                        <a:buNone/>
+                      </a:pPr>
+                      <a:r>
+                        <a:rPr lang="en-US" sz="1200" dirty="0">
+                          <a:solidFill>
+                            <a:srgbClr val="2B1E1C"/>
+                          </a:solidFill>
+                          <a:latin typeface="Calibri" pitchFamily="34" charset="0"/>
+                          <a:ea typeface="Calibri" pitchFamily="34" charset="-122"/>
+                          <a:cs typeface="Calibri" pitchFamily="34" charset="-120"/>
+                        </a:rPr>
+                        <a:t>Abrir, editar, adiar e cancelar ofertas de serviço</a:t>
+                      </a:r>
+                      <a:endParaRPr lang="en-US" sz="1200" dirty="0">
+                        <a:latin typeface="Calibri" charset="0"/>
+                        <a:ea typeface="Calibri" charset="0"/>
+                        <a:cs typeface="Calibri" charset="0"/>
+                      </a:endParaRPr>
+                    </a:p>
+                  </a:txBody>
+                  <a:tcPr marL="73152" marR="73152" marT="18288" marB="18288" anchor="ctr">
+                    <a:lnL w="6350" cap="flat" cmpd="sng" algn="ctr">
+                      <a:solidFill>
+                        <a:srgbClr val="EBE7E3"/>
+                      </a:solidFill>
+                      <a:prstDash val="solid"/>
+                      <a:round/>
+                      <a:headEnd type="none" w="med" len="med"/>
+                      <a:tailEnd type="none" w="med" len="med"/>
+                    </a:lnL>
+                    <a:lnR w="6350" cap="flat" cmpd="sng" algn="ctr">
+                      <a:solidFill>
+                        <a:srgbClr val="EBE7E3"/>
+                      </a:solidFill>
+                      <a:prstDash val="solid"/>
+                      <a:round/>
+                      <a:headEnd type="none" w="med" len="med"/>
+                      <a:tailEnd type="none" w="med" len="med"/>
+                    </a:lnR>
+                    <a:lnT w="6350" cap="flat" cmpd="sng" algn="ctr">
+                      <a:solidFill>
+                        <a:srgbClr val="EBE7E3"/>
+                      </a:solidFill>
+                      <a:prstDash val="solid"/>
+                      <a:round/>
+                      <a:headEnd type="none" w="med" len="med"/>
+                      <a:tailEnd type="none" w="med" len="med"/>
+                    </a:lnT>
+                    <a:lnB w="6350" cap="flat" cmpd="sng" algn="ctr">
+                      <a:solidFill>
+                        <a:srgbClr val="EBE7E3"/>
+                      </a:solidFill>
+                      <a:prstDash val="solid"/>
+                      <a:round/>
+                      <a:headEnd type="none" w="med" len="med"/>
+                      <a:tailEnd type="none" w="med" len="med"/>
+                    </a:lnB>
+                  </a:tcPr>
+                </a:tc>
+                <a:tc>
+                  <a:txBody>
+                    <a:bodyPr/>
+                    <a:lstStyle/>
+                    <a:p>
+                      <a:pPr algn="ctr" indent="0" marL="0">
+                        <a:buNone/>
+                      </a:pPr>
+                      <a:r>
+                        <a:rPr lang="en-US" sz="1100" b="1" dirty="0">
+                          <a:solidFill>
+                            <a:srgbClr val="545814"/>
+                          </a:solidFill>
+                          <a:latin typeface="Calibri" pitchFamily="34" charset="0"/>
+                          <a:ea typeface="Calibri" pitchFamily="34" charset="-122"/>
+                          <a:cs typeface="Calibri" pitchFamily="34" charset="-120"/>
+                        </a:rPr>
+                        <a:t>✓ Sim</a:t>
+                      </a:r>
+                      <a:endParaRPr lang="en-US" sz="1100" dirty="0">
+                        <a:latin typeface="Calibri" charset="0"/>
+                        <a:ea typeface="Calibri" charset="0"/>
+                        <a:cs typeface="Calibri" charset="0"/>
+                      </a:endParaRPr>
+                    </a:p>
+                  </a:txBody>
+                  <a:tcPr marL="73152" marR="73152" marT="18288" marB="18288" anchor="ctr">
+                    <a:lnL w="6350" cap="flat" cmpd="sng" algn="ctr">
+                      <a:solidFill>
+                        <a:srgbClr val="EBE7E3"/>
+                      </a:solidFill>
+                      <a:prstDash val="solid"/>
+                      <a:round/>
+                      <a:headEnd type="none" w="med" len="med"/>
+                      <a:tailEnd type="none" w="med" len="med"/>
+                    </a:lnL>
+                    <a:lnR w="6350" cap="flat" cmpd="sng" algn="ctr">
+                      <a:solidFill>
+                        <a:srgbClr val="EBE7E3"/>
+                      </a:solidFill>
+                      <a:prstDash val="solid"/>
+                      <a:round/>
+                      <a:headEnd type="none" w="med" len="med"/>
+                      <a:tailEnd type="none" w="med" len="med"/>
+                    </a:lnR>
+                    <a:lnT w="6350" cap="flat" cmpd="sng" algn="ctr">
+                      <a:solidFill>
+                        <a:srgbClr val="EBE7E3"/>
+                      </a:solidFill>
+                      <a:prstDash val="solid"/>
+                      <a:round/>
+                      <a:headEnd type="none" w="med" len="med"/>
+                      <a:tailEnd type="none" w="med" len="med"/>
+                    </a:lnT>
+                    <a:lnB w="6350" cap="flat" cmpd="sng" algn="ctr">
+                      <a:solidFill>
+                        <a:srgbClr val="EBE7E3"/>
+                      </a:solidFill>
+                      <a:prstDash val="solid"/>
+                      <a:round/>
+                      <a:headEnd type="none" w="med" len="med"/>
+                      <a:tailEnd type="none" w="med" len="med"/>
+                    </a:lnB>
+                    <a:solidFill>
+                      <a:srgbClr val="E4E6C3"/>
+                    </a:solidFill>
+                  </a:tcPr>
+                </a:tc>
+                <a:tc>
+                  <a:txBody>
+                    <a:bodyPr/>
+                    <a:lstStyle/>
+                    <a:p>
+                      <a:pPr algn="ctr" indent="0" marL="0">
+                        <a:buNone/>
+                      </a:pPr>
+                      <a:r>
+                        <a:rPr lang="en-US" sz="1100" b="1" dirty="0">
+                          <a:solidFill>
+                            <a:srgbClr val="6B4E00"/>
+                          </a:solidFill>
+                          <a:latin typeface="Calibri" pitchFamily="34" charset="0"/>
+                          <a:ea typeface="Calibri" pitchFamily="34" charset="-122"/>
+                          <a:cs typeface="Calibri" pitchFamily="34" charset="-120"/>
+                        </a:rPr>
+                        <a:t>◐ Se configurado</a:t>
+                      </a:r>
+                      <a:endParaRPr lang="en-US" sz="1100" dirty="0">
+                        <a:latin typeface="Calibri" charset="0"/>
+                        <a:ea typeface="Calibri" charset="0"/>
+                        <a:cs typeface="Calibri" charset="0"/>
+                      </a:endParaRPr>
+                    </a:p>
+                  </a:txBody>
+                  <a:tcPr marL="73152" marR="73152" marT="18288" marB="18288" anchor="ctr">
+                    <a:lnL w="6350" cap="flat" cmpd="sng" algn="ctr">
+                      <a:solidFill>
+                        <a:srgbClr val="EBE7E3"/>
+                      </a:solidFill>
+                      <a:prstDash val="solid"/>
+                      <a:round/>
+                      <a:headEnd type="none" w="med" len="med"/>
+                      <a:tailEnd type="none" w="med" len="med"/>
+                    </a:lnL>
+                    <a:lnR w="6350" cap="flat" cmpd="sng" algn="ctr">
+                      <a:solidFill>
+                        <a:srgbClr val="EBE7E3"/>
+                      </a:solidFill>
+                      <a:prstDash val="solid"/>
+                      <a:round/>
+                      <a:headEnd type="none" w="med" len="med"/>
+                      <a:tailEnd type="none" w="med" len="med"/>
+                    </a:lnR>
+                    <a:lnT w="6350" cap="flat" cmpd="sng" algn="ctr">
+                      <a:solidFill>
+                        <a:srgbClr val="EBE7E3"/>
+                      </a:solidFill>
+                      <a:prstDash val="solid"/>
+                      <a:round/>
+                      <a:headEnd type="none" w="med" len="med"/>
+                      <a:tailEnd type="none" w="med" len="med"/>
+                    </a:lnT>
+                    <a:lnB w="6350" cap="flat" cmpd="sng" algn="ctr">
+                      <a:solidFill>
+                        <a:srgbClr val="EBE7E3"/>
+                      </a:solidFill>
+                      <a:prstDash val="solid"/>
+                      <a:round/>
+                      <a:headEnd type="none" w="med" len="med"/>
+                      <a:tailEnd type="none" w="med" len="med"/>
+                    </a:lnB>
+                    <a:solidFill>
+                      <a:srgbClr val="FBEBC0"/>
+                    </a:solidFill>
+                  </a:tcPr>
+                </a:tc>
+                <a:tc>
+                  <a:txBody>
+                    <a:bodyPr/>
+                    <a:lstStyle/>
+                    <a:p>
+                      <a:pPr algn="ctr" indent="0" marL="0">
+                        <a:buNone/>
+                      </a:pPr>
+                      <a:r>
+                        <a:rPr lang="en-US" sz="1100" b="1" dirty="0">
+                          <a:solidFill>
+                            <a:srgbClr val="6B4E00"/>
+                          </a:solidFill>
+                          <a:latin typeface="Calibri" pitchFamily="34" charset="0"/>
+                          <a:ea typeface="Calibri" pitchFamily="34" charset="-122"/>
+                          <a:cs typeface="Calibri" pitchFamily="34" charset="-120"/>
+                        </a:rPr>
+                        <a:t>◐ Se configurado</a:t>
+                      </a:r>
+                      <a:endParaRPr lang="en-US" sz="1100" dirty="0">
+                        <a:latin typeface="Calibri" charset="0"/>
+                        <a:ea typeface="Calibri" charset="0"/>
+                        <a:cs typeface="Calibri" charset="0"/>
+                      </a:endParaRPr>
+                    </a:p>
+                  </a:txBody>
+                  <a:tcPr marL="73152" marR="73152" marT="18288" marB="18288" anchor="ctr">
+                    <a:lnL w="6350" cap="flat" cmpd="sng" algn="ctr">
+                      <a:solidFill>
+                        <a:srgbClr val="EBE7E3"/>
+                      </a:solidFill>
+                      <a:prstDash val="solid"/>
+                      <a:round/>
+                      <a:headEnd type="none" w="med" len="med"/>
+                      <a:tailEnd type="none" w="med" len="med"/>
+                    </a:lnL>
+                    <a:lnR w="6350" cap="flat" cmpd="sng" algn="ctr">
+                      <a:solidFill>
+                        <a:srgbClr val="EBE7E3"/>
+                      </a:solidFill>
+                      <a:prstDash val="solid"/>
+                      <a:round/>
+                      <a:headEnd type="none" w="med" len="med"/>
+                      <a:tailEnd type="none" w="med" len="med"/>
+                    </a:lnR>
+                    <a:lnT w="6350" cap="flat" cmpd="sng" algn="ctr">
+                      <a:solidFill>
+                        <a:srgbClr val="EBE7E3"/>
+                      </a:solidFill>
+                      <a:prstDash val="solid"/>
+                      <a:round/>
+                      <a:headEnd type="none" w="med" len="med"/>
+                      <a:tailEnd type="none" w="med" len="med"/>
+                    </a:lnT>
+                    <a:lnB w="6350" cap="flat" cmpd="sng" algn="ctr">
+                      <a:solidFill>
+                        <a:srgbClr val="EBE7E3"/>
+                      </a:solidFill>
+                      <a:prstDash val="solid"/>
+                      <a:round/>
+                      <a:headEnd type="none" w="med" len="med"/>
+                      <a:tailEnd type="none" w="med" len="med"/>
+                    </a:lnB>
+                    <a:solidFill>
+                      <a:srgbClr val="FBEBC0"/>
+                    </a:solidFill>
+                  </a:tcPr>
+                </a:tc>
+                <a:tc>
+                  <a:txBody>
+                    <a:bodyPr/>
+                    <a:lstStyle/>
+                    <a:p>
+                      <a:pPr algn="ctr" indent="0" marL="0">
+                        <a:buNone/>
+                      </a:pPr>
+                      <a:r>
+                        <a:rPr lang="en-US" sz="1100" b="1" dirty="0">
+                          <a:solidFill>
+                            <a:srgbClr val="6B4E00"/>
+                          </a:solidFill>
+                          <a:latin typeface="Calibri" pitchFamily="34" charset="0"/>
+                          <a:ea typeface="Calibri" pitchFamily="34" charset="-122"/>
+                          <a:cs typeface="Calibri" pitchFamily="34" charset="-120"/>
+                        </a:rPr>
+                        <a:t>◐ Se configurado</a:t>
+                      </a:r>
+                      <a:endParaRPr lang="en-US" sz="1100" dirty="0">
+                        <a:latin typeface="Calibri" charset="0"/>
+                        <a:ea typeface="Calibri" charset="0"/>
+                        <a:cs typeface="Calibri" charset="0"/>
+                      </a:endParaRPr>
+                    </a:p>
+                  </a:txBody>
+                  <a:tcPr marL="73152" marR="73152" marT="18288" marB="18288" anchor="ctr">
+                    <a:lnL w="6350" cap="flat" cmpd="sng" algn="ctr">
+                      <a:solidFill>
+                        <a:srgbClr val="EBE7E3"/>
+                      </a:solidFill>
+                      <a:prstDash val="solid"/>
+                      <a:round/>
+                      <a:headEnd type="none" w="med" len="med"/>
+                      <a:tailEnd type="none" w="med" len="med"/>
+                    </a:lnL>
+                    <a:lnR w="6350" cap="flat" cmpd="sng" algn="ctr">
+                      <a:solidFill>
+                        <a:srgbClr val="EBE7E3"/>
+                      </a:solidFill>
+                      <a:prstDash val="solid"/>
+                      <a:round/>
+                      <a:headEnd type="none" w="med" len="med"/>
+                      <a:tailEnd type="none" w="med" len="med"/>
+                    </a:lnR>
+                    <a:lnT w="6350" cap="flat" cmpd="sng" algn="ctr">
+                      <a:solidFill>
+                        <a:srgbClr val="EBE7E3"/>
+                      </a:solidFill>
+                      <a:prstDash val="solid"/>
+                      <a:round/>
+                      <a:headEnd type="none" w="med" len="med"/>
+                      <a:tailEnd type="none" w="med" len="med"/>
+                    </a:lnT>
+                    <a:lnB w="6350" cap="flat" cmpd="sng" algn="ctr">
+                      <a:solidFill>
+                        <a:srgbClr val="EBE7E3"/>
+                      </a:solidFill>
+                      <a:prstDash val="solid"/>
+                      <a:round/>
+                      <a:headEnd type="none" w="med" len="med"/>
+                      <a:tailEnd type="none" w="med" len="med"/>
+                    </a:lnB>
+                    <a:solidFill>
+                      <a:srgbClr val="FBEBC0"/>
+                    </a:solidFill>
+                  </a:tcPr>
+                </a:tc>
+                <a:tc>
+                  <a:txBody>
+                    <a:bodyPr/>
+                    <a:lstStyle/>
+                    <a:p>
+                      <a:pPr algn="ctr" indent="0" marL="0">
+                        <a:buNone/>
+                      </a:pPr>
+                      <a:r>
+                        <a:rPr lang="en-US" sz="1100" b="1" dirty="0">
+                          <a:solidFill>
+                            <a:srgbClr val="6B4E00"/>
+                          </a:solidFill>
+                          <a:latin typeface="Calibri" pitchFamily="34" charset="0"/>
+                          <a:ea typeface="Calibri" pitchFamily="34" charset="-122"/>
+                          <a:cs typeface="Calibri" pitchFamily="34" charset="-120"/>
+                        </a:rPr>
+                        <a:t>◐ Se configurado</a:t>
+                      </a:r>
+                      <a:endParaRPr lang="en-US" sz="1100" dirty="0">
+                        <a:latin typeface="Calibri" charset="0"/>
+                        <a:ea typeface="Calibri" charset="0"/>
+                        <a:cs typeface="Calibri" charset="0"/>
+                      </a:endParaRPr>
+                    </a:p>
+                  </a:txBody>
+                  <a:tcPr marL="73152" marR="73152" marT="18288" marB="18288" anchor="ctr">
+                    <a:lnL w="6350" cap="flat" cmpd="sng" algn="ctr">
+                      <a:solidFill>
+                        <a:srgbClr val="EBE7E3"/>
+                      </a:solidFill>
+                      <a:prstDash val="solid"/>
+                      <a:round/>
+                      <a:headEnd type="none" w="med" len="med"/>
+                      <a:tailEnd type="none" w="med" len="med"/>
+                    </a:lnL>
+                    <a:lnR w="6350" cap="flat" cmpd="sng" algn="ctr">
+                      <a:solidFill>
+                        <a:srgbClr val="EBE7E3"/>
+                      </a:solidFill>
+                      <a:prstDash val="solid"/>
+                      <a:round/>
+                      <a:headEnd type="none" w="med" len="med"/>
+                      <a:tailEnd type="none" w="med" len="med"/>
+                    </a:lnR>
+                    <a:lnT w="6350" cap="flat" cmpd="sng" algn="ctr">
+                      <a:solidFill>
+                        <a:srgbClr val="EBE7E3"/>
+                      </a:solidFill>
+                      <a:prstDash val="solid"/>
+                      <a:round/>
+                      <a:headEnd type="none" w="med" len="med"/>
+                      <a:tailEnd type="none" w="med" len="med"/>
+                    </a:lnT>
+                    <a:lnB w="6350" cap="flat" cmpd="sng" algn="ctr">
+                      <a:solidFill>
+                        <a:srgbClr val="EBE7E3"/>
+                      </a:solidFill>
+                      <a:prstDash val="solid"/>
+                      <a:round/>
+                      <a:headEnd type="none" w="med" len="med"/>
+                      <a:tailEnd type="none" w="med" len="med"/>
+                    </a:lnB>
+                    <a:solidFill>
+                      <a:srgbClr val="FBEBC0"/>
+                    </a:solidFill>
+                  </a:tcPr>
+                </a:tc>
+                <a:tc>
+                  <a:txBody>
+                    <a:bodyPr/>
+                    <a:lstStyle/>
+                    <a:p>
+                      <a:pPr algn="ctr" indent="0" marL="0">
+                        <a:buNone/>
+                      </a:pPr>
+                      <a:r>
+                        <a:rPr lang="en-US" sz="1100" b="1" dirty="0">
+                          <a:solidFill>
+                            <a:srgbClr val="545814"/>
+                          </a:solidFill>
+                          <a:latin typeface="Calibri" pitchFamily="34" charset="0"/>
+                          <a:ea typeface="Calibri" pitchFamily="34" charset="-122"/>
+                          <a:cs typeface="Calibri" pitchFamily="34" charset="-120"/>
+                        </a:rPr>
+                        <a:t>✓ Sim</a:t>
+                      </a:r>
+                      <a:endParaRPr lang="en-US" sz="1100" dirty="0">
+                        <a:latin typeface="Calibri" charset="0"/>
+                        <a:ea typeface="Calibri" charset="0"/>
+                        <a:cs typeface="Calibri" charset="0"/>
+                      </a:endParaRPr>
+                    </a:p>
+                  </a:txBody>
+                  <a:tcPr marL="73152" marR="73152" marT="18288" marB="18288" anchor="ctr">
+                    <a:lnL w="6350" cap="flat" cmpd="sng" algn="ctr">
+                      <a:solidFill>
+                        <a:srgbClr val="EBE7E3"/>
+                      </a:solidFill>
+                      <a:prstDash val="solid"/>
+                      <a:round/>
+                      <a:headEnd type="none" w="med" len="med"/>
+                      <a:tailEnd type="none" w="med" len="med"/>
+                    </a:lnL>
+                    <a:lnR w="6350" cap="flat" cmpd="sng" algn="ctr">
+                      <a:solidFill>
+                        <a:srgbClr val="EBE7E3"/>
+                      </a:solidFill>
+                      <a:prstDash val="solid"/>
+                      <a:round/>
+                      <a:headEnd type="none" w="med" len="med"/>
+                      <a:tailEnd type="none" w="med" len="med"/>
+                    </a:lnR>
+                    <a:lnT w="6350" cap="flat" cmpd="sng" algn="ctr">
+                      <a:solidFill>
+                        <a:srgbClr val="EBE7E3"/>
+                      </a:solidFill>
+                      <a:prstDash val="solid"/>
+                      <a:round/>
+                      <a:headEnd type="none" w="med" len="med"/>
+                      <a:tailEnd type="none" w="med" len="med"/>
+                    </a:lnT>
+                    <a:lnB w="6350" cap="flat" cmpd="sng" algn="ctr">
+                      <a:solidFill>
+                        <a:srgbClr val="EBE7E3"/>
+                      </a:solidFill>
+                      <a:prstDash val="solid"/>
+                      <a:round/>
+                      <a:headEnd type="none" w="med" len="med"/>
+                      <a:tailEnd type="none" w="med" len="med"/>
+                    </a:lnB>
+                    <a:solidFill>
+                      <a:srgbClr val="E4E6C3"/>
+                    </a:solidFill>
+                  </a:tcPr>
+                </a:tc>
+              </a:tr>
+              <a:tr h="347472">
+                <a:tc>
+                  <a:txBody>
+                    <a:bodyPr/>
+                    <a:lstStyle/>
+                    <a:p>
+                      <a:pPr indent="0" marL="0">
+                        <a:buNone/>
+                      </a:pPr>
+                      <a:r>
+                        <a:rPr lang="en-US" sz="1200" dirty="0">
+                          <a:solidFill>
+                            <a:srgbClr val="2B1E1C"/>
+                          </a:solidFill>
+                          <a:latin typeface="Calibri" pitchFamily="34" charset="0"/>
+                          <a:ea typeface="Calibri" pitchFamily="34" charset="-122"/>
+                          <a:cs typeface="Calibri" pitchFamily="34" charset="-120"/>
+                        </a:rPr>
+                        <a:t>Ver as adesões e exportar as listas (Excel, PDF, CSV)</a:t>
+                      </a:r>
+                      <a:endParaRPr lang="en-US" sz="1200" dirty="0">
+                        <a:latin typeface="Calibri" charset="0"/>
+                        <a:ea typeface="Calibri" charset="0"/>
+                        <a:cs typeface="Calibri" charset="0"/>
+                      </a:endParaRPr>
+                    </a:p>
+                  </a:txBody>
+                  <a:tcPr marL="73152" marR="73152" marT="18288" marB="18288" anchor="ctr">
+                    <a:lnL w="6350" cap="flat" cmpd="sng" algn="ctr">
+                      <a:solidFill>
+                        <a:srgbClr val="EBE7E3"/>
+                      </a:solidFill>
+                      <a:prstDash val="solid"/>
+                      <a:round/>
+                      <a:headEnd type="none" w="med" len="med"/>
+                      <a:tailEnd type="none" w="med" len="med"/>
+                    </a:lnL>
+                    <a:lnR w="6350" cap="flat" cmpd="sng" algn="ctr">
+                      <a:solidFill>
+                        <a:srgbClr val="EBE7E3"/>
+                      </a:solidFill>
+                      <a:prstDash val="solid"/>
+                      <a:round/>
+                      <a:headEnd type="none" w="med" len="med"/>
+                      <a:tailEnd type="none" w="med" len="med"/>
+                    </a:lnR>
+                    <a:lnT w="6350" cap="flat" cmpd="sng" algn="ctr">
+                      <a:solidFill>
+                        <a:srgbClr val="EBE7E3"/>
+                      </a:solidFill>
+                      <a:prstDash val="solid"/>
+                      <a:round/>
+                      <a:headEnd type="none" w="med" len="med"/>
+                      <a:tailEnd type="none" w="med" len="med"/>
+                    </a:lnT>
+                    <a:lnB w="6350" cap="flat" cmpd="sng" algn="ctr">
+                      <a:solidFill>
+                        <a:srgbClr val="EBE7E3"/>
+                      </a:solidFill>
+                      <a:prstDash val="solid"/>
+                      <a:round/>
+                      <a:headEnd type="none" w="med" len="med"/>
+                      <a:tailEnd type="none" w="med" len="med"/>
+                    </a:lnB>
+                  </a:tcPr>
+                </a:tc>
+                <a:tc>
+                  <a:txBody>
+                    <a:bodyPr/>
+                    <a:lstStyle/>
+                    <a:p>
+                      <a:pPr algn="ctr" indent="0" marL="0">
+                        <a:buNone/>
+                      </a:pPr>
+                      <a:r>
+                        <a:rPr lang="en-US" sz="1100" b="1" dirty="0">
+                          <a:solidFill>
+                            <a:srgbClr val="545814"/>
+                          </a:solidFill>
+                          <a:latin typeface="Calibri" pitchFamily="34" charset="0"/>
+                          <a:ea typeface="Calibri" pitchFamily="34" charset="-122"/>
+                          <a:cs typeface="Calibri" pitchFamily="34" charset="-120"/>
+                        </a:rPr>
+                        <a:t>✓ Sim</a:t>
+                      </a:r>
+                      <a:endParaRPr lang="en-US" sz="1100" dirty="0">
+                        <a:latin typeface="Calibri" charset="0"/>
+                        <a:ea typeface="Calibri" charset="0"/>
+                        <a:cs typeface="Calibri" charset="0"/>
+                      </a:endParaRPr>
+                    </a:p>
+                  </a:txBody>
+                  <a:tcPr marL="73152" marR="73152" marT="18288" marB="18288" anchor="ctr">
+                    <a:lnL w="6350" cap="flat" cmpd="sng" algn="ctr">
+                      <a:solidFill>
+                        <a:srgbClr val="EBE7E3"/>
+                      </a:solidFill>
+                      <a:prstDash val="solid"/>
+                      <a:round/>
+                      <a:headEnd type="none" w="med" len="med"/>
+                      <a:tailEnd type="none" w="med" len="med"/>
+                    </a:lnL>
+                    <a:lnR w="6350" cap="flat" cmpd="sng" algn="ctr">
+                      <a:solidFill>
+                        <a:srgbClr val="EBE7E3"/>
+                      </a:solidFill>
+                      <a:prstDash val="solid"/>
+                      <a:round/>
+                      <a:headEnd type="none" w="med" len="med"/>
+                      <a:tailEnd type="none" w="med" len="med"/>
+                    </a:lnR>
+                    <a:lnT w="6350" cap="flat" cmpd="sng" algn="ctr">
+                      <a:solidFill>
+                        <a:srgbClr val="EBE7E3"/>
+                      </a:solidFill>
+                      <a:prstDash val="solid"/>
+                      <a:round/>
+                      <a:headEnd type="none" w="med" len="med"/>
+                      <a:tailEnd type="none" w="med" len="med"/>
+                    </a:lnT>
+                    <a:lnB w="6350" cap="flat" cmpd="sng" algn="ctr">
+                      <a:solidFill>
+                        <a:srgbClr val="EBE7E3"/>
+                      </a:solidFill>
+                      <a:prstDash val="solid"/>
+                      <a:round/>
+                      <a:headEnd type="none" w="med" len="med"/>
+                      <a:tailEnd type="none" w="med" len="med"/>
+                    </a:lnB>
+                    <a:solidFill>
+                      <a:srgbClr val="E4E6C3"/>
+                    </a:solidFill>
+                  </a:tcPr>
+                </a:tc>
+                <a:tc>
+                  <a:txBody>
+                    <a:bodyPr/>
+                    <a:lstStyle/>
+                    <a:p>
+                      <a:pPr algn="ctr" indent="0" marL="0">
+                        <a:buNone/>
+                      </a:pPr>
+                      <a:r>
+                        <a:rPr lang="en-US" sz="1100" b="1" dirty="0">
+                          <a:solidFill>
+                            <a:srgbClr val="6B4E00"/>
+                          </a:solidFill>
+                          <a:latin typeface="Calibri" pitchFamily="34" charset="0"/>
+                          <a:ea typeface="Calibri" pitchFamily="34" charset="-122"/>
+                          <a:cs typeface="Calibri" pitchFamily="34" charset="-120"/>
+                        </a:rPr>
+                        <a:t>◐ Se configurado</a:t>
+                      </a:r>
+                      <a:endParaRPr lang="en-US" sz="1100" dirty="0">
+                        <a:latin typeface="Calibri" charset="0"/>
+                        <a:ea typeface="Calibri" charset="0"/>
+                        <a:cs typeface="Calibri" charset="0"/>
+                      </a:endParaRPr>
+                    </a:p>
+                  </a:txBody>
+                  <a:tcPr marL="73152" marR="73152" marT="18288" marB="18288" anchor="ctr">
+                    <a:lnL w="6350" cap="flat" cmpd="sng" algn="ctr">
+                      <a:solidFill>
+                        <a:srgbClr val="EBE7E3"/>
+                      </a:solidFill>
+                      <a:prstDash val="solid"/>
+                      <a:round/>
+                      <a:headEnd type="none" w="med" len="med"/>
+                      <a:tailEnd type="none" w="med" len="med"/>
+                    </a:lnL>
+                    <a:lnR w="6350" cap="flat" cmpd="sng" algn="ctr">
+                      <a:solidFill>
+                        <a:srgbClr val="EBE7E3"/>
+                      </a:solidFill>
+                      <a:prstDash val="solid"/>
+                      <a:round/>
+                      <a:headEnd type="none" w="med" len="med"/>
+                      <a:tailEnd type="none" w="med" len="med"/>
+                    </a:lnR>
+                    <a:lnT w="6350" cap="flat" cmpd="sng" algn="ctr">
+                      <a:solidFill>
+                        <a:srgbClr val="EBE7E3"/>
+                      </a:solidFill>
+                      <a:prstDash val="solid"/>
+                      <a:round/>
+                      <a:headEnd type="none" w="med" len="med"/>
+                      <a:tailEnd type="none" w="med" len="med"/>
+                    </a:lnT>
+                    <a:lnB w="6350" cap="flat" cmpd="sng" algn="ctr">
+                      <a:solidFill>
+                        <a:srgbClr val="EBE7E3"/>
+                      </a:solidFill>
+                      <a:prstDash val="solid"/>
+                      <a:round/>
+                      <a:headEnd type="none" w="med" len="med"/>
+                      <a:tailEnd type="none" w="med" len="med"/>
+                    </a:lnB>
+                    <a:solidFill>
+                      <a:srgbClr val="FBEBC0"/>
+                    </a:solidFill>
+                  </a:tcPr>
+                </a:tc>
+                <a:tc>
+                  <a:txBody>
+                    <a:bodyPr/>
+                    <a:lstStyle/>
+                    <a:p>
+                      <a:pPr algn="ctr" indent="0" marL="0">
+                        <a:buNone/>
+                      </a:pPr>
+                      <a:r>
+                        <a:rPr lang="en-US" sz="1100" b="1" dirty="0">
+                          <a:solidFill>
+                            <a:srgbClr val="6B4E00"/>
+                          </a:solidFill>
+                          <a:latin typeface="Calibri" pitchFamily="34" charset="0"/>
+                          <a:ea typeface="Calibri" pitchFamily="34" charset="-122"/>
+                          <a:cs typeface="Calibri" pitchFamily="34" charset="-120"/>
+                        </a:rPr>
+                        <a:t>◐ Se configurado</a:t>
+                      </a:r>
+                      <a:endParaRPr lang="en-US" sz="1100" dirty="0">
+                        <a:latin typeface="Calibri" charset="0"/>
+                        <a:ea typeface="Calibri" charset="0"/>
+                        <a:cs typeface="Calibri" charset="0"/>
+                      </a:endParaRPr>
+                    </a:p>
+                  </a:txBody>
+                  <a:tcPr marL="73152" marR="73152" marT="18288" marB="18288" anchor="ctr">
+                    <a:lnL w="6350" cap="flat" cmpd="sng" algn="ctr">
+                      <a:solidFill>
+                        <a:srgbClr val="EBE7E3"/>
+                      </a:solidFill>
+                      <a:prstDash val="solid"/>
+                      <a:round/>
+                      <a:headEnd type="none" w="med" len="med"/>
+                      <a:tailEnd type="none" w="med" len="med"/>
+                    </a:lnL>
+                    <a:lnR w="6350" cap="flat" cmpd="sng" algn="ctr">
+                      <a:solidFill>
+                        <a:srgbClr val="EBE7E3"/>
+                      </a:solidFill>
+                      <a:prstDash val="solid"/>
+                      <a:round/>
+                      <a:headEnd type="none" w="med" len="med"/>
+                      <a:tailEnd type="none" w="med" len="med"/>
+                    </a:lnR>
+                    <a:lnT w="6350" cap="flat" cmpd="sng" algn="ctr">
+                      <a:solidFill>
+                        <a:srgbClr val="EBE7E3"/>
+                      </a:solidFill>
+                      <a:prstDash val="solid"/>
+                      <a:round/>
+                      <a:headEnd type="none" w="med" len="med"/>
+                      <a:tailEnd type="none" w="med" len="med"/>
+                    </a:lnT>
+                    <a:lnB w="6350" cap="flat" cmpd="sng" algn="ctr">
+                      <a:solidFill>
+                        <a:srgbClr val="EBE7E3"/>
+                      </a:solidFill>
+                      <a:prstDash val="solid"/>
+                      <a:round/>
+                      <a:headEnd type="none" w="med" len="med"/>
+                      <a:tailEnd type="none" w="med" len="med"/>
+                    </a:lnB>
+                    <a:solidFill>
+                      <a:srgbClr val="FBEBC0"/>
+                    </a:solidFill>
+                  </a:tcPr>
+                </a:tc>
+                <a:tc>
+                  <a:txBody>
+                    <a:bodyPr/>
+                    <a:lstStyle/>
+                    <a:p>
+                      <a:pPr algn="ctr" indent="0" marL="0">
+                        <a:buNone/>
+                      </a:pPr>
+                      <a:r>
+                        <a:rPr lang="en-US" sz="1100" b="1" dirty="0">
+                          <a:solidFill>
+                            <a:srgbClr val="6B4E00"/>
+                          </a:solidFill>
+                          <a:latin typeface="Calibri" pitchFamily="34" charset="0"/>
+                          <a:ea typeface="Calibri" pitchFamily="34" charset="-122"/>
+                          <a:cs typeface="Calibri" pitchFamily="34" charset="-120"/>
+                        </a:rPr>
+                        <a:t>◐ Se configurado</a:t>
+                      </a:r>
+                      <a:endParaRPr lang="en-US" sz="1100" dirty="0">
+                        <a:latin typeface="Calibri" charset="0"/>
+                        <a:ea typeface="Calibri" charset="0"/>
+                        <a:cs typeface="Calibri" charset="0"/>
+                      </a:endParaRPr>
+                    </a:p>
+                  </a:txBody>
+                  <a:tcPr marL="73152" marR="73152" marT="18288" marB="18288" anchor="ctr">
+                    <a:lnL w="6350" cap="flat" cmpd="sng" algn="ctr">
+                      <a:solidFill>
+                        <a:srgbClr val="EBE7E3"/>
+                      </a:solidFill>
+                      <a:prstDash val="solid"/>
+                      <a:round/>
+                      <a:headEnd type="none" w="med" len="med"/>
+                      <a:tailEnd type="none" w="med" len="med"/>
+                    </a:lnL>
+                    <a:lnR w="6350" cap="flat" cmpd="sng" algn="ctr">
+                      <a:solidFill>
+                        <a:srgbClr val="EBE7E3"/>
+                      </a:solidFill>
+                      <a:prstDash val="solid"/>
+                      <a:round/>
+                      <a:headEnd type="none" w="med" len="med"/>
+                      <a:tailEnd type="none" w="med" len="med"/>
+                    </a:lnR>
+                    <a:lnT w="6350" cap="flat" cmpd="sng" algn="ctr">
+                      <a:solidFill>
+                        <a:srgbClr val="EBE7E3"/>
+                      </a:solidFill>
+                      <a:prstDash val="solid"/>
+                      <a:round/>
+                      <a:headEnd type="none" w="med" len="med"/>
+                      <a:tailEnd type="none" w="med" len="med"/>
+                    </a:lnT>
+                    <a:lnB w="6350" cap="flat" cmpd="sng" algn="ctr">
+                      <a:solidFill>
+                        <a:srgbClr val="EBE7E3"/>
+                      </a:solidFill>
+                      <a:prstDash val="solid"/>
+                      <a:round/>
+                      <a:headEnd type="none" w="med" len="med"/>
+                      <a:tailEnd type="none" w="med" len="med"/>
+                    </a:lnB>
+                    <a:solidFill>
+                      <a:srgbClr val="FBEBC0"/>
+                    </a:solidFill>
+                  </a:tcPr>
+                </a:tc>
+                <a:tc>
+                  <a:txBody>
+                    <a:bodyPr/>
+                    <a:lstStyle/>
+                    <a:p>
+                      <a:pPr algn="ctr" indent="0" marL="0">
+                        <a:buNone/>
+                      </a:pPr>
+                      <a:r>
+                        <a:rPr lang="en-US" sz="1100" b="1" dirty="0">
+                          <a:solidFill>
+                            <a:srgbClr val="6B4E00"/>
+                          </a:solidFill>
+                          <a:latin typeface="Calibri" pitchFamily="34" charset="0"/>
+                          <a:ea typeface="Calibri" pitchFamily="34" charset="-122"/>
+                          <a:cs typeface="Calibri" pitchFamily="34" charset="-120"/>
+                        </a:rPr>
+                        <a:t>◐ Se configurado</a:t>
+                      </a:r>
+                      <a:endParaRPr lang="en-US" sz="1100" dirty="0">
+                        <a:latin typeface="Calibri" charset="0"/>
+                        <a:ea typeface="Calibri" charset="0"/>
+                        <a:cs typeface="Calibri" charset="0"/>
+                      </a:endParaRPr>
+                    </a:p>
+                  </a:txBody>
+                  <a:tcPr marL="73152" marR="73152" marT="18288" marB="18288" anchor="ctr">
+                    <a:lnL w="6350" cap="flat" cmpd="sng" algn="ctr">
+                      <a:solidFill>
+                        <a:srgbClr val="EBE7E3"/>
+                      </a:solidFill>
+                      <a:prstDash val="solid"/>
+                      <a:round/>
+                      <a:headEnd type="none" w="med" len="med"/>
+                      <a:tailEnd type="none" w="med" len="med"/>
+                    </a:lnL>
+                    <a:lnR w="6350" cap="flat" cmpd="sng" algn="ctr">
+                      <a:solidFill>
+                        <a:srgbClr val="EBE7E3"/>
+                      </a:solidFill>
+                      <a:prstDash val="solid"/>
+                      <a:round/>
+                      <a:headEnd type="none" w="med" len="med"/>
+                      <a:tailEnd type="none" w="med" len="med"/>
+                    </a:lnR>
+                    <a:lnT w="6350" cap="flat" cmpd="sng" algn="ctr">
+                      <a:solidFill>
+                        <a:srgbClr val="EBE7E3"/>
+                      </a:solidFill>
+                      <a:prstDash val="solid"/>
+                      <a:round/>
+                      <a:headEnd type="none" w="med" len="med"/>
+                      <a:tailEnd type="none" w="med" len="med"/>
+                    </a:lnT>
+                    <a:lnB w="6350" cap="flat" cmpd="sng" algn="ctr">
+                      <a:solidFill>
+                        <a:srgbClr val="EBE7E3"/>
+                      </a:solidFill>
+                      <a:prstDash val="solid"/>
+                      <a:round/>
+                      <a:headEnd type="none" w="med" len="med"/>
+                      <a:tailEnd type="none" w="med" len="med"/>
+                    </a:lnB>
+                    <a:solidFill>
+                      <a:srgbClr val="FBEBC0"/>
+                    </a:solidFill>
+                  </a:tcPr>
+                </a:tc>
+                <a:tc>
+                  <a:txBody>
+                    <a:bodyPr/>
+                    <a:lstStyle/>
+                    <a:p>
+                      <a:pPr algn="ctr" indent="0" marL="0">
+                        <a:buNone/>
+                      </a:pPr>
+                      <a:r>
+                        <a:rPr lang="en-US" sz="1100" b="1" dirty="0">
+                          <a:solidFill>
+                            <a:srgbClr val="545814"/>
+                          </a:solidFill>
+                          <a:latin typeface="Calibri" pitchFamily="34" charset="0"/>
+                          <a:ea typeface="Calibri" pitchFamily="34" charset="-122"/>
+                          <a:cs typeface="Calibri" pitchFamily="34" charset="-120"/>
+                        </a:rPr>
+                        <a:t>✓ Sim</a:t>
+                      </a:r>
+                      <a:endParaRPr lang="en-US" sz="1100" dirty="0">
+                        <a:latin typeface="Calibri" charset="0"/>
+                        <a:ea typeface="Calibri" charset="0"/>
+                        <a:cs typeface="Calibri" charset="0"/>
+                      </a:endParaRPr>
+                    </a:p>
+                  </a:txBody>
+                  <a:tcPr marL="73152" marR="73152" marT="18288" marB="18288" anchor="ctr">
+                    <a:lnL w="6350" cap="flat" cmpd="sng" algn="ctr">
+                      <a:solidFill>
+                        <a:srgbClr val="EBE7E3"/>
+                      </a:solidFill>
+                      <a:prstDash val="solid"/>
+                      <a:round/>
+                      <a:headEnd type="none" w="med" len="med"/>
+                      <a:tailEnd type="none" w="med" len="med"/>
+                    </a:lnL>
+                    <a:lnR w="6350" cap="flat" cmpd="sng" algn="ctr">
+                      <a:solidFill>
+                        <a:srgbClr val="EBE7E3"/>
+                      </a:solidFill>
+                      <a:prstDash val="solid"/>
+                      <a:round/>
+                      <a:headEnd type="none" w="med" len="med"/>
+                      <a:tailEnd type="none" w="med" len="med"/>
+                    </a:lnR>
+                    <a:lnT w="6350" cap="flat" cmpd="sng" algn="ctr">
+                      <a:solidFill>
+                        <a:srgbClr val="EBE7E3"/>
+                      </a:solidFill>
+                      <a:prstDash val="solid"/>
+                      <a:round/>
+                      <a:headEnd type="none" w="med" len="med"/>
+                      <a:tailEnd type="none" w="med" len="med"/>
+                    </a:lnT>
+                    <a:lnB w="6350" cap="flat" cmpd="sng" algn="ctr">
+                      <a:solidFill>
+                        <a:srgbClr val="EBE7E3"/>
+                      </a:solidFill>
+                      <a:prstDash val="solid"/>
+                      <a:round/>
+                      <a:headEnd type="none" w="med" len="med"/>
+                      <a:tailEnd type="none" w="med" len="med"/>
+                    </a:lnB>
+                    <a:solidFill>
+                      <a:srgbClr val="E4E6C3"/>
+                    </a:solidFill>
+                  </a:tcPr>
+                </a:tc>
+              </a:tr>
+              <a:tr h="347472">
+                <a:tc>
+                  <a:txBody>
+                    <a:bodyPr/>
+                    <a:lstStyle/>
+                    <a:p>
+                      <a:pPr indent="0" marL="0">
+                        <a:buNone/>
+                      </a:pPr>
+                      <a:r>
+                        <a:rPr lang="en-US" sz="1200" dirty="0">
+                          <a:solidFill>
+                            <a:srgbClr val="2B1E1C"/>
+                          </a:solidFill>
+                          <a:latin typeface="Calibri" pitchFamily="34" charset="0"/>
+                          <a:ea typeface="Calibri" pitchFamily="34" charset="-122"/>
+                          <a:cs typeface="Calibri" pitchFamily="34" charset="-120"/>
+                        </a:rPr>
+                        <a:t>Ver as leituras e as fotos do hidrômetro de todas as casas</a:t>
+                      </a:r>
+                      <a:endParaRPr lang="en-US" sz="1200" dirty="0">
+                        <a:latin typeface="Calibri" charset="0"/>
+                        <a:ea typeface="Calibri" charset="0"/>
+                        <a:cs typeface="Calibri" charset="0"/>
+                      </a:endParaRPr>
+                    </a:p>
+                  </a:txBody>
+                  <a:tcPr marL="73152" marR="73152" marT="18288" marB="18288" anchor="ctr">
+                    <a:lnL w="6350" cap="flat" cmpd="sng" algn="ctr">
+                      <a:solidFill>
+                        <a:srgbClr val="EBE7E3"/>
+                      </a:solidFill>
+                      <a:prstDash val="solid"/>
+                      <a:round/>
+                      <a:headEnd type="none" w="med" len="med"/>
+                      <a:tailEnd type="none" w="med" len="med"/>
+                    </a:lnL>
+                    <a:lnR w="6350" cap="flat" cmpd="sng" algn="ctr">
+                      <a:solidFill>
+                        <a:srgbClr val="EBE7E3"/>
+                      </a:solidFill>
+                      <a:prstDash val="solid"/>
+                      <a:round/>
+                      <a:headEnd type="none" w="med" len="med"/>
+                      <a:tailEnd type="none" w="med" len="med"/>
+                    </a:lnR>
+                    <a:lnT w="6350" cap="flat" cmpd="sng" algn="ctr">
+                      <a:solidFill>
+                        <a:srgbClr val="EBE7E3"/>
+                      </a:solidFill>
+                      <a:prstDash val="solid"/>
+                      <a:round/>
+                      <a:headEnd type="none" w="med" len="med"/>
+                      <a:tailEnd type="none" w="med" len="med"/>
+                    </a:lnT>
+                    <a:lnB w="6350" cap="flat" cmpd="sng" algn="ctr">
+                      <a:solidFill>
+                        <a:srgbClr val="EBE7E3"/>
+                      </a:solidFill>
+                      <a:prstDash val="solid"/>
+                      <a:round/>
+                      <a:headEnd type="none" w="med" len="med"/>
+                      <a:tailEnd type="none" w="med" len="med"/>
+                    </a:lnB>
+                  </a:tcPr>
+                </a:tc>
+                <a:tc>
+                  <a:txBody>
+                    <a:bodyPr/>
+                    <a:lstStyle/>
+                    <a:p>
+                      <a:pPr algn="ctr" indent="0" marL="0">
+                        <a:buNone/>
+                      </a:pPr>
+                      <a:r>
+                        <a:rPr lang="en-US" sz="1100" b="1" dirty="0">
+                          <a:solidFill>
+                            <a:srgbClr val="545814"/>
+                          </a:solidFill>
+                          <a:latin typeface="Calibri" pitchFamily="34" charset="0"/>
+                          <a:ea typeface="Calibri" pitchFamily="34" charset="-122"/>
+                          <a:cs typeface="Calibri" pitchFamily="34" charset="-120"/>
+                        </a:rPr>
+                        <a:t>✓ Sim</a:t>
+                      </a:r>
+                      <a:endParaRPr lang="en-US" sz="1100" dirty="0">
+                        <a:latin typeface="Calibri" charset="0"/>
+                        <a:ea typeface="Calibri" charset="0"/>
+                        <a:cs typeface="Calibri" charset="0"/>
+                      </a:endParaRPr>
+                    </a:p>
+                  </a:txBody>
+                  <a:tcPr marL="73152" marR="73152" marT="18288" marB="18288" anchor="ctr">
+                    <a:lnL w="6350" cap="flat" cmpd="sng" algn="ctr">
+                      <a:solidFill>
+                        <a:srgbClr val="EBE7E3"/>
+                      </a:solidFill>
+                      <a:prstDash val="solid"/>
+                      <a:round/>
+                      <a:headEnd type="none" w="med" len="med"/>
+                      <a:tailEnd type="none" w="med" len="med"/>
+                    </a:lnL>
+                    <a:lnR w="6350" cap="flat" cmpd="sng" algn="ctr">
+                      <a:solidFill>
+                        <a:srgbClr val="EBE7E3"/>
+                      </a:solidFill>
+                      <a:prstDash val="solid"/>
+                      <a:round/>
+                      <a:headEnd type="none" w="med" len="med"/>
+                      <a:tailEnd type="none" w="med" len="med"/>
+                    </a:lnR>
+                    <a:lnT w="6350" cap="flat" cmpd="sng" algn="ctr">
+                      <a:solidFill>
+                        <a:srgbClr val="EBE7E3"/>
+                      </a:solidFill>
+                      <a:prstDash val="solid"/>
+                      <a:round/>
+                      <a:headEnd type="none" w="med" len="med"/>
+                      <a:tailEnd type="none" w="med" len="med"/>
+                    </a:lnT>
+                    <a:lnB w="6350" cap="flat" cmpd="sng" algn="ctr">
+                      <a:solidFill>
+                        <a:srgbClr val="EBE7E3"/>
+                      </a:solidFill>
+                      <a:prstDash val="solid"/>
+                      <a:round/>
+                      <a:headEnd type="none" w="med" len="med"/>
+                      <a:tailEnd type="none" w="med" len="med"/>
+                    </a:lnB>
+                    <a:solidFill>
+                      <a:srgbClr val="E4E6C3"/>
+                    </a:solidFill>
+                  </a:tcPr>
+                </a:tc>
+                <a:tc>
+                  <a:txBody>
+                    <a:bodyPr/>
+                    <a:lstStyle/>
+                    <a:p>
+                      <a:pPr algn="ctr" indent="0" marL="0">
+                        <a:buNone/>
+                      </a:pPr>
+                      <a:r>
+                        <a:rPr lang="en-US" sz="1100" b="1" dirty="0">
+                          <a:solidFill>
+                            <a:srgbClr val="545814"/>
+                          </a:solidFill>
+                          <a:latin typeface="Calibri" pitchFamily="34" charset="0"/>
+                          <a:ea typeface="Calibri" pitchFamily="34" charset="-122"/>
+                          <a:cs typeface="Calibri" pitchFamily="34" charset="-120"/>
+                        </a:rPr>
+                        <a:t>✓ Sim</a:t>
+                      </a:r>
+                      <a:endParaRPr lang="en-US" sz="1100" dirty="0">
+                        <a:latin typeface="Calibri" charset="0"/>
+                        <a:ea typeface="Calibri" charset="0"/>
+                        <a:cs typeface="Calibri" charset="0"/>
+                      </a:endParaRPr>
+                    </a:p>
+                  </a:txBody>
+                  <a:tcPr marL="73152" marR="73152" marT="18288" marB="18288" anchor="ctr">
+                    <a:lnL w="6350" cap="flat" cmpd="sng" algn="ctr">
+                      <a:solidFill>
+                        <a:srgbClr val="EBE7E3"/>
+                      </a:solidFill>
+                      <a:prstDash val="solid"/>
+                      <a:round/>
+                      <a:headEnd type="none" w="med" len="med"/>
+                      <a:tailEnd type="none" w="med" len="med"/>
+                    </a:lnL>
+                    <a:lnR w="6350" cap="flat" cmpd="sng" algn="ctr">
+                      <a:solidFill>
+                        <a:srgbClr val="EBE7E3"/>
+                      </a:solidFill>
+                      <a:prstDash val="solid"/>
+                      <a:round/>
+                      <a:headEnd type="none" w="med" len="med"/>
+                      <a:tailEnd type="none" w="med" len="med"/>
+                    </a:lnR>
+                    <a:lnT w="6350" cap="flat" cmpd="sng" algn="ctr">
+                      <a:solidFill>
+                        <a:srgbClr val="EBE7E3"/>
+                      </a:solidFill>
+                      <a:prstDash val="solid"/>
+                      <a:round/>
+                      <a:headEnd type="none" w="med" len="med"/>
+                      <a:tailEnd type="none" w="med" len="med"/>
+                    </a:lnT>
+                    <a:lnB w="6350" cap="flat" cmpd="sng" algn="ctr">
+                      <a:solidFill>
+                        <a:srgbClr val="EBE7E3"/>
+                      </a:solidFill>
+                      <a:prstDash val="solid"/>
+                      <a:round/>
+                      <a:headEnd type="none" w="med" len="med"/>
+                      <a:tailEnd type="none" w="med" len="med"/>
+                    </a:lnB>
+                    <a:solidFill>
+                      <a:srgbClr val="E4E6C3"/>
+                    </a:solidFill>
+                  </a:tcPr>
+                </a:tc>
+                <a:tc>
+                  <a:txBody>
+                    <a:bodyPr/>
+                    <a:lstStyle/>
+                    <a:p>
+                      <a:pPr algn="ctr" indent="0" marL="0">
+                        <a:buNone/>
+                      </a:pPr>
+                      <a:r>
+                        <a:rPr lang="en-US" sz="1100" b="1" dirty="0">
+                          <a:solidFill>
+                            <a:srgbClr val="545814"/>
+                          </a:solidFill>
+                          <a:latin typeface="Calibri" pitchFamily="34" charset="0"/>
+                          <a:ea typeface="Calibri" pitchFamily="34" charset="-122"/>
+                          <a:cs typeface="Calibri" pitchFamily="34" charset="-120"/>
+                        </a:rPr>
+                        <a:t>✓ Sim</a:t>
+                      </a:r>
+                      <a:endParaRPr lang="en-US" sz="1100" dirty="0">
+                        <a:latin typeface="Calibri" charset="0"/>
+                        <a:ea typeface="Calibri" charset="0"/>
+                        <a:cs typeface="Calibri" charset="0"/>
+                      </a:endParaRPr>
+                    </a:p>
+                  </a:txBody>
+                  <a:tcPr marL="73152" marR="73152" marT="18288" marB="18288" anchor="ctr">
+                    <a:lnL w="6350" cap="flat" cmpd="sng" algn="ctr">
+                      <a:solidFill>
+                        <a:srgbClr val="EBE7E3"/>
+                      </a:solidFill>
+                      <a:prstDash val="solid"/>
+                      <a:round/>
+                      <a:headEnd type="none" w="med" len="med"/>
+                      <a:tailEnd type="none" w="med" len="med"/>
+                    </a:lnL>
+                    <a:lnR w="6350" cap="flat" cmpd="sng" algn="ctr">
+                      <a:solidFill>
+                        <a:srgbClr val="EBE7E3"/>
+                      </a:solidFill>
+                      <a:prstDash val="solid"/>
+                      <a:round/>
+                      <a:headEnd type="none" w="med" len="med"/>
+                      <a:tailEnd type="none" w="med" len="med"/>
+                    </a:lnR>
+                    <a:lnT w="6350" cap="flat" cmpd="sng" algn="ctr">
+                      <a:solidFill>
+                        <a:srgbClr val="EBE7E3"/>
+                      </a:solidFill>
+                      <a:prstDash val="solid"/>
+                      <a:round/>
+                      <a:headEnd type="none" w="med" len="med"/>
+                      <a:tailEnd type="none" w="med" len="med"/>
+                    </a:lnT>
+                    <a:lnB w="6350" cap="flat" cmpd="sng" algn="ctr">
+                      <a:solidFill>
+                        <a:srgbClr val="EBE7E3"/>
+                      </a:solidFill>
+                      <a:prstDash val="solid"/>
+                      <a:round/>
+                      <a:headEnd type="none" w="med" len="med"/>
+                      <a:tailEnd type="none" w="med" len="med"/>
+                    </a:lnB>
+                    <a:solidFill>
+                      <a:srgbClr val="E4E6C3"/>
+                    </a:solidFill>
+                  </a:tcPr>
+                </a:tc>
+                <a:tc>
+                  <a:txBody>
+                    <a:bodyPr/>
+                    <a:lstStyle/>
+                    <a:p>
+                      <a:pPr algn="ctr" indent="0" marL="0">
+                        <a:buNone/>
+                      </a:pPr>
+                      <a:r>
+                        <a:rPr lang="en-US" sz="1100" b="1" dirty="0">
+                          <a:solidFill>
+                            <a:srgbClr val="545814"/>
+                          </a:solidFill>
+                          <a:latin typeface="Calibri" pitchFamily="34" charset="0"/>
+                          <a:ea typeface="Calibri" pitchFamily="34" charset="-122"/>
+                          <a:cs typeface="Calibri" pitchFamily="34" charset="-120"/>
+                        </a:rPr>
+                        <a:t>✓ Sim</a:t>
+                      </a:r>
+                      <a:endParaRPr lang="en-US" sz="1100" dirty="0">
+                        <a:latin typeface="Calibri" charset="0"/>
+                        <a:ea typeface="Calibri" charset="0"/>
+                        <a:cs typeface="Calibri" charset="0"/>
+                      </a:endParaRPr>
+                    </a:p>
+                  </a:txBody>
+                  <a:tcPr marL="73152" marR="73152" marT="18288" marB="18288" anchor="ctr">
+                    <a:lnL w="6350" cap="flat" cmpd="sng" algn="ctr">
+                      <a:solidFill>
+                        <a:srgbClr val="EBE7E3"/>
+                      </a:solidFill>
+                      <a:prstDash val="solid"/>
+                      <a:round/>
+                      <a:headEnd type="none" w="med" len="med"/>
+                      <a:tailEnd type="none" w="med" len="med"/>
+                    </a:lnL>
+                    <a:lnR w="6350" cap="flat" cmpd="sng" algn="ctr">
+                      <a:solidFill>
+                        <a:srgbClr val="EBE7E3"/>
+                      </a:solidFill>
+                      <a:prstDash val="solid"/>
+                      <a:round/>
+                      <a:headEnd type="none" w="med" len="med"/>
+                      <a:tailEnd type="none" w="med" len="med"/>
+                    </a:lnR>
+                    <a:lnT w="6350" cap="flat" cmpd="sng" algn="ctr">
+                      <a:solidFill>
+                        <a:srgbClr val="EBE7E3"/>
+                      </a:solidFill>
+                      <a:prstDash val="solid"/>
+                      <a:round/>
+                      <a:headEnd type="none" w="med" len="med"/>
+                      <a:tailEnd type="none" w="med" len="med"/>
+                    </a:lnT>
+                    <a:lnB w="6350" cap="flat" cmpd="sng" algn="ctr">
+                      <a:solidFill>
+                        <a:srgbClr val="EBE7E3"/>
+                      </a:solidFill>
+                      <a:prstDash val="solid"/>
+                      <a:round/>
+                      <a:headEnd type="none" w="med" len="med"/>
+                      <a:tailEnd type="none" w="med" len="med"/>
+                    </a:lnB>
+                    <a:solidFill>
+                      <a:srgbClr val="E4E6C3"/>
+                    </a:solidFill>
+                  </a:tcPr>
+                </a:tc>
+                <a:tc>
+                  <a:txBody>
+                    <a:bodyPr/>
+                    <a:lstStyle/>
+                    <a:p>
+                      <a:pPr algn="ctr" indent="0" marL="0">
+                        <a:buNone/>
+                      </a:pPr>
+                      <a:r>
+                        <a:rPr lang="en-US" sz="1100" b="1" dirty="0">
+                          <a:solidFill>
+                            <a:srgbClr val="545814"/>
+                          </a:solidFill>
+                          <a:latin typeface="Calibri" pitchFamily="34" charset="0"/>
+                          <a:ea typeface="Calibri" pitchFamily="34" charset="-122"/>
+                          <a:cs typeface="Calibri" pitchFamily="34" charset="-120"/>
+                        </a:rPr>
+                        <a:t>✓ Sim</a:t>
+                      </a:r>
+                      <a:endParaRPr lang="en-US" sz="1100" dirty="0">
+                        <a:latin typeface="Calibri" charset="0"/>
+                        <a:ea typeface="Calibri" charset="0"/>
+                        <a:cs typeface="Calibri" charset="0"/>
+                      </a:endParaRPr>
+                    </a:p>
+                  </a:txBody>
+                  <a:tcPr marL="73152" marR="73152" marT="18288" marB="18288" anchor="ctr">
+                    <a:lnL w="6350" cap="flat" cmpd="sng" algn="ctr">
+                      <a:solidFill>
+                        <a:srgbClr val="EBE7E3"/>
+                      </a:solidFill>
+                      <a:prstDash val="solid"/>
+                      <a:round/>
+                      <a:headEnd type="none" w="med" len="med"/>
+                      <a:tailEnd type="none" w="med" len="med"/>
+                    </a:lnL>
+                    <a:lnR w="6350" cap="flat" cmpd="sng" algn="ctr">
+                      <a:solidFill>
+                        <a:srgbClr val="EBE7E3"/>
+                      </a:solidFill>
+                      <a:prstDash val="solid"/>
+                      <a:round/>
+                      <a:headEnd type="none" w="med" len="med"/>
+                      <a:tailEnd type="none" w="med" len="med"/>
+                    </a:lnR>
+                    <a:lnT w="6350" cap="flat" cmpd="sng" algn="ctr">
+                      <a:solidFill>
+                        <a:srgbClr val="EBE7E3"/>
+                      </a:solidFill>
+                      <a:prstDash val="solid"/>
+                      <a:round/>
+                      <a:headEnd type="none" w="med" len="med"/>
+                      <a:tailEnd type="none" w="med" len="med"/>
+                    </a:lnT>
+                    <a:lnB w="6350" cap="flat" cmpd="sng" algn="ctr">
+                      <a:solidFill>
+                        <a:srgbClr val="EBE7E3"/>
+                      </a:solidFill>
+                      <a:prstDash val="solid"/>
+                      <a:round/>
+                      <a:headEnd type="none" w="med" len="med"/>
+                      <a:tailEnd type="none" w="med" len="med"/>
+                    </a:lnB>
+                    <a:solidFill>
+                      <a:srgbClr val="E4E6C3"/>
+                    </a:solidFill>
+                  </a:tcPr>
+                </a:tc>
+                <a:tc>
+                  <a:txBody>
+                    <a:bodyPr/>
+                    <a:lstStyle/>
+                    <a:p>
+                      <a:pPr algn="ctr" indent="0" marL="0">
+                        <a:buNone/>
+                      </a:pPr>
+                      <a:r>
+                        <a:rPr lang="en-US" sz="1100" b="1" dirty="0">
+                          <a:solidFill>
+                            <a:srgbClr val="545814"/>
+                          </a:solidFill>
+                          <a:latin typeface="Calibri" pitchFamily="34" charset="0"/>
+                          <a:ea typeface="Calibri" pitchFamily="34" charset="-122"/>
+                          <a:cs typeface="Calibri" pitchFamily="34" charset="-120"/>
+                        </a:rPr>
+                        <a:t>✓ Sim</a:t>
+                      </a:r>
+                      <a:endParaRPr lang="en-US" sz="1100" dirty="0">
+                        <a:latin typeface="Calibri" charset="0"/>
+                        <a:ea typeface="Calibri" charset="0"/>
+                        <a:cs typeface="Calibri" charset="0"/>
+                      </a:endParaRPr>
+                    </a:p>
+                  </a:txBody>
+                  <a:tcPr marL="73152" marR="73152" marT="18288" marB="18288" anchor="ctr">
+                    <a:lnL w="6350" cap="flat" cmpd="sng" algn="ctr">
+                      <a:solidFill>
+                        <a:srgbClr val="EBE7E3"/>
+                      </a:solidFill>
+                      <a:prstDash val="solid"/>
+                      <a:round/>
+                      <a:headEnd type="none" w="med" len="med"/>
+                      <a:tailEnd type="none" w="med" len="med"/>
+                    </a:lnL>
+                    <a:lnR w="6350" cap="flat" cmpd="sng" algn="ctr">
+                      <a:solidFill>
+                        <a:srgbClr val="EBE7E3"/>
+                      </a:solidFill>
+                      <a:prstDash val="solid"/>
+                      <a:round/>
+                      <a:headEnd type="none" w="med" len="med"/>
+                      <a:tailEnd type="none" w="med" len="med"/>
+                    </a:lnR>
+                    <a:lnT w="6350" cap="flat" cmpd="sng" algn="ctr">
+                      <a:solidFill>
+                        <a:srgbClr val="EBE7E3"/>
+                      </a:solidFill>
+                      <a:prstDash val="solid"/>
+                      <a:round/>
+                      <a:headEnd type="none" w="med" len="med"/>
+                      <a:tailEnd type="none" w="med" len="med"/>
+                    </a:lnT>
+                    <a:lnB w="6350" cap="flat" cmpd="sng" algn="ctr">
+                      <a:solidFill>
+                        <a:srgbClr val="EBE7E3"/>
+                      </a:solidFill>
+                      <a:prstDash val="solid"/>
+                      <a:round/>
+                      <a:headEnd type="none" w="med" len="med"/>
+                      <a:tailEnd type="none" w="med" len="med"/>
+                    </a:lnB>
+                    <a:solidFill>
+                      <a:srgbClr val="E4E6C3"/>
+                    </a:solidFill>
+                  </a:tcPr>
+                </a:tc>
+              </a:tr>
+              <a:tr h="347472">
+                <a:tc>
+                  <a:txBody>
+                    <a:bodyPr/>
+                    <a:lstStyle/>
+                    <a:p>
+                      <a:pPr indent="0" marL="0">
+                        <a:buNone/>
+                      </a:pPr>
+                      <a:r>
+                        <a:rPr lang="en-US" sz="1200" dirty="0">
+                          <a:solidFill>
+                            <a:srgbClr val="2B1E1C"/>
+                          </a:solidFill>
+                          <a:latin typeface="Calibri" pitchFamily="34" charset="0"/>
+                          <a:ea typeface="Calibri" pitchFamily="34" charset="-122"/>
+                          <a:cs typeface="Calibri" pitchFamily="34" charset="-120"/>
+                        </a:rPr>
+                        <a:t>Conferir leituras e pedir nova foto</a:t>
+                      </a:r>
+                      <a:endParaRPr lang="en-US" sz="1200" dirty="0">
+                        <a:latin typeface="Calibri" charset="0"/>
+                        <a:ea typeface="Calibri" charset="0"/>
+                        <a:cs typeface="Calibri" charset="0"/>
+                      </a:endParaRPr>
+                    </a:p>
+                  </a:txBody>
+                  <a:tcPr marL="73152" marR="73152" marT="18288" marB="18288" anchor="ctr">
+                    <a:lnL w="6350" cap="flat" cmpd="sng" algn="ctr">
+                      <a:solidFill>
+                        <a:srgbClr val="EBE7E3"/>
+                      </a:solidFill>
+                      <a:prstDash val="solid"/>
+                      <a:round/>
+                      <a:headEnd type="none" w="med" len="med"/>
+                      <a:tailEnd type="none" w="med" len="med"/>
+                    </a:lnL>
+                    <a:lnR w="6350" cap="flat" cmpd="sng" algn="ctr">
+                      <a:solidFill>
+                        <a:srgbClr val="EBE7E3"/>
+                      </a:solidFill>
+                      <a:prstDash val="solid"/>
+                      <a:round/>
+                      <a:headEnd type="none" w="med" len="med"/>
+                      <a:tailEnd type="none" w="med" len="med"/>
+                    </a:lnR>
+                    <a:lnT w="6350" cap="flat" cmpd="sng" algn="ctr">
+                      <a:solidFill>
+                        <a:srgbClr val="EBE7E3"/>
+                      </a:solidFill>
+                      <a:prstDash val="solid"/>
+                      <a:round/>
+                      <a:headEnd type="none" w="med" len="med"/>
+                      <a:tailEnd type="none" w="med" len="med"/>
+                    </a:lnT>
+                    <a:lnB w="6350" cap="flat" cmpd="sng" algn="ctr">
+                      <a:solidFill>
+                        <a:srgbClr val="EBE7E3"/>
+                      </a:solidFill>
+                      <a:prstDash val="solid"/>
+                      <a:round/>
+                      <a:headEnd type="none" w="med" len="med"/>
+                      <a:tailEnd type="none" w="med" len="med"/>
+                    </a:lnB>
+                  </a:tcPr>
+                </a:tc>
+                <a:tc>
+                  <a:txBody>
+                    <a:bodyPr/>
+                    <a:lstStyle/>
+                    <a:p>
+                      <a:pPr algn="ctr" indent="0" marL="0">
+                        <a:buNone/>
+                      </a:pPr>
+                      <a:r>
+                        <a:rPr lang="en-US" sz="1100" b="1" dirty="0">
+                          <a:solidFill>
+                            <a:srgbClr val="545814"/>
+                          </a:solidFill>
+                          <a:latin typeface="Calibri" pitchFamily="34" charset="0"/>
+                          <a:ea typeface="Calibri" pitchFamily="34" charset="-122"/>
+                          <a:cs typeface="Calibri" pitchFamily="34" charset="-120"/>
+                        </a:rPr>
+                        <a:t>✓ Sim</a:t>
+                      </a:r>
+                      <a:endParaRPr lang="en-US" sz="1100" dirty="0">
+                        <a:latin typeface="Calibri" charset="0"/>
+                        <a:ea typeface="Calibri" charset="0"/>
+                        <a:cs typeface="Calibri" charset="0"/>
+                      </a:endParaRPr>
+                    </a:p>
+                  </a:txBody>
+                  <a:tcPr marL="73152" marR="73152" marT="18288" marB="18288" anchor="ctr">
+                    <a:lnL w="6350" cap="flat" cmpd="sng" algn="ctr">
+                      <a:solidFill>
+                        <a:srgbClr val="EBE7E3"/>
+                      </a:solidFill>
+                      <a:prstDash val="solid"/>
+                      <a:round/>
+                      <a:headEnd type="none" w="med" len="med"/>
+                      <a:tailEnd type="none" w="med" len="med"/>
+                    </a:lnL>
+                    <a:lnR w="6350" cap="flat" cmpd="sng" algn="ctr">
+                      <a:solidFill>
+                        <a:srgbClr val="EBE7E3"/>
+                      </a:solidFill>
+                      <a:prstDash val="solid"/>
+                      <a:round/>
+                      <a:headEnd type="none" w="med" len="med"/>
+                      <a:tailEnd type="none" w="med" len="med"/>
+                    </a:lnR>
+                    <a:lnT w="6350" cap="flat" cmpd="sng" algn="ctr">
+                      <a:solidFill>
+                        <a:srgbClr val="EBE7E3"/>
+                      </a:solidFill>
+                      <a:prstDash val="solid"/>
+                      <a:round/>
+                      <a:headEnd type="none" w="med" len="med"/>
+                      <a:tailEnd type="none" w="med" len="med"/>
+                    </a:lnT>
+                    <a:lnB w="6350" cap="flat" cmpd="sng" algn="ctr">
+                      <a:solidFill>
+                        <a:srgbClr val="EBE7E3"/>
+                      </a:solidFill>
+                      <a:prstDash val="solid"/>
+                      <a:round/>
+                      <a:headEnd type="none" w="med" len="med"/>
+                      <a:tailEnd type="none" w="med" len="med"/>
+                    </a:lnB>
+                    <a:solidFill>
+                      <a:srgbClr val="E4E6C3"/>
+                    </a:solidFill>
+                  </a:tcPr>
+                </a:tc>
+                <a:tc>
+                  <a:txBody>
+                    <a:bodyPr/>
+                    <a:lstStyle/>
+                    <a:p>
+                      <a:pPr algn="ctr" indent="0" marL="0">
+                        <a:buNone/>
+                      </a:pPr>
+                      <a:r>
+                        <a:rPr lang="en-US" sz="1100" b="1" dirty="0">
+                          <a:solidFill>
+                            <a:srgbClr val="6B4E00"/>
+                          </a:solidFill>
+                          <a:latin typeface="Calibri" pitchFamily="34" charset="0"/>
+                          <a:ea typeface="Calibri" pitchFamily="34" charset="-122"/>
+                          <a:cs typeface="Calibri" pitchFamily="34" charset="-120"/>
+                        </a:rPr>
+                        <a:t>◐ Se configurado</a:t>
+                      </a:r>
+                      <a:endParaRPr lang="en-US" sz="1100" dirty="0">
+                        <a:latin typeface="Calibri" charset="0"/>
+                        <a:ea typeface="Calibri" charset="0"/>
+                        <a:cs typeface="Calibri" charset="0"/>
+                      </a:endParaRPr>
+                    </a:p>
+                  </a:txBody>
+                  <a:tcPr marL="73152" marR="73152" marT="18288" marB="18288" anchor="ctr">
+                    <a:lnL w="6350" cap="flat" cmpd="sng" algn="ctr">
+                      <a:solidFill>
+                        <a:srgbClr val="EBE7E3"/>
+                      </a:solidFill>
+                      <a:prstDash val="solid"/>
+                      <a:round/>
+                      <a:headEnd type="none" w="med" len="med"/>
+                      <a:tailEnd type="none" w="med" len="med"/>
+                    </a:lnL>
+                    <a:lnR w="6350" cap="flat" cmpd="sng" algn="ctr">
+                      <a:solidFill>
+                        <a:srgbClr val="EBE7E3"/>
+                      </a:solidFill>
+                      <a:prstDash val="solid"/>
+                      <a:round/>
+                      <a:headEnd type="none" w="med" len="med"/>
+                      <a:tailEnd type="none" w="med" len="med"/>
+                    </a:lnR>
+                    <a:lnT w="6350" cap="flat" cmpd="sng" algn="ctr">
+                      <a:solidFill>
+                        <a:srgbClr val="EBE7E3"/>
+                      </a:solidFill>
+                      <a:prstDash val="solid"/>
+                      <a:round/>
+                      <a:headEnd type="none" w="med" len="med"/>
+                      <a:tailEnd type="none" w="med" len="med"/>
+                    </a:lnT>
+                    <a:lnB w="6350" cap="flat" cmpd="sng" algn="ctr">
+                      <a:solidFill>
+                        <a:srgbClr val="EBE7E3"/>
+                      </a:solidFill>
+                      <a:prstDash val="solid"/>
+                      <a:round/>
+                      <a:headEnd type="none" w="med" len="med"/>
+                      <a:tailEnd type="none" w="med" len="med"/>
+                    </a:lnB>
+                    <a:solidFill>
+                      <a:srgbClr val="FBEBC0"/>
+                    </a:solidFill>
+                  </a:tcPr>
+                </a:tc>
+                <a:tc>
+                  <a:txBody>
+                    <a:bodyPr/>
+                    <a:lstStyle/>
+                    <a:p>
+                      <a:pPr algn="ctr" indent="0" marL="0">
+                        <a:buNone/>
+                      </a:pPr>
+                      <a:r>
+                        <a:rPr lang="en-US" sz="1100" b="1" dirty="0">
+                          <a:solidFill>
+                            <a:srgbClr val="6B4E00"/>
+                          </a:solidFill>
+                          <a:latin typeface="Calibri" pitchFamily="34" charset="0"/>
+                          <a:ea typeface="Calibri" pitchFamily="34" charset="-122"/>
+                          <a:cs typeface="Calibri" pitchFamily="34" charset="-120"/>
+                        </a:rPr>
+                        <a:t>◐ Se configurado</a:t>
+                      </a:r>
+                      <a:endParaRPr lang="en-US" sz="1100" dirty="0">
+                        <a:latin typeface="Calibri" charset="0"/>
+                        <a:ea typeface="Calibri" charset="0"/>
+                        <a:cs typeface="Calibri" charset="0"/>
+                      </a:endParaRPr>
+                    </a:p>
+                  </a:txBody>
+                  <a:tcPr marL="73152" marR="73152" marT="18288" marB="18288" anchor="ctr">
+                    <a:lnL w="6350" cap="flat" cmpd="sng" algn="ctr">
+                      <a:solidFill>
+                        <a:srgbClr val="EBE7E3"/>
+                      </a:solidFill>
+                      <a:prstDash val="solid"/>
+                      <a:round/>
+                      <a:headEnd type="none" w="med" len="med"/>
+                      <a:tailEnd type="none" w="med" len="med"/>
+                    </a:lnL>
+                    <a:lnR w="6350" cap="flat" cmpd="sng" algn="ctr">
+                      <a:solidFill>
+                        <a:srgbClr val="EBE7E3"/>
+                      </a:solidFill>
+                      <a:prstDash val="solid"/>
+                      <a:round/>
+                      <a:headEnd type="none" w="med" len="med"/>
+                      <a:tailEnd type="none" w="med" len="med"/>
+                    </a:lnR>
+                    <a:lnT w="6350" cap="flat" cmpd="sng" algn="ctr">
+                      <a:solidFill>
+                        <a:srgbClr val="EBE7E3"/>
+                      </a:solidFill>
+                      <a:prstDash val="solid"/>
+                      <a:round/>
+                      <a:headEnd type="none" w="med" len="med"/>
+                      <a:tailEnd type="none" w="med" len="med"/>
+                    </a:lnT>
+                    <a:lnB w="6350" cap="flat" cmpd="sng" algn="ctr">
+                      <a:solidFill>
+                        <a:srgbClr val="EBE7E3"/>
+                      </a:solidFill>
+                      <a:prstDash val="solid"/>
+                      <a:round/>
+                      <a:headEnd type="none" w="med" len="med"/>
+                      <a:tailEnd type="none" w="med" len="med"/>
+                    </a:lnB>
+                    <a:solidFill>
+                      <a:srgbClr val="FBEBC0"/>
+                    </a:solidFill>
+                  </a:tcPr>
+                </a:tc>
+                <a:tc>
+                  <a:txBody>
+                    <a:bodyPr/>
+                    <a:lstStyle/>
+                    <a:p>
+                      <a:pPr algn="ctr" indent="0" marL="0">
+                        <a:buNone/>
+                      </a:pPr>
+                      <a:r>
+                        <a:rPr lang="en-US" sz="1100" b="1" dirty="0">
+                          <a:solidFill>
+                            <a:srgbClr val="6B4E00"/>
+                          </a:solidFill>
+                          <a:latin typeface="Calibri" pitchFamily="34" charset="0"/>
+                          <a:ea typeface="Calibri" pitchFamily="34" charset="-122"/>
+                          <a:cs typeface="Calibri" pitchFamily="34" charset="-120"/>
+                        </a:rPr>
+                        <a:t>◐ Se configurado</a:t>
+                      </a:r>
+                      <a:endParaRPr lang="en-US" sz="1100" dirty="0">
+                        <a:latin typeface="Calibri" charset="0"/>
+                        <a:ea typeface="Calibri" charset="0"/>
+                        <a:cs typeface="Calibri" charset="0"/>
+                      </a:endParaRPr>
+                    </a:p>
+                  </a:txBody>
+                  <a:tcPr marL="73152" marR="73152" marT="18288" marB="18288" anchor="ctr">
+                    <a:lnL w="6350" cap="flat" cmpd="sng" algn="ctr">
+                      <a:solidFill>
+                        <a:srgbClr val="EBE7E3"/>
+                      </a:solidFill>
+                      <a:prstDash val="solid"/>
+                      <a:round/>
+                      <a:headEnd type="none" w="med" len="med"/>
+                      <a:tailEnd type="none" w="med" len="med"/>
+                    </a:lnL>
+                    <a:lnR w="6350" cap="flat" cmpd="sng" algn="ctr">
+                      <a:solidFill>
+                        <a:srgbClr val="EBE7E3"/>
+                      </a:solidFill>
+                      <a:prstDash val="solid"/>
+                      <a:round/>
+                      <a:headEnd type="none" w="med" len="med"/>
+                      <a:tailEnd type="none" w="med" len="med"/>
+                    </a:lnR>
+                    <a:lnT w="6350" cap="flat" cmpd="sng" algn="ctr">
+                      <a:solidFill>
+                        <a:srgbClr val="EBE7E3"/>
+                      </a:solidFill>
+                      <a:prstDash val="solid"/>
+                      <a:round/>
+                      <a:headEnd type="none" w="med" len="med"/>
+                      <a:tailEnd type="none" w="med" len="med"/>
+                    </a:lnT>
+                    <a:lnB w="6350" cap="flat" cmpd="sng" algn="ctr">
+                      <a:solidFill>
+                        <a:srgbClr val="EBE7E3"/>
+                      </a:solidFill>
+                      <a:prstDash val="solid"/>
+                      <a:round/>
+                      <a:headEnd type="none" w="med" len="med"/>
+                      <a:tailEnd type="none" w="med" len="med"/>
+                    </a:lnB>
+                    <a:solidFill>
+                      <a:srgbClr val="FBEBC0"/>
+                    </a:solidFill>
+                  </a:tcPr>
+                </a:tc>
+                <a:tc>
+                  <a:txBody>
+                    <a:bodyPr/>
+                    <a:lstStyle/>
+                    <a:p>
+                      <a:pPr algn="ctr" indent="0" marL="0">
+                        <a:buNone/>
+                      </a:pPr>
+                      <a:r>
+                        <a:rPr lang="en-US" sz="1100" b="1" dirty="0">
+                          <a:solidFill>
+                            <a:srgbClr val="545814"/>
+                          </a:solidFill>
+                          <a:latin typeface="Calibri" pitchFamily="34" charset="0"/>
+                          <a:ea typeface="Calibri" pitchFamily="34" charset="-122"/>
+                          <a:cs typeface="Calibri" pitchFamily="34" charset="-120"/>
+                        </a:rPr>
+                        <a:t>✓ Sim</a:t>
+                      </a:r>
+                      <a:endParaRPr lang="en-US" sz="1100" dirty="0">
+                        <a:latin typeface="Calibri" charset="0"/>
+                        <a:ea typeface="Calibri" charset="0"/>
+                        <a:cs typeface="Calibri" charset="0"/>
+                      </a:endParaRPr>
+                    </a:p>
+                  </a:txBody>
+                  <a:tcPr marL="73152" marR="73152" marT="18288" marB="18288" anchor="ctr">
+                    <a:lnL w="6350" cap="flat" cmpd="sng" algn="ctr">
+                      <a:solidFill>
+                        <a:srgbClr val="EBE7E3"/>
+                      </a:solidFill>
+                      <a:prstDash val="solid"/>
+                      <a:round/>
+                      <a:headEnd type="none" w="med" len="med"/>
+                      <a:tailEnd type="none" w="med" len="med"/>
+                    </a:lnL>
+                    <a:lnR w="6350" cap="flat" cmpd="sng" algn="ctr">
+                      <a:solidFill>
+                        <a:srgbClr val="EBE7E3"/>
+                      </a:solidFill>
+                      <a:prstDash val="solid"/>
+                      <a:round/>
+                      <a:headEnd type="none" w="med" len="med"/>
+                      <a:tailEnd type="none" w="med" len="med"/>
+                    </a:lnR>
+                    <a:lnT w="6350" cap="flat" cmpd="sng" algn="ctr">
+                      <a:solidFill>
+                        <a:srgbClr val="EBE7E3"/>
+                      </a:solidFill>
+                      <a:prstDash val="solid"/>
+                      <a:round/>
+                      <a:headEnd type="none" w="med" len="med"/>
+                      <a:tailEnd type="none" w="med" len="med"/>
+                    </a:lnT>
+                    <a:lnB w="6350" cap="flat" cmpd="sng" algn="ctr">
+                      <a:solidFill>
+                        <a:srgbClr val="EBE7E3"/>
+                      </a:solidFill>
+                      <a:prstDash val="solid"/>
+                      <a:round/>
+                      <a:headEnd type="none" w="med" len="med"/>
+                      <a:tailEnd type="none" w="med" len="med"/>
+                    </a:lnB>
+                    <a:solidFill>
+                      <a:srgbClr val="E4E6C3"/>
+                    </a:solidFill>
+                  </a:tcPr>
+                </a:tc>
+                <a:tc>
+                  <a:txBody>
+                    <a:bodyPr/>
+                    <a:lstStyle/>
+                    <a:p>
+                      <a:pPr algn="ctr" indent="0" marL="0">
+                        <a:buNone/>
+                      </a:pPr>
+                      <a:r>
+                        <a:rPr lang="en-US" sz="1100" b="1" dirty="0">
+                          <a:solidFill>
+                            <a:srgbClr val="545814"/>
+                          </a:solidFill>
+                          <a:latin typeface="Calibri" pitchFamily="34" charset="0"/>
+                          <a:ea typeface="Calibri" pitchFamily="34" charset="-122"/>
+                          <a:cs typeface="Calibri" pitchFamily="34" charset="-120"/>
+                        </a:rPr>
+                        <a:t>✓ Sim</a:t>
+                      </a:r>
+                      <a:endParaRPr lang="en-US" sz="1100" dirty="0">
+                        <a:latin typeface="Calibri" charset="0"/>
+                        <a:ea typeface="Calibri" charset="0"/>
+                        <a:cs typeface="Calibri" charset="0"/>
+                      </a:endParaRPr>
+                    </a:p>
+                  </a:txBody>
+                  <a:tcPr marL="73152" marR="73152" marT="18288" marB="18288" anchor="ctr">
+                    <a:lnL w="6350" cap="flat" cmpd="sng" algn="ctr">
+                      <a:solidFill>
+                        <a:srgbClr val="EBE7E3"/>
+                      </a:solidFill>
+                      <a:prstDash val="solid"/>
+                      <a:round/>
+                      <a:headEnd type="none" w="med" len="med"/>
+                      <a:tailEnd type="none" w="med" len="med"/>
+                    </a:lnL>
+                    <a:lnR w="6350" cap="flat" cmpd="sng" algn="ctr">
+                      <a:solidFill>
+                        <a:srgbClr val="EBE7E3"/>
+                      </a:solidFill>
+                      <a:prstDash val="solid"/>
+                      <a:round/>
+                      <a:headEnd type="none" w="med" len="med"/>
+                      <a:tailEnd type="none" w="med" len="med"/>
+                    </a:lnR>
+                    <a:lnT w="6350" cap="flat" cmpd="sng" algn="ctr">
+                      <a:solidFill>
+                        <a:srgbClr val="EBE7E3"/>
+                      </a:solidFill>
+                      <a:prstDash val="solid"/>
+                      <a:round/>
+                      <a:headEnd type="none" w="med" len="med"/>
+                      <a:tailEnd type="none" w="med" len="med"/>
+                    </a:lnT>
+                    <a:lnB w="6350" cap="flat" cmpd="sng" algn="ctr">
+                      <a:solidFill>
+                        <a:srgbClr val="EBE7E3"/>
+                      </a:solidFill>
+                      <a:prstDash val="solid"/>
+                      <a:round/>
+                      <a:headEnd type="none" w="med" len="med"/>
+                      <a:tailEnd type="none" w="med" len="med"/>
+                    </a:lnB>
+                    <a:solidFill>
+                      <a:srgbClr val="E4E6C3"/>
+                    </a:solidFill>
+                  </a:tcPr>
+                </a:tc>
+              </a:tr>
+              <a:tr h="347472">
+                <a:tc>
+                  <a:txBody>
+                    <a:bodyPr/>
+                    <a:lstStyle/>
+                    <a:p>
+                      <a:pPr indent="0" marL="0">
+                        <a:buNone/>
+                      </a:pPr>
+                      <a:r>
+                        <a:rPr lang="en-US" sz="1200" dirty="0">
+                          <a:solidFill>
+                            <a:srgbClr val="2B1E1C"/>
+                          </a:solidFill>
+                          <a:latin typeface="Calibri" pitchFamily="34" charset="0"/>
+                          <a:ea typeface="Calibri" pitchFamily="34" charset="-122"/>
+                          <a:cs typeface="Calibri" pitchFamily="34" charset="-120"/>
+                        </a:rPr>
+                        <a:t>Calcular a água e exportar para o boleto</a:t>
+                      </a:r>
+                      <a:endParaRPr lang="en-US" sz="1200" dirty="0">
+                        <a:latin typeface="Calibri" charset="0"/>
+                        <a:ea typeface="Calibri" charset="0"/>
+                        <a:cs typeface="Calibri" charset="0"/>
+                      </a:endParaRPr>
+                    </a:p>
+                  </a:txBody>
+                  <a:tcPr marL="73152" marR="73152" marT="18288" marB="18288" anchor="ctr">
+                    <a:lnL w="6350" cap="flat" cmpd="sng" algn="ctr">
+                      <a:solidFill>
+                        <a:srgbClr val="EBE7E3"/>
+                      </a:solidFill>
+                      <a:prstDash val="solid"/>
+                      <a:round/>
+                      <a:headEnd type="none" w="med" len="med"/>
+                      <a:tailEnd type="none" w="med" len="med"/>
+                    </a:lnL>
+                    <a:lnR w="6350" cap="flat" cmpd="sng" algn="ctr">
+                      <a:solidFill>
+                        <a:srgbClr val="EBE7E3"/>
+                      </a:solidFill>
+                      <a:prstDash val="solid"/>
+                      <a:round/>
+                      <a:headEnd type="none" w="med" len="med"/>
+                      <a:tailEnd type="none" w="med" len="med"/>
+                    </a:lnR>
+                    <a:lnT w="6350" cap="flat" cmpd="sng" algn="ctr">
+                      <a:solidFill>
+                        <a:srgbClr val="EBE7E3"/>
+                      </a:solidFill>
+                      <a:prstDash val="solid"/>
+                      <a:round/>
+                      <a:headEnd type="none" w="med" len="med"/>
+                      <a:tailEnd type="none" w="med" len="med"/>
+                    </a:lnT>
+                    <a:lnB w="6350" cap="flat" cmpd="sng" algn="ctr">
+                      <a:solidFill>
+                        <a:srgbClr val="EBE7E3"/>
+                      </a:solidFill>
+                      <a:prstDash val="solid"/>
+                      <a:round/>
+                      <a:headEnd type="none" w="med" len="med"/>
+                      <a:tailEnd type="none" w="med" len="med"/>
+                    </a:lnB>
+                  </a:tcPr>
+                </a:tc>
+                <a:tc>
+                  <a:txBody>
+                    <a:bodyPr/>
+                    <a:lstStyle/>
+                    <a:p>
+                      <a:pPr algn="ctr" indent="0" marL="0">
+                        <a:buNone/>
+                      </a:pPr>
+                      <a:r>
+                        <a:rPr lang="en-US" sz="1100" b="1" dirty="0">
+                          <a:solidFill>
+                            <a:srgbClr val="545814"/>
+                          </a:solidFill>
+                          <a:latin typeface="Calibri" pitchFamily="34" charset="0"/>
+                          <a:ea typeface="Calibri" pitchFamily="34" charset="-122"/>
+                          <a:cs typeface="Calibri" pitchFamily="34" charset="-120"/>
+                        </a:rPr>
+                        <a:t>✓ Sim</a:t>
+                      </a:r>
+                      <a:endParaRPr lang="en-US" sz="1100" dirty="0">
+                        <a:latin typeface="Calibri" charset="0"/>
+                        <a:ea typeface="Calibri" charset="0"/>
+                        <a:cs typeface="Calibri" charset="0"/>
+                      </a:endParaRPr>
+                    </a:p>
+                  </a:txBody>
+                  <a:tcPr marL="73152" marR="73152" marT="18288" marB="18288" anchor="ctr">
+                    <a:lnL w="6350" cap="flat" cmpd="sng" algn="ctr">
+                      <a:solidFill>
+                        <a:srgbClr val="EBE7E3"/>
+                      </a:solidFill>
+                      <a:prstDash val="solid"/>
+                      <a:round/>
+                      <a:headEnd type="none" w="med" len="med"/>
+                      <a:tailEnd type="none" w="med" len="med"/>
+                    </a:lnL>
+                    <a:lnR w="6350" cap="flat" cmpd="sng" algn="ctr">
+                      <a:solidFill>
+                        <a:srgbClr val="EBE7E3"/>
+                      </a:solidFill>
+                      <a:prstDash val="solid"/>
+                      <a:round/>
+                      <a:headEnd type="none" w="med" len="med"/>
+                      <a:tailEnd type="none" w="med" len="med"/>
+                    </a:lnR>
+                    <a:lnT w="6350" cap="flat" cmpd="sng" algn="ctr">
+                      <a:solidFill>
+                        <a:srgbClr val="EBE7E3"/>
+                      </a:solidFill>
+                      <a:prstDash val="solid"/>
+                      <a:round/>
+                      <a:headEnd type="none" w="med" len="med"/>
+                      <a:tailEnd type="none" w="med" len="med"/>
+                    </a:lnT>
+                    <a:lnB w="6350" cap="flat" cmpd="sng" algn="ctr">
+                      <a:solidFill>
+                        <a:srgbClr val="EBE7E3"/>
+                      </a:solidFill>
+                      <a:prstDash val="solid"/>
+                      <a:round/>
+                      <a:headEnd type="none" w="med" len="med"/>
+                      <a:tailEnd type="none" w="med" len="med"/>
+                    </a:lnB>
+                    <a:solidFill>
+                      <a:srgbClr val="E4E6C3"/>
+                    </a:solidFill>
+                  </a:tcPr>
+                </a:tc>
+                <a:tc>
+                  <a:txBody>
+                    <a:bodyPr/>
+                    <a:lstStyle/>
+                    <a:p>
+                      <a:pPr algn="ctr" indent="0" marL="0">
+                        <a:buNone/>
+                      </a:pPr>
+                      <a:r>
+                        <a:rPr lang="en-US" sz="1100" b="1" dirty="0">
+                          <a:solidFill>
+                            <a:srgbClr val="6B4E00"/>
+                          </a:solidFill>
+                          <a:latin typeface="Calibri" pitchFamily="34" charset="0"/>
+                          <a:ea typeface="Calibri" pitchFamily="34" charset="-122"/>
+                          <a:cs typeface="Calibri" pitchFamily="34" charset="-120"/>
+                        </a:rPr>
+                        <a:t>◐ Se configurado</a:t>
+                      </a:r>
+                      <a:endParaRPr lang="en-US" sz="1100" dirty="0">
+                        <a:latin typeface="Calibri" charset="0"/>
+                        <a:ea typeface="Calibri" charset="0"/>
+                        <a:cs typeface="Calibri" charset="0"/>
+                      </a:endParaRPr>
+                    </a:p>
+                  </a:txBody>
+                  <a:tcPr marL="73152" marR="73152" marT="18288" marB="18288" anchor="ctr">
+                    <a:lnL w="6350" cap="flat" cmpd="sng" algn="ctr">
+                      <a:solidFill>
+                        <a:srgbClr val="EBE7E3"/>
+                      </a:solidFill>
+                      <a:prstDash val="solid"/>
+                      <a:round/>
+                      <a:headEnd type="none" w="med" len="med"/>
+                      <a:tailEnd type="none" w="med" len="med"/>
+                    </a:lnL>
+                    <a:lnR w="6350" cap="flat" cmpd="sng" algn="ctr">
+                      <a:solidFill>
+                        <a:srgbClr val="EBE7E3"/>
+                      </a:solidFill>
+                      <a:prstDash val="solid"/>
+                      <a:round/>
+                      <a:headEnd type="none" w="med" len="med"/>
+                      <a:tailEnd type="none" w="med" len="med"/>
+                    </a:lnR>
+                    <a:lnT w="6350" cap="flat" cmpd="sng" algn="ctr">
+                      <a:solidFill>
+                        <a:srgbClr val="EBE7E3"/>
+                      </a:solidFill>
+                      <a:prstDash val="solid"/>
+                      <a:round/>
+                      <a:headEnd type="none" w="med" len="med"/>
+                      <a:tailEnd type="none" w="med" len="med"/>
+                    </a:lnT>
+                    <a:lnB w="6350" cap="flat" cmpd="sng" algn="ctr">
+                      <a:solidFill>
+                        <a:srgbClr val="EBE7E3"/>
+                      </a:solidFill>
+                      <a:prstDash val="solid"/>
+                      <a:round/>
+                      <a:headEnd type="none" w="med" len="med"/>
+                      <a:tailEnd type="none" w="med" len="med"/>
+                    </a:lnB>
+                    <a:solidFill>
+                      <a:srgbClr val="FBEBC0"/>
+                    </a:solidFill>
+                  </a:tcPr>
+                </a:tc>
+                <a:tc>
+                  <a:txBody>
+                    <a:bodyPr/>
+                    <a:lstStyle/>
+                    <a:p>
+                      <a:pPr algn="ctr" indent="0" marL="0">
+                        <a:buNone/>
+                      </a:pPr>
+                      <a:r>
+                        <a:rPr lang="en-US" sz="1100" b="1" dirty="0">
+                          <a:solidFill>
+                            <a:srgbClr val="6B4E00"/>
+                          </a:solidFill>
+                          <a:latin typeface="Calibri" pitchFamily="34" charset="0"/>
+                          <a:ea typeface="Calibri" pitchFamily="34" charset="-122"/>
+                          <a:cs typeface="Calibri" pitchFamily="34" charset="-120"/>
+                        </a:rPr>
+                        <a:t>◐ Se configurado</a:t>
+                      </a:r>
+                      <a:endParaRPr lang="en-US" sz="1100" dirty="0">
+                        <a:latin typeface="Calibri" charset="0"/>
+                        <a:ea typeface="Calibri" charset="0"/>
+                        <a:cs typeface="Calibri" charset="0"/>
+                      </a:endParaRPr>
+                    </a:p>
+                  </a:txBody>
+                  <a:tcPr marL="73152" marR="73152" marT="18288" marB="18288" anchor="ctr">
+                    <a:lnL w="6350" cap="flat" cmpd="sng" algn="ctr">
+                      <a:solidFill>
+                        <a:srgbClr val="EBE7E3"/>
+                      </a:solidFill>
+                      <a:prstDash val="solid"/>
+                      <a:round/>
+                      <a:headEnd type="none" w="med" len="med"/>
+                      <a:tailEnd type="none" w="med" len="med"/>
+                    </a:lnL>
+                    <a:lnR w="6350" cap="flat" cmpd="sng" algn="ctr">
+                      <a:solidFill>
+                        <a:srgbClr val="EBE7E3"/>
+                      </a:solidFill>
+                      <a:prstDash val="solid"/>
+                      <a:round/>
+                      <a:headEnd type="none" w="med" len="med"/>
+                      <a:tailEnd type="none" w="med" len="med"/>
+                    </a:lnR>
+                    <a:lnT w="6350" cap="flat" cmpd="sng" algn="ctr">
+                      <a:solidFill>
+                        <a:srgbClr val="EBE7E3"/>
+                      </a:solidFill>
+                      <a:prstDash val="solid"/>
+                      <a:round/>
+                      <a:headEnd type="none" w="med" len="med"/>
+                      <a:tailEnd type="none" w="med" len="med"/>
+                    </a:lnT>
+                    <a:lnB w="6350" cap="flat" cmpd="sng" algn="ctr">
+                      <a:solidFill>
+                        <a:srgbClr val="EBE7E3"/>
+                      </a:solidFill>
+                      <a:prstDash val="solid"/>
+                      <a:round/>
+                      <a:headEnd type="none" w="med" len="med"/>
+                      <a:tailEnd type="none" w="med" len="med"/>
+                    </a:lnB>
+                    <a:solidFill>
+                      <a:srgbClr val="FBEBC0"/>
+                    </a:solidFill>
+                  </a:tcPr>
+                </a:tc>
+                <a:tc>
+                  <a:txBody>
+                    <a:bodyPr/>
+                    <a:lstStyle/>
+                    <a:p>
+                      <a:pPr algn="ctr" indent="0" marL="0">
+                        <a:buNone/>
+                      </a:pPr>
+                      <a:r>
+                        <a:rPr lang="en-US" sz="1100" b="1" dirty="0">
+                          <a:solidFill>
+                            <a:srgbClr val="6B4E00"/>
+                          </a:solidFill>
+                          <a:latin typeface="Calibri" pitchFamily="34" charset="0"/>
+                          <a:ea typeface="Calibri" pitchFamily="34" charset="-122"/>
+                          <a:cs typeface="Calibri" pitchFamily="34" charset="-120"/>
+                        </a:rPr>
+                        <a:t>◐ Se configurado</a:t>
+                      </a:r>
+                      <a:endParaRPr lang="en-US" sz="1100" dirty="0">
+                        <a:latin typeface="Calibri" charset="0"/>
+                        <a:ea typeface="Calibri" charset="0"/>
+                        <a:cs typeface="Calibri" charset="0"/>
+                      </a:endParaRPr>
+                    </a:p>
+                  </a:txBody>
+                  <a:tcPr marL="73152" marR="73152" marT="18288" marB="18288" anchor="ctr">
+                    <a:lnL w="6350" cap="flat" cmpd="sng" algn="ctr">
+                      <a:solidFill>
+                        <a:srgbClr val="EBE7E3"/>
+                      </a:solidFill>
+                      <a:prstDash val="solid"/>
+                      <a:round/>
+                      <a:headEnd type="none" w="med" len="med"/>
+                      <a:tailEnd type="none" w="med" len="med"/>
+                    </a:lnL>
+                    <a:lnR w="6350" cap="flat" cmpd="sng" algn="ctr">
+                      <a:solidFill>
+                        <a:srgbClr val="EBE7E3"/>
+                      </a:solidFill>
+                      <a:prstDash val="solid"/>
+                      <a:round/>
+                      <a:headEnd type="none" w="med" len="med"/>
+                      <a:tailEnd type="none" w="med" len="med"/>
+                    </a:lnR>
+                    <a:lnT w="6350" cap="flat" cmpd="sng" algn="ctr">
+                      <a:solidFill>
+                        <a:srgbClr val="EBE7E3"/>
+                      </a:solidFill>
+                      <a:prstDash val="solid"/>
+                      <a:round/>
+                      <a:headEnd type="none" w="med" len="med"/>
+                      <a:tailEnd type="none" w="med" len="med"/>
+                    </a:lnT>
+                    <a:lnB w="6350" cap="flat" cmpd="sng" algn="ctr">
+                      <a:solidFill>
+                        <a:srgbClr val="EBE7E3"/>
+                      </a:solidFill>
+                      <a:prstDash val="solid"/>
+                      <a:round/>
+                      <a:headEnd type="none" w="med" len="med"/>
+                      <a:tailEnd type="none" w="med" len="med"/>
+                    </a:lnB>
+                    <a:solidFill>
+                      <a:srgbClr val="FBEBC0"/>
+                    </a:solidFill>
+                  </a:tcPr>
+                </a:tc>
+                <a:tc>
+                  <a:txBody>
+                    <a:bodyPr/>
+                    <a:lstStyle/>
+                    <a:p>
+                      <a:pPr algn="ctr" indent="0" marL="0">
+                        <a:buNone/>
+                      </a:pPr>
+                      <a:r>
+                        <a:rPr lang="en-US" sz="1100" b="1" dirty="0">
+                          <a:solidFill>
+                            <a:srgbClr val="545814"/>
+                          </a:solidFill>
+                          <a:latin typeface="Calibri" pitchFamily="34" charset="0"/>
+                          <a:ea typeface="Calibri" pitchFamily="34" charset="-122"/>
+                          <a:cs typeface="Calibri" pitchFamily="34" charset="-120"/>
+                        </a:rPr>
+                        <a:t>✓ Sim</a:t>
+                      </a:r>
+                      <a:endParaRPr lang="en-US" sz="1100" dirty="0">
+                        <a:latin typeface="Calibri" charset="0"/>
+                        <a:ea typeface="Calibri" charset="0"/>
+                        <a:cs typeface="Calibri" charset="0"/>
+                      </a:endParaRPr>
+                    </a:p>
+                  </a:txBody>
+                  <a:tcPr marL="73152" marR="73152" marT="18288" marB="18288" anchor="ctr">
+                    <a:lnL w="6350" cap="flat" cmpd="sng" algn="ctr">
+                      <a:solidFill>
+                        <a:srgbClr val="EBE7E3"/>
+                      </a:solidFill>
+                      <a:prstDash val="solid"/>
+                      <a:round/>
+                      <a:headEnd type="none" w="med" len="med"/>
+                      <a:tailEnd type="none" w="med" len="med"/>
+                    </a:lnL>
+                    <a:lnR w="6350" cap="flat" cmpd="sng" algn="ctr">
+                      <a:solidFill>
+                        <a:srgbClr val="EBE7E3"/>
+                      </a:solidFill>
+                      <a:prstDash val="solid"/>
+                      <a:round/>
+                      <a:headEnd type="none" w="med" len="med"/>
+                      <a:tailEnd type="none" w="med" len="med"/>
+                    </a:lnR>
+                    <a:lnT w="6350" cap="flat" cmpd="sng" algn="ctr">
+                      <a:solidFill>
+                        <a:srgbClr val="EBE7E3"/>
+                      </a:solidFill>
+                      <a:prstDash val="solid"/>
+                      <a:round/>
+                      <a:headEnd type="none" w="med" len="med"/>
+                      <a:tailEnd type="none" w="med" len="med"/>
+                    </a:lnT>
+                    <a:lnB w="6350" cap="flat" cmpd="sng" algn="ctr">
+                      <a:solidFill>
+                        <a:srgbClr val="EBE7E3"/>
+                      </a:solidFill>
+                      <a:prstDash val="solid"/>
+                      <a:round/>
+                      <a:headEnd type="none" w="med" len="med"/>
+                      <a:tailEnd type="none" w="med" len="med"/>
+                    </a:lnB>
+                    <a:solidFill>
+                      <a:srgbClr val="E4E6C3"/>
+                    </a:solidFill>
+                  </a:tcPr>
+                </a:tc>
+                <a:tc>
+                  <a:txBody>
+                    <a:bodyPr/>
+                    <a:lstStyle/>
+                    <a:p>
+                      <a:pPr algn="ctr" indent="0" marL="0">
+                        <a:buNone/>
+                      </a:pPr>
+                      <a:r>
+                        <a:rPr lang="en-US" sz="1100" b="1" dirty="0">
+                          <a:solidFill>
+                            <a:srgbClr val="545814"/>
+                          </a:solidFill>
+                          <a:latin typeface="Calibri" pitchFamily="34" charset="0"/>
+                          <a:ea typeface="Calibri" pitchFamily="34" charset="-122"/>
+                          <a:cs typeface="Calibri" pitchFamily="34" charset="-120"/>
+                        </a:rPr>
+                        <a:t>✓ Sim</a:t>
+                      </a:r>
+                      <a:endParaRPr lang="en-US" sz="1100" dirty="0">
+                        <a:latin typeface="Calibri" charset="0"/>
+                        <a:ea typeface="Calibri" charset="0"/>
+                        <a:cs typeface="Calibri" charset="0"/>
+                      </a:endParaRPr>
+                    </a:p>
+                  </a:txBody>
+                  <a:tcPr marL="73152" marR="73152" marT="18288" marB="18288" anchor="ctr">
+                    <a:lnL w="6350" cap="flat" cmpd="sng" algn="ctr">
+                      <a:solidFill>
+                        <a:srgbClr val="EBE7E3"/>
+                      </a:solidFill>
+                      <a:prstDash val="solid"/>
+                      <a:round/>
+                      <a:headEnd type="none" w="med" len="med"/>
+                      <a:tailEnd type="none" w="med" len="med"/>
+                    </a:lnL>
+                    <a:lnR w="6350" cap="flat" cmpd="sng" algn="ctr">
+                      <a:solidFill>
+                        <a:srgbClr val="EBE7E3"/>
+                      </a:solidFill>
+                      <a:prstDash val="solid"/>
+                      <a:round/>
+                      <a:headEnd type="none" w="med" len="med"/>
+                      <a:tailEnd type="none" w="med" len="med"/>
+                    </a:lnR>
+                    <a:lnT w="6350" cap="flat" cmpd="sng" algn="ctr">
+                      <a:solidFill>
+                        <a:srgbClr val="EBE7E3"/>
+                      </a:solidFill>
+                      <a:prstDash val="solid"/>
+                      <a:round/>
+                      <a:headEnd type="none" w="med" len="med"/>
+                      <a:tailEnd type="none" w="med" len="med"/>
+                    </a:lnT>
+                    <a:lnB w="6350" cap="flat" cmpd="sng" algn="ctr">
+                      <a:solidFill>
+                        <a:srgbClr val="EBE7E3"/>
+                      </a:solidFill>
+                      <a:prstDash val="solid"/>
+                      <a:round/>
+                      <a:headEnd type="none" w="med" len="med"/>
+                      <a:tailEnd type="none" w="med" len="med"/>
+                    </a:lnB>
+                    <a:solidFill>
+                      <a:srgbClr val="E4E6C3"/>
+                    </a:solidFill>
+                  </a:tcPr>
+                </a:tc>
+              </a:tr>
+            </a:tbl>
+          </a:graphicData>
+        </a:graphic>
+      </p:graphicFrame>
+      <p:sp>
+        <p:nvSpPr>
+          <p:cNvPr id="4" name="Text 1"/>
+          <p:cNvSpPr txBox="1"/>
+          <p:nvPr/>
+        </p:nvSpPr>
+        <p:spPr>
+          <a:xfrm>
+            <a:off x="548640" y="4114800"/>
+            <a:ext cx="11094415" cy="457200"/>
+          </a:xfrm>
+          <a:prstGeom prst="rect">
+            <a:avLst/>
+          </a:prstGeom>
+          <a:noFill/>
+          <a:ln/>
+        </p:spPr>
+        <p:txBody>
+          <a:bodyPr wrap="square" lIns="0" tIns="0" rIns="0" bIns="0" rtlCol="0" anchor="t"/>
+          <a:lstStyle/>
+          <a:p>
+            <a:pPr indent="0" marL="0">
+              <a:buNone/>
+            </a:pPr>
+            <a:r>
+              <a:rPr lang="en-US" sz="1200" dirty="0">
+                <a:solidFill>
+                  <a:srgbClr val="6E5B58"/>
+                </a:solidFill>
+                <a:latin typeface="Calibri" pitchFamily="34" charset="0"/>
+                <a:ea typeface="Calibri" pitchFamily="34" charset="-122"/>
+                <a:cs typeface="Calibri" pitchFamily="34" charset="-120"/>
+              </a:rPr>
+              <a:t>Se configurado: o síndico escolhe os cargos nas configurações. Hoje, só o síndico gerencia os serviços; o síndico e a administradora conferem as leituras e calculam a água. A administradora precisa do termo assinado. Na própria casa, o morador adere aos serviços e envia a leitura (slide 9).</a:t>
+            </a:r>
+            <a:endParaRPr lang="en-US" sz="1200" dirty="0"/>
+          </a:p>
+        </p:txBody>
+      </p:sp>
+      <p:sp>
+        <p:nvSpPr>
+          <p:cNvPr id="25" name="Slide Number Placeholder 0"/>
+          <p:cNvSpPr>
+            <a:spLocks noGrp="1"/>
+          </p:cNvSpPr>
+          <p:nvPr>
+            <p:ph type="sldNum" sz="quarter" idx="4294967295"/>
+          </p:nvPr>
+        </p:nvSpPr>
+        <p:spPr>
+          <a:xfrm>
+            <a:off x="11094415" y="6400800"/>
+            <a:ext cx="548640" cy="274320"/>
+          </a:xfrm>
+          <a:prstGeom prst="rect">
+            <a:avLst/>
+          </a:prstGeom>
+          <a:extLst>
+            <a:ext uri="{C572A759-6A51-4108-AA02-DFA0A04FC94B}">
+              <ma14:wrappingTextBoxFlag xmlns:ma14="http://schemas.microsoft.com/office/mac/drawingml/2011/main" val="0"/>
+            </a:ext>
+          </a:extLst>
+        </p:spPr>
+        <p:txBody>
+          <a:bodyPr/>
+          <a:lstStyle>
+            <a:lvl1pPr>
+              <a:defRPr sz="1000">
+                <a:solidFill>
+                  <a:srgbClr val="6E5B58"/>
+                </a:solidFill>
+                <a:latin typeface="Calibri"/>
+                <a:ea typeface="Calibri"/>
+                <a:cs typeface="Calibri"/>
+              </a:defRPr>
+            </a:lvl1pPr>
+          </a:lstStyle>
+          <a:p>
+            <a:pPr algn="r"/>
+            <a:fld id="{F7021451-1387-4CA6-816F-3879F97B5CBC}" type="slidenum">
+              <a:rPr b="0" lang="en-US"/>
+              <a:t>11</a:t>
+            </a:fld>
+            <a:endParaRPr lang="en-US"/>
           </a:p>
         </p:txBody>
       </p:sp>

</xml_diff>

<commit_message>
Alinha a documentação, o protótipo e a apresentação ao que foi feito (#30)
- arquitetura-mvp.md: modelo de dados com as tabelas e campos reais
  (ofertas_servico, adesões, adiamentos, leituras, cálculo da água),
  chaves de configuração certas, backend FastAPI e React+Vite escolhidos,
  fluxos de serviços e água atualizados, Fase 2 com merge, convenções
  de interface (menu da conta, Início do síndico, badges) e o protótipo.
- decisoes-gestao.md: leitura e cálculo da água, serviços com adesão e
  a ordem do Início do síndico.
- para-publicar.md: arquivos a guardar e aviso sobre dados_ficticios.py.
- personas.md: "oferta de serviço" no lugar de "chamada".
- design-system/README.md: menu da conta, gestão das ofertas, exportação
  e blocos do Início.
- Apresentação: slide novo "Serviços e conta de água: quem faz o quê" e
  pontos novos para o conselho confirmar.


Claude-Session: https://claude.ai/code/session_01WMuJZBNVY5w6pDizGVPh75

Co-authored-by: Claude <noreply@anthropic.com>
</commit_message>
<xml_diff>
--- a/apresentacoes/Personas-e-perfis-de-acesso.pptx
+++ b/apresentacoes/Personas-e-perfis-de-acesso.pptx
@@ -15,6 +15,7 @@
     <p:sldId id="263" r:id="rId9"/>
     <p:sldId id="264" r:id="rId10"/>
     <p:sldId id="265" r:id="rId11"/>
+    <p:sldId id="269" r:id="rId20"/>
     <p:sldId id="266" r:id="rId12"/>
     <p:sldId id="267" r:id="rId13"/>
     <p:sldId id="268" r:id="rId14"/>
@@ -9251,7 +9252,7 @@
             <a:pPr algn="r"/>
             <a:fld id="{F7021451-1387-4CA6-816F-3879F97B5CBC}" type="slidenum">
               <a:rPr b="0" lang="en-US"/>
-              <a:t>11</a:t>
+              <a:t>12</a:t>
             </a:fld>
             <a:endParaRPr lang="en-US"/>
           </a:p>
@@ -10199,7 +10200,7 @@
             <a:pPr algn="r"/>
             <a:fld id="{F7021451-1387-4CA6-816F-3879F97B5CBC}" type="slidenum">
               <a:rPr b="0" lang="en-US"/>
-              <a:t>12</a:t>
+              <a:t>13</a:t>
             </a:fld>
             <a:endParaRPr lang="en-US"/>
           </a:p>
@@ -10240,7 +10241,7 @@
         </p:nvSpPr>
         <p:spPr>
           <a:xfrm>
-            <a:off x="548640" y="2011680"/>
+            <a:off x="548640" y="1280160"/>
             <a:ext cx="6583680" cy="1737360"/>
           </a:xfrm>
           <a:prstGeom prst="rect">
@@ -10279,7 +10280,7 @@
         </p:nvSpPr>
         <p:spPr>
           <a:xfrm>
-            <a:off x="548640" y="3931920"/>
+            <a:off x="548640" y="3200400"/>
             <a:ext cx="10789920" cy="2468880"/>
           </a:xfrm>
           <a:prstGeom prst="rect">
@@ -10413,7 +10414,49 @@
                 <a:ea typeface="Calibri" pitchFamily="34" charset="-122"/>
                 <a:cs typeface="Calibri" pitchFamily="34" charset="-120"/>
               </a:rPr>
-              <a:t>O que cada perfil vê primeiro no Início (hoje: avisos primeiro para todos).</a:t>
+              <a:t>O que cada perfil vê primeiro no Início (hoje: avisos primeiro; para o síndico, a gestão no alto).</a:t>
+            </a:r>
+            <a:endParaRPr lang="en-US" sz="1800" dirty="0"/>
+          </a:p>
+          <a:p>
+            <a:pPr marL="342900" indent="-342900">
+              <a:spcAft>
+                <a:spcPts val="600"/>
+              </a:spcAft>
+              <a:buSzPct val="100000"/>
+              <a:buChar char="•"/>
+            </a:pPr>
+            <a:r>
+              <a:rPr lang="en-US" sz="1800" dirty="0">
+                <a:solidFill>
+                  <a:srgbClr val="B9CDDC"/>
+                </a:solidFill>
+                <a:latin typeface="Calibri" pitchFamily="34" charset="0"/>
+                <a:ea typeface="Calibri" pitchFamily="34" charset="-122"/>
+                <a:cs typeface="Calibri" pitchFamily="34" charset="-120"/>
+              </a:rPr>
+              <a:t>Serviços com adesão: só o síndico abre as ofertas; prazo sugerido de 2 dias antes.</a:t>
+            </a:r>
+            <a:endParaRPr lang="en-US" sz="1800" dirty="0"/>
+          </a:p>
+          <a:p>
+            <a:pPr marL="342900" indent="-342900">
+              <a:spcAft>
+                <a:spcPts val="600"/>
+              </a:spcAft>
+              <a:buSzPct val="100000"/>
+              <a:buChar char="•"/>
+            </a:pPr>
+            <a:r>
+              <a:rPr lang="en-US" sz="1800" dirty="0">
+                <a:solidFill>
+                  <a:srgbClr val="B9CDDC"/>
+                </a:solidFill>
+                <a:latin typeface="Calibri" pitchFamily="34" charset="0"/>
+                <a:ea typeface="Calibri" pitchFamily="34" charset="-122"/>
+                <a:cs typeface="Calibri" pitchFamily="34" charset="-120"/>
+              </a:rPr>
+              <a:t>Água: forma de cálculo (valor do m³ ou rateio) e casa sem leitura pela média.</a:t>
             </a:r>
             <a:endParaRPr lang="en-US" sz="1800" dirty="0"/>
           </a:p>
@@ -10429,7 +10472,7 @@
         </p:nvSpPr>
         <p:spPr>
           <a:xfrm>
-            <a:off x="548640" y="3931920"/>
+            <a:off x="548640" y="3200400"/>
             <a:ext cx="6583680" cy="1097280"/>
           </a:xfrm>
           <a:prstGeom prst="rect">
@@ -10446,6 +10489,3131 @@
               <a:buNone/>
             </a:pPr>
             <a:endParaRPr lang="en-US" sz="2000" dirty="0"/>
+          </a:p>
+        </p:txBody>
+      </p:sp>
+    </p:spTree>
+  </p:cSld>
+  <p:clrMapOvr>
+    <a:masterClrMapping/>
+  </p:clrMapOvr>
+</p:sld>
+</file>
+
+<file path=ppt/slides/slide14.xml><?xml version="1.0" encoding="utf-8"?>
+<p:sld xmlns:a="http://schemas.openxmlformats.org/drawingml/2006/main" xmlns:r="http://schemas.openxmlformats.org/officeDocument/2006/relationships" xmlns:p="http://schemas.openxmlformats.org/presentationml/2006/main">
+  <p:cSld name="Slide 10">
+    <p:spTree>
+      <p:nvGrpSpPr>
+        <p:cNvPr id="1" name=""/>
+        <p:cNvGrpSpPr/>
+        <p:nvPr/>
+      </p:nvGrpSpPr>
+      <p:grpSpPr>
+        <a:xfrm>
+          <a:off x="0" y="0"/>
+          <a:ext cx="0" cy="0"/>
+          <a:chOff x="0" y="0"/>
+          <a:chExt cx="0" cy="0"/>
+        </a:xfrm>
+      </p:grpSpPr>
+      <p:sp>
+        <p:nvSpPr>
+          <p:cNvPr id="2" name="Text 0"/>
+          <p:cNvSpPr/>
+          <p:nvPr>
+            <p:ph idx="100" type="title" hasCustomPrompt="1"/>
+          </p:nvPr>
+        </p:nvSpPr>
+        <p:spPr>
+          <a:xfrm>
+            <a:off x="548640" y="365760"/>
+            <a:ext cx="11094415" cy="731520"/>
+          </a:xfrm>
+          <a:prstGeom prst="rect">
+            <a:avLst/>
+          </a:prstGeom>
+          <a:noFill/>
+          <a:ln/>
+        </p:spPr>
+        <p:txBody>
+          <a:bodyPr wrap="square" lIns="0" tIns="0" rIns="0" bIns="0" rtlCol="0" anchor="ctr"/>
+          <a:lstStyle/>
+          <a:p>
+            <a:pPr algn="l" indent="0" marL="0">
+              <a:buNone/>
+            </a:pPr>
+            <a:r>
+              <a:rPr lang="en-US" sz="3200" b="1" dirty="0">
+                <a:solidFill>
+                  <a:srgbClr val="2B1E1C"/>
+                </a:solidFill>
+                <a:latin typeface="Arial" pitchFamily="34" charset="0"/>
+                <a:ea typeface="Arial" pitchFamily="34" charset="-122"/>
+                <a:cs typeface="Arial" pitchFamily="34" charset="-120"/>
+              </a:rPr>
+              <a:t>Serviços e conta de água: quem faz o quê</a:t>
+            </a:r>
+            <a:endParaRPr lang="en-US" sz="3200" dirty="0"/>
+          </a:p>
+        </p:txBody>
+      </p:sp>
+      <p:graphicFrame>
+        <p:nvGraphicFramePr>
+          <p:cNvPr id="11" name="Table 0"/>
+          <p:cNvGraphicFramePr>
+            <a:graphicFrameLocks noGrp="1"/>
+          </p:cNvGraphicFramePr>
+          <p:nvPr>
+            <p:extLst>
+              <p:ext uri="{D42A27DB-BD31-4B8C-83A1-F6EECF244321}">
+                <p14:modId xmlns:p14="http://schemas.microsoft.com/office/powerpoint/2010/main" val="1579011935"/>
+              </p:ext>
+            </p:extLst>
+          </p:nvPr>
+        </p:nvGraphicFramePr>
+        <p:xfrm>
+          <a:off x="548640" y="1234440"/>
+          <a:ext cx="11094415" cy="914400"/>
+        </p:xfrm>
+        <a:graphic>
+          <a:graphicData uri="http://schemas.openxmlformats.org/drawingml/2006/table">
+            <a:tbl>
+              <a:tblPr/>
+              <a:tblGrid>
+                <a:gridCol w="3520440"/>
+                <a:gridCol w="1188720"/>
+                <a:gridCol w="1188720"/>
+                <a:gridCol w="1280160"/>
+                <a:gridCol w="1280160"/>
+                <a:gridCol w="1188720"/>
+                <a:gridCol w="1444752"/>
+              </a:tblGrid>
+              <a:tr h="502920">
+                <a:tc>
+                  <a:txBody>
+                    <a:bodyPr/>
+                    <a:lstStyle/>
+                    <a:p>
+                      <a:pPr indent="0" marL="0">
+                        <a:buNone/>
+                      </a:pPr>
+                      <a:r>
+                        <a:rPr lang="en-US" sz="1200" b="1" dirty="0">
+                          <a:solidFill>
+                            <a:srgbClr val="FFFFFF"/>
+                          </a:solidFill>
+                          <a:latin typeface="Arial" pitchFamily="34" charset="0"/>
+                          <a:ea typeface="Arial" pitchFamily="34" charset="-122"/>
+                          <a:cs typeface="Arial" pitchFamily="34" charset="-120"/>
+                        </a:rPr>
+                        <a:t>Serviços e conta de água</a:t>
+                      </a:r>
+                      <a:endParaRPr lang="en-US" sz="1200" dirty="0">
+                        <a:latin typeface="Arial" charset="0"/>
+                        <a:ea typeface="Arial" charset="0"/>
+                        <a:cs typeface="Arial" charset="0"/>
+                      </a:endParaRPr>
+                    </a:p>
+                  </a:txBody>
+                  <a:tcPr marL="73152" marR="73152" marT="18288" marB="18288" anchor="ctr">
+                    <a:lnL w="6350" cap="flat" cmpd="sng" algn="ctr">
+                      <a:solidFill>
+                        <a:srgbClr val="EBE7E3"/>
+                      </a:solidFill>
+                      <a:prstDash val="solid"/>
+                      <a:round/>
+                      <a:headEnd type="none" w="med" len="med"/>
+                      <a:tailEnd type="none" w="med" len="med"/>
+                    </a:lnL>
+                    <a:lnR w="6350" cap="flat" cmpd="sng" algn="ctr">
+                      <a:solidFill>
+                        <a:srgbClr val="EBE7E3"/>
+                      </a:solidFill>
+                      <a:prstDash val="solid"/>
+                      <a:round/>
+                      <a:headEnd type="none" w="med" len="med"/>
+                      <a:tailEnd type="none" w="med" len="med"/>
+                    </a:lnR>
+                    <a:lnT w="6350" cap="flat" cmpd="sng" algn="ctr">
+                      <a:solidFill>
+                        <a:srgbClr val="EBE7E3"/>
+                      </a:solidFill>
+                      <a:prstDash val="solid"/>
+                      <a:round/>
+                      <a:headEnd type="none" w="med" len="med"/>
+                      <a:tailEnd type="none" w="med" len="med"/>
+                    </a:lnT>
+                    <a:lnB w="6350" cap="flat" cmpd="sng" algn="ctr">
+                      <a:solidFill>
+                        <a:srgbClr val="EBE7E3"/>
+                      </a:solidFill>
+                      <a:prstDash val="solid"/>
+                      <a:round/>
+                      <a:headEnd type="none" w="med" len="med"/>
+                      <a:tailEnd type="none" w="med" len="med"/>
+                    </a:lnB>
+                    <a:solidFill>
+                      <a:srgbClr val="264B65"/>
+                    </a:solidFill>
+                  </a:tcPr>
+                </a:tc>
+                <a:tc>
+                  <a:txBody>
+                    <a:bodyPr/>
+                    <a:lstStyle/>
+                    <a:p>
+                      <a:pPr algn="ctr" indent="0" marL="0">
+                        <a:buNone/>
+                      </a:pPr>
+                      <a:r>
+                        <a:rPr lang="en-US" sz="1100" b="1" dirty="0">
+                          <a:solidFill>
+                            <a:srgbClr val="FFFFFF"/>
+                          </a:solidFill>
+                          <a:latin typeface="Arial" pitchFamily="34" charset="0"/>
+                          <a:ea typeface="Arial" pitchFamily="34" charset="-122"/>
+                          <a:cs typeface="Arial" pitchFamily="34" charset="-120"/>
+                        </a:rPr>
+                        <a:t>Síndico</a:t>
+                      </a:r>
+                      <a:endParaRPr lang="en-US" sz="1100" dirty="0">
+                        <a:latin typeface="Arial" charset="0"/>
+                        <a:ea typeface="Arial" charset="0"/>
+                        <a:cs typeface="Arial" charset="0"/>
+                      </a:endParaRPr>
+                    </a:p>
+                  </a:txBody>
+                  <a:tcPr marL="73152" marR="73152" marT="18288" marB="18288" anchor="ctr">
+                    <a:lnL w="6350" cap="flat" cmpd="sng" algn="ctr">
+                      <a:solidFill>
+                        <a:srgbClr val="EBE7E3"/>
+                      </a:solidFill>
+                      <a:prstDash val="solid"/>
+                      <a:round/>
+                      <a:headEnd type="none" w="med" len="med"/>
+                      <a:tailEnd type="none" w="med" len="med"/>
+                    </a:lnL>
+                    <a:lnR w="6350" cap="flat" cmpd="sng" algn="ctr">
+                      <a:solidFill>
+                        <a:srgbClr val="EBE7E3"/>
+                      </a:solidFill>
+                      <a:prstDash val="solid"/>
+                      <a:round/>
+                      <a:headEnd type="none" w="med" len="med"/>
+                      <a:tailEnd type="none" w="med" len="med"/>
+                    </a:lnR>
+                    <a:lnT w="6350" cap="flat" cmpd="sng" algn="ctr">
+                      <a:solidFill>
+                        <a:srgbClr val="EBE7E3"/>
+                      </a:solidFill>
+                      <a:prstDash val="solid"/>
+                      <a:round/>
+                      <a:headEnd type="none" w="med" len="med"/>
+                      <a:tailEnd type="none" w="med" len="med"/>
+                    </a:lnT>
+                    <a:lnB w="6350" cap="flat" cmpd="sng" algn="ctr">
+                      <a:solidFill>
+                        <a:srgbClr val="EBE7E3"/>
+                      </a:solidFill>
+                      <a:prstDash val="solid"/>
+                      <a:round/>
+                      <a:headEnd type="none" w="med" len="med"/>
+                      <a:tailEnd type="none" w="med" len="med"/>
+                    </a:lnB>
+                    <a:solidFill>
+                      <a:srgbClr val="264B65"/>
+                    </a:solidFill>
+                  </a:tcPr>
+                </a:tc>
+                <a:tc>
+                  <a:txBody>
+                    <a:bodyPr/>
+                    <a:lstStyle/>
+                    <a:p>
+                      <a:pPr algn="ctr" indent="0" marL="0">
+                        <a:buNone/>
+                      </a:pPr>
+                      <a:r>
+                        <a:rPr lang="en-US" sz="1100" b="1" dirty="0">
+                          <a:solidFill>
+                            <a:srgbClr val="FFFFFF"/>
+                          </a:solidFill>
+                          <a:latin typeface="Arial" pitchFamily="34" charset="0"/>
+                          <a:ea typeface="Arial" pitchFamily="34" charset="-122"/>
+                          <a:cs typeface="Arial" pitchFamily="34" charset="-120"/>
+                        </a:rPr>
+                        <a:t>Subsíndico</a:t>
+                      </a:r>
+                      <a:endParaRPr lang="en-US" sz="1100" dirty="0">
+                        <a:latin typeface="Arial" charset="0"/>
+                        <a:ea typeface="Arial" charset="0"/>
+                        <a:cs typeface="Arial" charset="0"/>
+                      </a:endParaRPr>
+                    </a:p>
+                  </a:txBody>
+                  <a:tcPr marL="73152" marR="73152" marT="18288" marB="18288" anchor="ctr">
+                    <a:lnL w="6350" cap="flat" cmpd="sng" algn="ctr">
+                      <a:solidFill>
+                        <a:srgbClr val="EBE7E3"/>
+                      </a:solidFill>
+                      <a:prstDash val="solid"/>
+                      <a:round/>
+                      <a:headEnd type="none" w="med" len="med"/>
+                      <a:tailEnd type="none" w="med" len="med"/>
+                    </a:lnL>
+                    <a:lnR w="6350" cap="flat" cmpd="sng" algn="ctr">
+                      <a:solidFill>
+                        <a:srgbClr val="EBE7E3"/>
+                      </a:solidFill>
+                      <a:prstDash val="solid"/>
+                      <a:round/>
+                      <a:headEnd type="none" w="med" len="med"/>
+                      <a:tailEnd type="none" w="med" len="med"/>
+                    </a:lnR>
+                    <a:lnT w="6350" cap="flat" cmpd="sng" algn="ctr">
+                      <a:solidFill>
+                        <a:srgbClr val="EBE7E3"/>
+                      </a:solidFill>
+                      <a:prstDash val="solid"/>
+                      <a:round/>
+                      <a:headEnd type="none" w="med" len="med"/>
+                      <a:tailEnd type="none" w="med" len="med"/>
+                    </a:lnT>
+                    <a:lnB w="6350" cap="flat" cmpd="sng" algn="ctr">
+                      <a:solidFill>
+                        <a:srgbClr val="EBE7E3"/>
+                      </a:solidFill>
+                      <a:prstDash val="solid"/>
+                      <a:round/>
+                      <a:headEnd type="none" w="med" len="med"/>
+                      <a:tailEnd type="none" w="med" len="med"/>
+                    </a:lnB>
+                    <a:solidFill>
+                      <a:srgbClr val="264B65"/>
+                    </a:solidFill>
+                  </a:tcPr>
+                </a:tc>
+                <a:tc>
+                  <a:txBody>
+                    <a:bodyPr/>
+                    <a:lstStyle/>
+                    <a:p>
+                      <a:pPr algn="ctr" indent="0" marL="0">
+                        <a:buNone/>
+                      </a:pPr>
+                      <a:r>
+                        <a:rPr lang="en-US" sz="1100" b="1" dirty="0">
+                          <a:solidFill>
+                            <a:srgbClr val="FFFFFF"/>
+                          </a:solidFill>
+                          <a:latin typeface="Arial" pitchFamily="34" charset="0"/>
+                          <a:ea typeface="Arial" pitchFamily="34" charset="-122"/>
+                          <a:cs typeface="Arial" pitchFamily="34" charset="-120"/>
+                        </a:rPr>
+                        <a:t>Presidente</a:t>
+                      </a:r>
+                      <a:endParaRPr lang="en-US" sz="1100" dirty="0">
+                        <a:latin typeface="Arial" charset="0"/>
+                        <a:ea typeface="Arial" charset="0"/>
+                        <a:cs typeface="Arial" charset="0"/>
+                      </a:endParaRPr>
+                    </a:p>
+                    <a:p>
+                      <a:pPr algn="ctr" indent="0" marL="0">
+                        <a:buNone/>
+                      </a:pPr>
+                      <a:r>
+                        <a:rPr lang="en-US" sz="1100" b="1" dirty="0">
+                          <a:solidFill>
+                            <a:srgbClr val="FFFFFF"/>
+                          </a:solidFill>
+                          <a:latin typeface="Arial" pitchFamily="34" charset="0"/>
+                          <a:ea typeface="Arial" pitchFamily="34" charset="-122"/>
+                          <a:cs typeface="Arial" pitchFamily="34" charset="-120"/>
+                        </a:rPr>
+                        <a:t>do conselho</a:t>
+                      </a:r>
+                      <a:endParaRPr lang="en-US" sz="1100" dirty="0">
+                        <a:latin typeface="Arial" charset="0"/>
+                        <a:ea typeface="Arial" charset="0"/>
+                        <a:cs typeface="Arial" charset="0"/>
+                      </a:endParaRPr>
+                    </a:p>
+                  </a:txBody>
+                  <a:tcPr marL="73152" marR="73152" marT="18288" marB="18288" anchor="ctr">
+                    <a:lnL w="6350" cap="flat" cmpd="sng" algn="ctr">
+                      <a:solidFill>
+                        <a:srgbClr val="EBE7E3"/>
+                      </a:solidFill>
+                      <a:prstDash val="solid"/>
+                      <a:round/>
+                      <a:headEnd type="none" w="med" len="med"/>
+                      <a:tailEnd type="none" w="med" len="med"/>
+                    </a:lnL>
+                    <a:lnR w="6350" cap="flat" cmpd="sng" algn="ctr">
+                      <a:solidFill>
+                        <a:srgbClr val="EBE7E3"/>
+                      </a:solidFill>
+                      <a:prstDash val="solid"/>
+                      <a:round/>
+                      <a:headEnd type="none" w="med" len="med"/>
+                      <a:tailEnd type="none" w="med" len="med"/>
+                    </a:lnR>
+                    <a:lnT w="6350" cap="flat" cmpd="sng" algn="ctr">
+                      <a:solidFill>
+                        <a:srgbClr val="EBE7E3"/>
+                      </a:solidFill>
+                      <a:prstDash val="solid"/>
+                      <a:round/>
+                      <a:headEnd type="none" w="med" len="med"/>
+                      <a:tailEnd type="none" w="med" len="med"/>
+                    </a:lnT>
+                    <a:lnB w="6350" cap="flat" cmpd="sng" algn="ctr">
+                      <a:solidFill>
+                        <a:srgbClr val="EBE7E3"/>
+                      </a:solidFill>
+                      <a:prstDash val="solid"/>
+                      <a:round/>
+                      <a:headEnd type="none" w="med" len="med"/>
+                      <a:tailEnd type="none" w="med" len="med"/>
+                    </a:lnB>
+                    <a:solidFill>
+                      <a:srgbClr val="264B65"/>
+                    </a:solidFill>
+                  </a:tcPr>
+                </a:tc>
+                <a:tc>
+                  <a:txBody>
+                    <a:bodyPr/>
+                    <a:lstStyle/>
+                    <a:p>
+                      <a:pPr algn="ctr" indent="0" marL="0">
+                        <a:buNone/>
+                      </a:pPr>
+                      <a:r>
+                        <a:rPr lang="en-US" sz="1100" b="1" dirty="0">
+                          <a:solidFill>
+                            <a:srgbClr val="FFFFFF"/>
+                          </a:solidFill>
+                          <a:latin typeface="Arial" pitchFamily="34" charset="0"/>
+                          <a:ea typeface="Arial" pitchFamily="34" charset="-122"/>
+                          <a:cs typeface="Arial" pitchFamily="34" charset="-120"/>
+                        </a:rPr>
+                        <a:t>Membros do</a:t>
+                      </a:r>
+                      <a:endParaRPr lang="en-US" sz="1100" dirty="0">
+                        <a:latin typeface="Arial" charset="0"/>
+                        <a:ea typeface="Arial" charset="0"/>
+                        <a:cs typeface="Arial" charset="0"/>
+                      </a:endParaRPr>
+                    </a:p>
+                    <a:p>
+                      <a:pPr algn="ctr" indent="0" marL="0">
+                        <a:buNone/>
+                      </a:pPr>
+                      <a:r>
+                        <a:rPr lang="en-US" sz="1100" b="1" dirty="0">
+                          <a:solidFill>
+                            <a:srgbClr val="FFFFFF"/>
+                          </a:solidFill>
+                          <a:latin typeface="Arial" pitchFamily="34" charset="0"/>
+                          <a:ea typeface="Arial" pitchFamily="34" charset="-122"/>
+                          <a:cs typeface="Arial" pitchFamily="34" charset="-120"/>
+                        </a:rPr>
+                        <a:t>conselho</a:t>
+                      </a:r>
+                      <a:endParaRPr lang="en-US" sz="1100" dirty="0">
+                        <a:latin typeface="Arial" charset="0"/>
+                        <a:ea typeface="Arial" charset="0"/>
+                        <a:cs typeface="Arial" charset="0"/>
+                      </a:endParaRPr>
+                    </a:p>
+                  </a:txBody>
+                  <a:tcPr marL="73152" marR="73152" marT="18288" marB="18288" anchor="ctr">
+                    <a:lnL w="6350" cap="flat" cmpd="sng" algn="ctr">
+                      <a:solidFill>
+                        <a:srgbClr val="EBE7E3"/>
+                      </a:solidFill>
+                      <a:prstDash val="solid"/>
+                      <a:round/>
+                      <a:headEnd type="none" w="med" len="med"/>
+                      <a:tailEnd type="none" w="med" len="med"/>
+                    </a:lnL>
+                    <a:lnR w="6350" cap="flat" cmpd="sng" algn="ctr">
+                      <a:solidFill>
+                        <a:srgbClr val="EBE7E3"/>
+                      </a:solidFill>
+                      <a:prstDash val="solid"/>
+                      <a:round/>
+                      <a:headEnd type="none" w="med" len="med"/>
+                      <a:tailEnd type="none" w="med" len="med"/>
+                    </a:lnR>
+                    <a:lnT w="6350" cap="flat" cmpd="sng" algn="ctr">
+                      <a:solidFill>
+                        <a:srgbClr val="EBE7E3"/>
+                      </a:solidFill>
+                      <a:prstDash val="solid"/>
+                      <a:round/>
+                      <a:headEnd type="none" w="med" len="med"/>
+                      <a:tailEnd type="none" w="med" len="med"/>
+                    </a:lnT>
+                    <a:lnB w="6350" cap="flat" cmpd="sng" algn="ctr">
+                      <a:solidFill>
+                        <a:srgbClr val="EBE7E3"/>
+                      </a:solidFill>
+                      <a:prstDash val="solid"/>
+                      <a:round/>
+                      <a:headEnd type="none" w="med" len="med"/>
+                      <a:tailEnd type="none" w="med" len="med"/>
+                    </a:lnB>
+                    <a:solidFill>
+                      <a:srgbClr val="264B65"/>
+                    </a:solidFill>
+                  </a:tcPr>
+                </a:tc>
+                <a:tc>
+                  <a:txBody>
+                    <a:bodyPr/>
+                    <a:lstStyle/>
+                    <a:p>
+                      <a:pPr algn="ctr" indent="0" marL="0">
+                        <a:buNone/>
+                      </a:pPr>
+                      <a:r>
+                        <a:rPr lang="en-US" sz="1100" b="1" dirty="0">
+                          <a:solidFill>
+                            <a:srgbClr val="FFFFFF"/>
+                          </a:solidFill>
+                          <a:latin typeface="Arial" pitchFamily="34" charset="0"/>
+                          <a:ea typeface="Arial" pitchFamily="34" charset="-122"/>
+                          <a:cs typeface="Arial" pitchFamily="34" charset="-120"/>
+                        </a:rPr>
+                        <a:t>Adminis-</a:t>
+                      </a:r>
+                      <a:endParaRPr lang="en-US" sz="1100" dirty="0">
+                        <a:latin typeface="Arial" charset="0"/>
+                        <a:ea typeface="Arial" charset="0"/>
+                        <a:cs typeface="Arial" charset="0"/>
+                      </a:endParaRPr>
+                    </a:p>
+                    <a:p>
+                      <a:pPr algn="ctr" indent="0" marL="0">
+                        <a:buNone/>
+                      </a:pPr>
+                      <a:r>
+                        <a:rPr lang="en-US" sz="1100" b="1" dirty="0">
+                          <a:solidFill>
+                            <a:srgbClr val="FFFFFF"/>
+                          </a:solidFill>
+                          <a:latin typeface="Arial" pitchFamily="34" charset="0"/>
+                          <a:ea typeface="Arial" pitchFamily="34" charset="-122"/>
+                          <a:cs typeface="Arial" pitchFamily="34" charset="-120"/>
+                        </a:rPr>
+                        <a:t>tradora</a:t>
+                      </a:r>
+                      <a:endParaRPr lang="en-US" sz="1100" dirty="0">
+                        <a:latin typeface="Arial" charset="0"/>
+                        <a:ea typeface="Arial" charset="0"/>
+                        <a:cs typeface="Arial" charset="0"/>
+                      </a:endParaRPr>
+                    </a:p>
+                  </a:txBody>
+                  <a:tcPr marL="73152" marR="73152" marT="18288" marB="18288" anchor="ctr">
+                    <a:lnL w="6350" cap="flat" cmpd="sng" algn="ctr">
+                      <a:solidFill>
+                        <a:srgbClr val="EBE7E3"/>
+                      </a:solidFill>
+                      <a:prstDash val="solid"/>
+                      <a:round/>
+                      <a:headEnd type="none" w="med" len="med"/>
+                      <a:tailEnd type="none" w="med" len="med"/>
+                    </a:lnL>
+                    <a:lnR w="6350" cap="flat" cmpd="sng" algn="ctr">
+                      <a:solidFill>
+                        <a:srgbClr val="EBE7E3"/>
+                      </a:solidFill>
+                      <a:prstDash val="solid"/>
+                      <a:round/>
+                      <a:headEnd type="none" w="med" len="med"/>
+                      <a:tailEnd type="none" w="med" len="med"/>
+                    </a:lnR>
+                    <a:lnT w="6350" cap="flat" cmpd="sng" algn="ctr">
+                      <a:solidFill>
+                        <a:srgbClr val="EBE7E3"/>
+                      </a:solidFill>
+                      <a:prstDash val="solid"/>
+                      <a:round/>
+                      <a:headEnd type="none" w="med" len="med"/>
+                      <a:tailEnd type="none" w="med" len="med"/>
+                    </a:lnT>
+                    <a:lnB w="6350" cap="flat" cmpd="sng" algn="ctr">
+                      <a:solidFill>
+                        <a:srgbClr val="EBE7E3"/>
+                      </a:solidFill>
+                      <a:prstDash val="solid"/>
+                      <a:round/>
+                      <a:headEnd type="none" w="med" len="med"/>
+                      <a:tailEnd type="none" w="med" len="med"/>
+                    </a:lnB>
+                    <a:solidFill>
+                      <a:srgbClr val="264B65"/>
+                    </a:solidFill>
+                  </a:tcPr>
+                </a:tc>
+                <a:tc>
+                  <a:txBody>
+                    <a:bodyPr/>
+                    <a:lstStyle/>
+                    <a:p>
+                      <a:pPr algn="ctr" indent="0" marL="0">
+                        <a:buNone/>
+                      </a:pPr>
+                      <a:r>
+                        <a:rPr lang="en-US" sz="1100" b="1" dirty="0">
+                          <a:solidFill>
+                            <a:srgbClr val="FFFFFF"/>
+                          </a:solidFill>
+                          <a:latin typeface="Arial" pitchFamily="34" charset="0"/>
+                          <a:ea typeface="Arial" pitchFamily="34" charset="-122"/>
+                          <a:cs typeface="Arial" pitchFamily="34" charset="-120"/>
+                        </a:rPr>
+                        <a:t>Admin. do site</a:t>
+                      </a:r>
+                      <a:endParaRPr lang="en-US" sz="1100" dirty="0">
+                        <a:latin typeface="Arial" charset="0"/>
+                        <a:ea typeface="Arial" charset="0"/>
+                        <a:cs typeface="Arial" charset="0"/>
+                      </a:endParaRPr>
+                    </a:p>
+                    <a:p>
+                      <a:pPr algn="ctr" indent="0" marL="0">
+                        <a:buNone/>
+                      </a:pPr>
+                      <a:r>
+                        <a:rPr lang="en-US" sz="1100" b="1" dirty="0">
+                          <a:solidFill>
+                            <a:srgbClr val="FFFFFF"/>
+                          </a:solidFill>
+                          <a:latin typeface="Arial" pitchFamily="34" charset="0"/>
+                          <a:ea typeface="Arial" pitchFamily="34" charset="-122"/>
+                          <a:cs typeface="Arial" pitchFamily="34" charset="-120"/>
+                        </a:rPr>
+                        <a:t>com o termo</a:t>
+                      </a:r>
+                      <a:endParaRPr lang="en-US" sz="1100" dirty="0">
+                        <a:latin typeface="Arial" charset="0"/>
+                        <a:ea typeface="Arial" charset="0"/>
+                        <a:cs typeface="Arial" charset="0"/>
+                      </a:endParaRPr>
+                    </a:p>
+                  </a:txBody>
+                  <a:tcPr marL="73152" marR="73152" marT="18288" marB="18288" anchor="ctr">
+                    <a:lnL w="6350" cap="flat" cmpd="sng" algn="ctr">
+                      <a:solidFill>
+                        <a:srgbClr val="EBE7E3"/>
+                      </a:solidFill>
+                      <a:prstDash val="solid"/>
+                      <a:round/>
+                      <a:headEnd type="none" w="med" len="med"/>
+                      <a:tailEnd type="none" w="med" len="med"/>
+                    </a:lnL>
+                    <a:lnR w="6350" cap="flat" cmpd="sng" algn="ctr">
+                      <a:solidFill>
+                        <a:srgbClr val="EBE7E3"/>
+                      </a:solidFill>
+                      <a:prstDash val="solid"/>
+                      <a:round/>
+                      <a:headEnd type="none" w="med" len="med"/>
+                      <a:tailEnd type="none" w="med" len="med"/>
+                    </a:lnR>
+                    <a:lnT w="6350" cap="flat" cmpd="sng" algn="ctr">
+                      <a:solidFill>
+                        <a:srgbClr val="EBE7E3"/>
+                      </a:solidFill>
+                      <a:prstDash val="solid"/>
+                      <a:round/>
+                      <a:headEnd type="none" w="med" len="med"/>
+                      <a:tailEnd type="none" w="med" len="med"/>
+                    </a:lnT>
+                    <a:lnB w="6350" cap="flat" cmpd="sng" algn="ctr">
+                      <a:solidFill>
+                        <a:srgbClr val="EBE7E3"/>
+                      </a:solidFill>
+                      <a:prstDash val="solid"/>
+                      <a:round/>
+                      <a:headEnd type="none" w="med" len="med"/>
+                      <a:tailEnd type="none" w="med" len="med"/>
+                    </a:lnB>
+                    <a:solidFill>
+                      <a:srgbClr val="264B65"/>
+                    </a:solidFill>
+                  </a:tcPr>
+                </a:tc>
+              </a:tr>
+              <a:tr h="347472">
+                <a:tc>
+                  <a:txBody>
+                    <a:bodyPr/>
+                    <a:lstStyle/>
+                    <a:p>
+                      <a:pPr indent="0" marL="0">
+                        <a:buNone/>
+                      </a:pPr>
+                      <a:r>
+                        <a:rPr lang="en-US" sz="1200" dirty="0">
+                          <a:solidFill>
+                            <a:srgbClr val="2B1E1C"/>
+                          </a:solidFill>
+                          <a:latin typeface="Calibri" pitchFamily="34" charset="0"/>
+                          <a:ea typeface="Calibri" pitchFamily="34" charset="-122"/>
+                          <a:cs typeface="Calibri" pitchFamily="34" charset="-120"/>
+                        </a:rPr>
+                        <a:t>Abrir, editar, adiar e cancelar ofertas de serviço</a:t>
+                      </a:r>
+                      <a:endParaRPr lang="en-US" sz="1200" dirty="0">
+                        <a:latin typeface="Calibri" charset="0"/>
+                        <a:ea typeface="Calibri" charset="0"/>
+                        <a:cs typeface="Calibri" charset="0"/>
+                      </a:endParaRPr>
+                    </a:p>
+                  </a:txBody>
+                  <a:tcPr marL="73152" marR="73152" marT="18288" marB="18288" anchor="ctr">
+                    <a:lnL w="6350" cap="flat" cmpd="sng" algn="ctr">
+                      <a:solidFill>
+                        <a:srgbClr val="EBE7E3"/>
+                      </a:solidFill>
+                      <a:prstDash val="solid"/>
+                      <a:round/>
+                      <a:headEnd type="none" w="med" len="med"/>
+                      <a:tailEnd type="none" w="med" len="med"/>
+                    </a:lnL>
+                    <a:lnR w="6350" cap="flat" cmpd="sng" algn="ctr">
+                      <a:solidFill>
+                        <a:srgbClr val="EBE7E3"/>
+                      </a:solidFill>
+                      <a:prstDash val="solid"/>
+                      <a:round/>
+                      <a:headEnd type="none" w="med" len="med"/>
+                      <a:tailEnd type="none" w="med" len="med"/>
+                    </a:lnR>
+                    <a:lnT w="6350" cap="flat" cmpd="sng" algn="ctr">
+                      <a:solidFill>
+                        <a:srgbClr val="EBE7E3"/>
+                      </a:solidFill>
+                      <a:prstDash val="solid"/>
+                      <a:round/>
+                      <a:headEnd type="none" w="med" len="med"/>
+                      <a:tailEnd type="none" w="med" len="med"/>
+                    </a:lnT>
+                    <a:lnB w="6350" cap="flat" cmpd="sng" algn="ctr">
+                      <a:solidFill>
+                        <a:srgbClr val="EBE7E3"/>
+                      </a:solidFill>
+                      <a:prstDash val="solid"/>
+                      <a:round/>
+                      <a:headEnd type="none" w="med" len="med"/>
+                      <a:tailEnd type="none" w="med" len="med"/>
+                    </a:lnB>
+                  </a:tcPr>
+                </a:tc>
+                <a:tc>
+                  <a:txBody>
+                    <a:bodyPr/>
+                    <a:lstStyle/>
+                    <a:p>
+                      <a:pPr algn="ctr" indent="0" marL="0">
+                        <a:buNone/>
+                      </a:pPr>
+                      <a:r>
+                        <a:rPr lang="en-US" sz="1100" b="1" dirty="0">
+                          <a:solidFill>
+                            <a:srgbClr val="545814"/>
+                          </a:solidFill>
+                          <a:latin typeface="Calibri" pitchFamily="34" charset="0"/>
+                          <a:ea typeface="Calibri" pitchFamily="34" charset="-122"/>
+                          <a:cs typeface="Calibri" pitchFamily="34" charset="-120"/>
+                        </a:rPr>
+                        <a:t>✓ Sim</a:t>
+                      </a:r>
+                      <a:endParaRPr lang="en-US" sz="1100" dirty="0">
+                        <a:latin typeface="Calibri" charset="0"/>
+                        <a:ea typeface="Calibri" charset="0"/>
+                        <a:cs typeface="Calibri" charset="0"/>
+                      </a:endParaRPr>
+                    </a:p>
+                  </a:txBody>
+                  <a:tcPr marL="73152" marR="73152" marT="18288" marB="18288" anchor="ctr">
+                    <a:lnL w="6350" cap="flat" cmpd="sng" algn="ctr">
+                      <a:solidFill>
+                        <a:srgbClr val="EBE7E3"/>
+                      </a:solidFill>
+                      <a:prstDash val="solid"/>
+                      <a:round/>
+                      <a:headEnd type="none" w="med" len="med"/>
+                      <a:tailEnd type="none" w="med" len="med"/>
+                    </a:lnL>
+                    <a:lnR w="6350" cap="flat" cmpd="sng" algn="ctr">
+                      <a:solidFill>
+                        <a:srgbClr val="EBE7E3"/>
+                      </a:solidFill>
+                      <a:prstDash val="solid"/>
+                      <a:round/>
+                      <a:headEnd type="none" w="med" len="med"/>
+                      <a:tailEnd type="none" w="med" len="med"/>
+                    </a:lnR>
+                    <a:lnT w="6350" cap="flat" cmpd="sng" algn="ctr">
+                      <a:solidFill>
+                        <a:srgbClr val="EBE7E3"/>
+                      </a:solidFill>
+                      <a:prstDash val="solid"/>
+                      <a:round/>
+                      <a:headEnd type="none" w="med" len="med"/>
+                      <a:tailEnd type="none" w="med" len="med"/>
+                    </a:lnT>
+                    <a:lnB w="6350" cap="flat" cmpd="sng" algn="ctr">
+                      <a:solidFill>
+                        <a:srgbClr val="EBE7E3"/>
+                      </a:solidFill>
+                      <a:prstDash val="solid"/>
+                      <a:round/>
+                      <a:headEnd type="none" w="med" len="med"/>
+                      <a:tailEnd type="none" w="med" len="med"/>
+                    </a:lnB>
+                    <a:solidFill>
+                      <a:srgbClr val="E4E6C3"/>
+                    </a:solidFill>
+                  </a:tcPr>
+                </a:tc>
+                <a:tc>
+                  <a:txBody>
+                    <a:bodyPr/>
+                    <a:lstStyle/>
+                    <a:p>
+                      <a:pPr algn="ctr" indent="0" marL="0">
+                        <a:buNone/>
+                      </a:pPr>
+                      <a:r>
+                        <a:rPr lang="en-US" sz="1100" b="1" dirty="0">
+                          <a:solidFill>
+                            <a:srgbClr val="6B4E00"/>
+                          </a:solidFill>
+                          <a:latin typeface="Calibri" pitchFamily="34" charset="0"/>
+                          <a:ea typeface="Calibri" pitchFamily="34" charset="-122"/>
+                          <a:cs typeface="Calibri" pitchFamily="34" charset="-120"/>
+                        </a:rPr>
+                        <a:t>◐ Se configurado</a:t>
+                      </a:r>
+                      <a:endParaRPr lang="en-US" sz="1100" dirty="0">
+                        <a:latin typeface="Calibri" charset="0"/>
+                        <a:ea typeface="Calibri" charset="0"/>
+                        <a:cs typeface="Calibri" charset="0"/>
+                      </a:endParaRPr>
+                    </a:p>
+                  </a:txBody>
+                  <a:tcPr marL="73152" marR="73152" marT="18288" marB="18288" anchor="ctr">
+                    <a:lnL w="6350" cap="flat" cmpd="sng" algn="ctr">
+                      <a:solidFill>
+                        <a:srgbClr val="EBE7E3"/>
+                      </a:solidFill>
+                      <a:prstDash val="solid"/>
+                      <a:round/>
+                      <a:headEnd type="none" w="med" len="med"/>
+                      <a:tailEnd type="none" w="med" len="med"/>
+                    </a:lnL>
+                    <a:lnR w="6350" cap="flat" cmpd="sng" algn="ctr">
+                      <a:solidFill>
+                        <a:srgbClr val="EBE7E3"/>
+                      </a:solidFill>
+                      <a:prstDash val="solid"/>
+                      <a:round/>
+                      <a:headEnd type="none" w="med" len="med"/>
+                      <a:tailEnd type="none" w="med" len="med"/>
+                    </a:lnR>
+                    <a:lnT w="6350" cap="flat" cmpd="sng" algn="ctr">
+                      <a:solidFill>
+                        <a:srgbClr val="EBE7E3"/>
+                      </a:solidFill>
+                      <a:prstDash val="solid"/>
+                      <a:round/>
+                      <a:headEnd type="none" w="med" len="med"/>
+                      <a:tailEnd type="none" w="med" len="med"/>
+                    </a:lnT>
+                    <a:lnB w="6350" cap="flat" cmpd="sng" algn="ctr">
+                      <a:solidFill>
+                        <a:srgbClr val="EBE7E3"/>
+                      </a:solidFill>
+                      <a:prstDash val="solid"/>
+                      <a:round/>
+                      <a:headEnd type="none" w="med" len="med"/>
+                      <a:tailEnd type="none" w="med" len="med"/>
+                    </a:lnB>
+                    <a:solidFill>
+                      <a:srgbClr val="FBEBC0"/>
+                    </a:solidFill>
+                  </a:tcPr>
+                </a:tc>
+                <a:tc>
+                  <a:txBody>
+                    <a:bodyPr/>
+                    <a:lstStyle/>
+                    <a:p>
+                      <a:pPr algn="ctr" indent="0" marL="0">
+                        <a:buNone/>
+                      </a:pPr>
+                      <a:r>
+                        <a:rPr lang="en-US" sz="1100" b="1" dirty="0">
+                          <a:solidFill>
+                            <a:srgbClr val="6B4E00"/>
+                          </a:solidFill>
+                          <a:latin typeface="Calibri" pitchFamily="34" charset="0"/>
+                          <a:ea typeface="Calibri" pitchFamily="34" charset="-122"/>
+                          <a:cs typeface="Calibri" pitchFamily="34" charset="-120"/>
+                        </a:rPr>
+                        <a:t>◐ Se configurado</a:t>
+                      </a:r>
+                      <a:endParaRPr lang="en-US" sz="1100" dirty="0">
+                        <a:latin typeface="Calibri" charset="0"/>
+                        <a:ea typeface="Calibri" charset="0"/>
+                        <a:cs typeface="Calibri" charset="0"/>
+                      </a:endParaRPr>
+                    </a:p>
+                  </a:txBody>
+                  <a:tcPr marL="73152" marR="73152" marT="18288" marB="18288" anchor="ctr">
+                    <a:lnL w="6350" cap="flat" cmpd="sng" algn="ctr">
+                      <a:solidFill>
+                        <a:srgbClr val="EBE7E3"/>
+                      </a:solidFill>
+                      <a:prstDash val="solid"/>
+                      <a:round/>
+                      <a:headEnd type="none" w="med" len="med"/>
+                      <a:tailEnd type="none" w="med" len="med"/>
+                    </a:lnL>
+                    <a:lnR w="6350" cap="flat" cmpd="sng" algn="ctr">
+                      <a:solidFill>
+                        <a:srgbClr val="EBE7E3"/>
+                      </a:solidFill>
+                      <a:prstDash val="solid"/>
+                      <a:round/>
+                      <a:headEnd type="none" w="med" len="med"/>
+                      <a:tailEnd type="none" w="med" len="med"/>
+                    </a:lnR>
+                    <a:lnT w="6350" cap="flat" cmpd="sng" algn="ctr">
+                      <a:solidFill>
+                        <a:srgbClr val="EBE7E3"/>
+                      </a:solidFill>
+                      <a:prstDash val="solid"/>
+                      <a:round/>
+                      <a:headEnd type="none" w="med" len="med"/>
+                      <a:tailEnd type="none" w="med" len="med"/>
+                    </a:lnT>
+                    <a:lnB w="6350" cap="flat" cmpd="sng" algn="ctr">
+                      <a:solidFill>
+                        <a:srgbClr val="EBE7E3"/>
+                      </a:solidFill>
+                      <a:prstDash val="solid"/>
+                      <a:round/>
+                      <a:headEnd type="none" w="med" len="med"/>
+                      <a:tailEnd type="none" w="med" len="med"/>
+                    </a:lnB>
+                    <a:solidFill>
+                      <a:srgbClr val="FBEBC0"/>
+                    </a:solidFill>
+                  </a:tcPr>
+                </a:tc>
+                <a:tc>
+                  <a:txBody>
+                    <a:bodyPr/>
+                    <a:lstStyle/>
+                    <a:p>
+                      <a:pPr algn="ctr" indent="0" marL="0">
+                        <a:buNone/>
+                      </a:pPr>
+                      <a:r>
+                        <a:rPr lang="en-US" sz="1100" b="1" dirty="0">
+                          <a:solidFill>
+                            <a:srgbClr val="6B4E00"/>
+                          </a:solidFill>
+                          <a:latin typeface="Calibri" pitchFamily="34" charset="0"/>
+                          <a:ea typeface="Calibri" pitchFamily="34" charset="-122"/>
+                          <a:cs typeface="Calibri" pitchFamily="34" charset="-120"/>
+                        </a:rPr>
+                        <a:t>◐ Se configurado</a:t>
+                      </a:r>
+                      <a:endParaRPr lang="en-US" sz="1100" dirty="0">
+                        <a:latin typeface="Calibri" charset="0"/>
+                        <a:ea typeface="Calibri" charset="0"/>
+                        <a:cs typeface="Calibri" charset="0"/>
+                      </a:endParaRPr>
+                    </a:p>
+                  </a:txBody>
+                  <a:tcPr marL="73152" marR="73152" marT="18288" marB="18288" anchor="ctr">
+                    <a:lnL w="6350" cap="flat" cmpd="sng" algn="ctr">
+                      <a:solidFill>
+                        <a:srgbClr val="EBE7E3"/>
+                      </a:solidFill>
+                      <a:prstDash val="solid"/>
+                      <a:round/>
+                      <a:headEnd type="none" w="med" len="med"/>
+                      <a:tailEnd type="none" w="med" len="med"/>
+                    </a:lnL>
+                    <a:lnR w="6350" cap="flat" cmpd="sng" algn="ctr">
+                      <a:solidFill>
+                        <a:srgbClr val="EBE7E3"/>
+                      </a:solidFill>
+                      <a:prstDash val="solid"/>
+                      <a:round/>
+                      <a:headEnd type="none" w="med" len="med"/>
+                      <a:tailEnd type="none" w="med" len="med"/>
+                    </a:lnR>
+                    <a:lnT w="6350" cap="flat" cmpd="sng" algn="ctr">
+                      <a:solidFill>
+                        <a:srgbClr val="EBE7E3"/>
+                      </a:solidFill>
+                      <a:prstDash val="solid"/>
+                      <a:round/>
+                      <a:headEnd type="none" w="med" len="med"/>
+                      <a:tailEnd type="none" w="med" len="med"/>
+                    </a:lnT>
+                    <a:lnB w="6350" cap="flat" cmpd="sng" algn="ctr">
+                      <a:solidFill>
+                        <a:srgbClr val="EBE7E3"/>
+                      </a:solidFill>
+                      <a:prstDash val="solid"/>
+                      <a:round/>
+                      <a:headEnd type="none" w="med" len="med"/>
+                      <a:tailEnd type="none" w="med" len="med"/>
+                    </a:lnB>
+                    <a:solidFill>
+                      <a:srgbClr val="FBEBC0"/>
+                    </a:solidFill>
+                  </a:tcPr>
+                </a:tc>
+                <a:tc>
+                  <a:txBody>
+                    <a:bodyPr/>
+                    <a:lstStyle/>
+                    <a:p>
+                      <a:pPr algn="ctr" indent="0" marL="0">
+                        <a:buNone/>
+                      </a:pPr>
+                      <a:r>
+                        <a:rPr lang="en-US" sz="1100" b="1" dirty="0">
+                          <a:solidFill>
+                            <a:srgbClr val="6B4E00"/>
+                          </a:solidFill>
+                          <a:latin typeface="Calibri" pitchFamily="34" charset="0"/>
+                          <a:ea typeface="Calibri" pitchFamily="34" charset="-122"/>
+                          <a:cs typeface="Calibri" pitchFamily="34" charset="-120"/>
+                        </a:rPr>
+                        <a:t>◐ Se configurado</a:t>
+                      </a:r>
+                      <a:endParaRPr lang="en-US" sz="1100" dirty="0">
+                        <a:latin typeface="Calibri" charset="0"/>
+                        <a:ea typeface="Calibri" charset="0"/>
+                        <a:cs typeface="Calibri" charset="0"/>
+                      </a:endParaRPr>
+                    </a:p>
+                  </a:txBody>
+                  <a:tcPr marL="73152" marR="73152" marT="18288" marB="18288" anchor="ctr">
+                    <a:lnL w="6350" cap="flat" cmpd="sng" algn="ctr">
+                      <a:solidFill>
+                        <a:srgbClr val="EBE7E3"/>
+                      </a:solidFill>
+                      <a:prstDash val="solid"/>
+                      <a:round/>
+                      <a:headEnd type="none" w="med" len="med"/>
+                      <a:tailEnd type="none" w="med" len="med"/>
+                    </a:lnL>
+                    <a:lnR w="6350" cap="flat" cmpd="sng" algn="ctr">
+                      <a:solidFill>
+                        <a:srgbClr val="EBE7E3"/>
+                      </a:solidFill>
+                      <a:prstDash val="solid"/>
+                      <a:round/>
+                      <a:headEnd type="none" w="med" len="med"/>
+                      <a:tailEnd type="none" w="med" len="med"/>
+                    </a:lnR>
+                    <a:lnT w="6350" cap="flat" cmpd="sng" algn="ctr">
+                      <a:solidFill>
+                        <a:srgbClr val="EBE7E3"/>
+                      </a:solidFill>
+                      <a:prstDash val="solid"/>
+                      <a:round/>
+                      <a:headEnd type="none" w="med" len="med"/>
+                      <a:tailEnd type="none" w="med" len="med"/>
+                    </a:lnT>
+                    <a:lnB w="6350" cap="flat" cmpd="sng" algn="ctr">
+                      <a:solidFill>
+                        <a:srgbClr val="EBE7E3"/>
+                      </a:solidFill>
+                      <a:prstDash val="solid"/>
+                      <a:round/>
+                      <a:headEnd type="none" w="med" len="med"/>
+                      <a:tailEnd type="none" w="med" len="med"/>
+                    </a:lnB>
+                    <a:solidFill>
+                      <a:srgbClr val="FBEBC0"/>
+                    </a:solidFill>
+                  </a:tcPr>
+                </a:tc>
+                <a:tc>
+                  <a:txBody>
+                    <a:bodyPr/>
+                    <a:lstStyle/>
+                    <a:p>
+                      <a:pPr algn="ctr" indent="0" marL="0">
+                        <a:buNone/>
+                      </a:pPr>
+                      <a:r>
+                        <a:rPr lang="en-US" sz="1100" b="1" dirty="0">
+                          <a:solidFill>
+                            <a:srgbClr val="545814"/>
+                          </a:solidFill>
+                          <a:latin typeface="Calibri" pitchFamily="34" charset="0"/>
+                          <a:ea typeface="Calibri" pitchFamily="34" charset="-122"/>
+                          <a:cs typeface="Calibri" pitchFamily="34" charset="-120"/>
+                        </a:rPr>
+                        <a:t>✓ Sim</a:t>
+                      </a:r>
+                      <a:endParaRPr lang="en-US" sz="1100" dirty="0">
+                        <a:latin typeface="Calibri" charset="0"/>
+                        <a:ea typeface="Calibri" charset="0"/>
+                        <a:cs typeface="Calibri" charset="0"/>
+                      </a:endParaRPr>
+                    </a:p>
+                  </a:txBody>
+                  <a:tcPr marL="73152" marR="73152" marT="18288" marB="18288" anchor="ctr">
+                    <a:lnL w="6350" cap="flat" cmpd="sng" algn="ctr">
+                      <a:solidFill>
+                        <a:srgbClr val="EBE7E3"/>
+                      </a:solidFill>
+                      <a:prstDash val="solid"/>
+                      <a:round/>
+                      <a:headEnd type="none" w="med" len="med"/>
+                      <a:tailEnd type="none" w="med" len="med"/>
+                    </a:lnL>
+                    <a:lnR w="6350" cap="flat" cmpd="sng" algn="ctr">
+                      <a:solidFill>
+                        <a:srgbClr val="EBE7E3"/>
+                      </a:solidFill>
+                      <a:prstDash val="solid"/>
+                      <a:round/>
+                      <a:headEnd type="none" w="med" len="med"/>
+                      <a:tailEnd type="none" w="med" len="med"/>
+                    </a:lnR>
+                    <a:lnT w="6350" cap="flat" cmpd="sng" algn="ctr">
+                      <a:solidFill>
+                        <a:srgbClr val="EBE7E3"/>
+                      </a:solidFill>
+                      <a:prstDash val="solid"/>
+                      <a:round/>
+                      <a:headEnd type="none" w="med" len="med"/>
+                      <a:tailEnd type="none" w="med" len="med"/>
+                    </a:lnT>
+                    <a:lnB w="6350" cap="flat" cmpd="sng" algn="ctr">
+                      <a:solidFill>
+                        <a:srgbClr val="EBE7E3"/>
+                      </a:solidFill>
+                      <a:prstDash val="solid"/>
+                      <a:round/>
+                      <a:headEnd type="none" w="med" len="med"/>
+                      <a:tailEnd type="none" w="med" len="med"/>
+                    </a:lnB>
+                    <a:solidFill>
+                      <a:srgbClr val="E4E6C3"/>
+                    </a:solidFill>
+                  </a:tcPr>
+                </a:tc>
+              </a:tr>
+              <a:tr h="347472">
+                <a:tc>
+                  <a:txBody>
+                    <a:bodyPr/>
+                    <a:lstStyle/>
+                    <a:p>
+                      <a:pPr indent="0" marL="0">
+                        <a:buNone/>
+                      </a:pPr>
+                      <a:r>
+                        <a:rPr lang="en-US" sz="1200" dirty="0">
+                          <a:solidFill>
+                            <a:srgbClr val="2B1E1C"/>
+                          </a:solidFill>
+                          <a:latin typeface="Calibri" pitchFamily="34" charset="0"/>
+                          <a:ea typeface="Calibri" pitchFamily="34" charset="-122"/>
+                          <a:cs typeface="Calibri" pitchFamily="34" charset="-120"/>
+                        </a:rPr>
+                        <a:t>Ver as adesões e exportar as listas (Excel, PDF, CSV)</a:t>
+                      </a:r>
+                      <a:endParaRPr lang="en-US" sz="1200" dirty="0">
+                        <a:latin typeface="Calibri" charset="0"/>
+                        <a:ea typeface="Calibri" charset="0"/>
+                        <a:cs typeface="Calibri" charset="0"/>
+                      </a:endParaRPr>
+                    </a:p>
+                  </a:txBody>
+                  <a:tcPr marL="73152" marR="73152" marT="18288" marB="18288" anchor="ctr">
+                    <a:lnL w="6350" cap="flat" cmpd="sng" algn="ctr">
+                      <a:solidFill>
+                        <a:srgbClr val="EBE7E3"/>
+                      </a:solidFill>
+                      <a:prstDash val="solid"/>
+                      <a:round/>
+                      <a:headEnd type="none" w="med" len="med"/>
+                      <a:tailEnd type="none" w="med" len="med"/>
+                    </a:lnL>
+                    <a:lnR w="6350" cap="flat" cmpd="sng" algn="ctr">
+                      <a:solidFill>
+                        <a:srgbClr val="EBE7E3"/>
+                      </a:solidFill>
+                      <a:prstDash val="solid"/>
+                      <a:round/>
+                      <a:headEnd type="none" w="med" len="med"/>
+                      <a:tailEnd type="none" w="med" len="med"/>
+                    </a:lnR>
+                    <a:lnT w="6350" cap="flat" cmpd="sng" algn="ctr">
+                      <a:solidFill>
+                        <a:srgbClr val="EBE7E3"/>
+                      </a:solidFill>
+                      <a:prstDash val="solid"/>
+                      <a:round/>
+                      <a:headEnd type="none" w="med" len="med"/>
+                      <a:tailEnd type="none" w="med" len="med"/>
+                    </a:lnT>
+                    <a:lnB w="6350" cap="flat" cmpd="sng" algn="ctr">
+                      <a:solidFill>
+                        <a:srgbClr val="EBE7E3"/>
+                      </a:solidFill>
+                      <a:prstDash val="solid"/>
+                      <a:round/>
+                      <a:headEnd type="none" w="med" len="med"/>
+                      <a:tailEnd type="none" w="med" len="med"/>
+                    </a:lnB>
+                  </a:tcPr>
+                </a:tc>
+                <a:tc>
+                  <a:txBody>
+                    <a:bodyPr/>
+                    <a:lstStyle/>
+                    <a:p>
+                      <a:pPr algn="ctr" indent="0" marL="0">
+                        <a:buNone/>
+                      </a:pPr>
+                      <a:r>
+                        <a:rPr lang="en-US" sz="1100" b="1" dirty="0">
+                          <a:solidFill>
+                            <a:srgbClr val="545814"/>
+                          </a:solidFill>
+                          <a:latin typeface="Calibri" pitchFamily="34" charset="0"/>
+                          <a:ea typeface="Calibri" pitchFamily="34" charset="-122"/>
+                          <a:cs typeface="Calibri" pitchFamily="34" charset="-120"/>
+                        </a:rPr>
+                        <a:t>✓ Sim</a:t>
+                      </a:r>
+                      <a:endParaRPr lang="en-US" sz="1100" dirty="0">
+                        <a:latin typeface="Calibri" charset="0"/>
+                        <a:ea typeface="Calibri" charset="0"/>
+                        <a:cs typeface="Calibri" charset="0"/>
+                      </a:endParaRPr>
+                    </a:p>
+                  </a:txBody>
+                  <a:tcPr marL="73152" marR="73152" marT="18288" marB="18288" anchor="ctr">
+                    <a:lnL w="6350" cap="flat" cmpd="sng" algn="ctr">
+                      <a:solidFill>
+                        <a:srgbClr val="EBE7E3"/>
+                      </a:solidFill>
+                      <a:prstDash val="solid"/>
+                      <a:round/>
+                      <a:headEnd type="none" w="med" len="med"/>
+                      <a:tailEnd type="none" w="med" len="med"/>
+                    </a:lnL>
+                    <a:lnR w="6350" cap="flat" cmpd="sng" algn="ctr">
+                      <a:solidFill>
+                        <a:srgbClr val="EBE7E3"/>
+                      </a:solidFill>
+                      <a:prstDash val="solid"/>
+                      <a:round/>
+                      <a:headEnd type="none" w="med" len="med"/>
+                      <a:tailEnd type="none" w="med" len="med"/>
+                    </a:lnR>
+                    <a:lnT w="6350" cap="flat" cmpd="sng" algn="ctr">
+                      <a:solidFill>
+                        <a:srgbClr val="EBE7E3"/>
+                      </a:solidFill>
+                      <a:prstDash val="solid"/>
+                      <a:round/>
+                      <a:headEnd type="none" w="med" len="med"/>
+                      <a:tailEnd type="none" w="med" len="med"/>
+                    </a:lnT>
+                    <a:lnB w="6350" cap="flat" cmpd="sng" algn="ctr">
+                      <a:solidFill>
+                        <a:srgbClr val="EBE7E3"/>
+                      </a:solidFill>
+                      <a:prstDash val="solid"/>
+                      <a:round/>
+                      <a:headEnd type="none" w="med" len="med"/>
+                      <a:tailEnd type="none" w="med" len="med"/>
+                    </a:lnB>
+                    <a:solidFill>
+                      <a:srgbClr val="E4E6C3"/>
+                    </a:solidFill>
+                  </a:tcPr>
+                </a:tc>
+                <a:tc>
+                  <a:txBody>
+                    <a:bodyPr/>
+                    <a:lstStyle/>
+                    <a:p>
+                      <a:pPr algn="ctr" indent="0" marL="0">
+                        <a:buNone/>
+                      </a:pPr>
+                      <a:r>
+                        <a:rPr lang="en-US" sz="1100" b="1" dirty="0">
+                          <a:solidFill>
+                            <a:srgbClr val="6B4E00"/>
+                          </a:solidFill>
+                          <a:latin typeface="Calibri" pitchFamily="34" charset="0"/>
+                          <a:ea typeface="Calibri" pitchFamily="34" charset="-122"/>
+                          <a:cs typeface="Calibri" pitchFamily="34" charset="-120"/>
+                        </a:rPr>
+                        <a:t>◐ Se configurado</a:t>
+                      </a:r>
+                      <a:endParaRPr lang="en-US" sz="1100" dirty="0">
+                        <a:latin typeface="Calibri" charset="0"/>
+                        <a:ea typeface="Calibri" charset="0"/>
+                        <a:cs typeface="Calibri" charset="0"/>
+                      </a:endParaRPr>
+                    </a:p>
+                  </a:txBody>
+                  <a:tcPr marL="73152" marR="73152" marT="18288" marB="18288" anchor="ctr">
+                    <a:lnL w="6350" cap="flat" cmpd="sng" algn="ctr">
+                      <a:solidFill>
+                        <a:srgbClr val="EBE7E3"/>
+                      </a:solidFill>
+                      <a:prstDash val="solid"/>
+                      <a:round/>
+                      <a:headEnd type="none" w="med" len="med"/>
+                      <a:tailEnd type="none" w="med" len="med"/>
+                    </a:lnL>
+                    <a:lnR w="6350" cap="flat" cmpd="sng" algn="ctr">
+                      <a:solidFill>
+                        <a:srgbClr val="EBE7E3"/>
+                      </a:solidFill>
+                      <a:prstDash val="solid"/>
+                      <a:round/>
+                      <a:headEnd type="none" w="med" len="med"/>
+                      <a:tailEnd type="none" w="med" len="med"/>
+                    </a:lnR>
+                    <a:lnT w="6350" cap="flat" cmpd="sng" algn="ctr">
+                      <a:solidFill>
+                        <a:srgbClr val="EBE7E3"/>
+                      </a:solidFill>
+                      <a:prstDash val="solid"/>
+                      <a:round/>
+                      <a:headEnd type="none" w="med" len="med"/>
+                      <a:tailEnd type="none" w="med" len="med"/>
+                    </a:lnT>
+                    <a:lnB w="6350" cap="flat" cmpd="sng" algn="ctr">
+                      <a:solidFill>
+                        <a:srgbClr val="EBE7E3"/>
+                      </a:solidFill>
+                      <a:prstDash val="solid"/>
+                      <a:round/>
+                      <a:headEnd type="none" w="med" len="med"/>
+                      <a:tailEnd type="none" w="med" len="med"/>
+                    </a:lnB>
+                    <a:solidFill>
+                      <a:srgbClr val="FBEBC0"/>
+                    </a:solidFill>
+                  </a:tcPr>
+                </a:tc>
+                <a:tc>
+                  <a:txBody>
+                    <a:bodyPr/>
+                    <a:lstStyle/>
+                    <a:p>
+                      <a:pPr algn="ctr" indent="0" marL="0">
+                        <a:buNone/>
+                      </a:pPr>
+                      <a:r>
+                        <a:rPr lang="en-US" sz="1100" b="1" dirty="0">
+                          <a:solidFill>
+                            <a:srgbClr val="6B4E00"/>
+                          </a:solidFill>
+                          <a:latin typeface="Calibri" pitchFamily="34" charset="0"/>
+                          <a:ea typeface="Calibri" pitchFamily="34" charset="-122"/>
+                          <a:cs typeface="Calibri" pitchFamily="34" charset="-120"/>
+                        </a:rPr>
+                        <a:t>◐ Se configurado</a:t>
+                      </a:r>
+                      <a:endParaRPr lang="en-US" sz="1100" dirty="0">
+                        <a:latin typeface="Calibri" charset="0"/>
+                        <a:ea typeface="Calibri" charset="0"/>
+                        <a:cs typeface="Calibri" charset="0"/>
+                      </a:endParaRPr>
+                    </a:p>
+                  </a:txBody>
+                  <a:tcPr marL="73152" marR="73152" marT="18288" marB="18288" anchor="ctr">
+                    <a:lnL w="6350" cap="flat" cmpd="sng" algn="ctr">
+                      <a:solidFill>
+                        <a:srgbClr val="EBE7E3"/>
+                      </a:solidFill>
+                      <a:prstDash val="solid"/>
+                      <a:round/>
+                      <a:headEnd type="none" w="med" len="med"/>
+                      <a:tailEnd type="none" w="med" len="med"/>
+                    </a:lnL>
+                    <a:lnR w="6350" cap="flat" cmpd="sng" algn="ctr">
+                      <a:solidFill>
+                        <a:srgbClr val="EBE7E3"/>
+                      </a:solidFill>
+                      <a:prstDash val="solid"/>
+                      <a:round/>
+                      <a:headEnd type="none" w="med" len="med"/>
+                      <a:tailEnd type="none" w="med" len="med"/>
+                    </a:lnR>
+                    <a:lnT w="6350" cap="flat" cmpd="sng" algn="ctr">
+                      <a:solidFill>
+                        <a:srgbClr val="EBE7E3"/>
+                      </a:solidFill>
+                      <a:prstDash val="solid"/>
+                      <a:round/>
+                      <a:headEnd type="none" w="med" len="med"/>
+                      <a:tailEnd type="none" w="med" len="med"/>
+                    </a:lnT>
+                    <a:lnB w="6350" cap="flat" cmpd="sng" algn="ctr">
+                      <a:solidFill>
+                        <a:srgbClr val="EBE7E3"/>
+                      </a:solidFill>
+                      <a:prstDash val="solid"/>
+                      <a:round/>
+                      <a:headEnd type="none" w="med" len="med"/>
+                      <a:tailEnd type="none" w="med" len="med"/>
+                    </a:lnB>
+                    <a:solidFill>
+                      <a:srgbClr val="FBEBC0"/>
+                    </a:solidFill>
+                  </a:tcPr>
+                </a:tc>
+                <a:tc>
+                  <a:txBody>
+                    <a:bodyPr/>
+                    <a:lstStyle/>
+                    <a:p>
+                      <a:pPr algn="ctr" indent="0" marL="0">
+                        <a:buNone/>
+                      </a:pPr>
+                      <a:r>
+                        <a:rPr lang="en-US" sz="1100" b="1" dirty="0">
+                          <a:solidFill>
+                            <a:srgbClr val="6B4E00"/>
+                          </a:solidFill>
+                          <a:latin typeface="Calibri" pitchFamily="34" charset="0"/>
+                          <a:ea typeface="Calibri" pitchFamily="34" charset="-122"/>
+                          <a:cs typeface="Calibri" pitchFamily="34" charset="-120"/>
+                        </a:rPr>
+                        <a:t>◐ Se configurado</a:t>
+                      </a:r>
+                      <a:endParaRPr lang="en-US" sz="1100" dirty="0">
+                        <a:latin typeface="Calibri" charset="0"/>
+                        <a:ea typeface="Calibri" charset="0"/>
+                        <a:cs typeface="Calibri" charset="0"/>
+                      </a:endParaRPr>
+                    </a:p>
+                  </a:txBody>
+                  <a:tcPr marL="73152" marR="73152" marT="18288" marB="18288" anchor="ctr">
+                    <a:lnL w="6350" cap="flat" cmpd="sng" algn="ctr">
+                      <a:solidFill>
+                        <a:srgbClr val="EBE7E3"/>
+                      </a:solidFill>
+                      <a:prstDash val="solid"/>
+                      <a:round/>
+                      <a:headEnd type="none" w="med" len="med"/>
+                      <a:tailEnd type="none" w="med" len="med"/>
+                    </a:lnL>
+                    <a:lnR w="6350" cap="flat" cmpd="sng" algn="ctr">
+                      <a:solidFill>
+                        <a:srgbClr val="EBE7E3"/>
+                      </a:solidFill>
+                      <a:prstDash val="solid"/>
+                      <a:round/>
+                      <a:headEnd type="none" w="med" len="med"/>
+                      <a:tailEnd type="none" w="med" len="med"/>
+                    </a:lnR>
+                    <a:lnT w="6350" cap="flat" cmpd="sng" algn="ctr">
+                      <a:solidFill>
+                        <a:srgbClr val="EBE7E3"/>
+                      </a:solidFill>
+                      <a:prstDash val="solid"/>
+                      <a:round/>
+                      <a:headEnd type="none" w="med" len="med"/>
+                      <a:tailEnd type="none" w="med" len="med"/>
+                    </a:lnT>
+                    <a:lnB w="6350" cap="flat" cmpd="sng" algn="ctr">
+                      <a:solidFill>
+                        <a:srgbClr val="EBE7E3"/>
+                      </a:solidFill>
+                      <a:prstDash val="solid"/>
+                      <a:round/>
+                      <a:headEnd type="none" w="med" len="med"/>
+                      <a:tailEnd type="none" w="med" len="med"/>
+                    </a:lnB>
+                    <a:solidFill>
+                      <a:srgbClr val="FBEBC0"/>
+                    </a:solidFill>
+                  </a:tcPr>
+                </a:tc>
+                <a:tc>
+                  <a:txBody>
+                    <a:bodyPr/>
+                    <a:lstStyle/>
+                    <a:p>
+                      <a:pPr algn="ctr" indent="0" marL="0">
+                        <a:buNone/>
+                      </a:pPr>
+                      <a:r>
+                        <a:rPr lang="en-US" sz="1100" b="1" dirty="0">
+                          <a:solidFill>
+                            <a:srgbClr val="6B4E00"/>
+                          </a:solidFill>
+                          <a:latin typeface="Calibri" pitchFamily="34" charset="0"/>
+                          <a:ea typeface="Calibri" pitchFamily="34" charset="-122"/>
+                          <a:cs typeface="Calibri" pitchFamily="34" charset="-120"/>
+                        </a:rPr>
+                        <a:t>◐ Se configurado</a:t>
+                      </a:r>
+                      <a:endParaRPr lang="en-US" sz="1100" dirty="0">
+                        <a:latin typeface="Calibri" charset="0"/>
+                        <a:ea typeface="Calibri" charset="0"/>
+                        <a:cs typeface="Calibri" charset="0"/>
+                      </a:endParaRPr>
+                    </a:p>
+                  </a:txBody>
+                  <a:tcPr marL="73152" marR="73152" marT="18288" marB="18288" anchor="ctr">
+                    <a:lnL w="6350" cap="flat" cmpd="sng" algn="ctr">
+                      <a:solidFill>
+                        <a:srgbClr val="EBE7E3"/>
+                      </a:solidFill>
+                      <a:prstDash val="solid"/>
+                      <a:round/>
+                      <a:headEnd type="none" w="med" len="med"/>
+                      <a:tailEnd type="none" w="med" len="med"/>
+                    </a:lnL>
+                    <a:lnR w="6350" cap="flat" cmpd="sng" algn="ctr">
+                      <a:solidFill>
+                        <a:srgbClr val="EBE7E3"/>
+                      </a:solidFill>
+                      <a:prstDash val="solid"/>
+                      <a:round/>
+                      <a:headEnd type="none" w="med" len="med"/>
+                      <a:tailEnd type="none" w="med" len="med"/>
+                    </a:lnR>
+                    <a:lnT w="6350" cap="flat" cmpd="sng" algn="ctr">
+                      <a:solidFill>
+                        <a:srgbClr val="EBE7E3"/>
+                      </a:solidFill>
+                      <a:prstDash val="solid"/>
+                      <a:round/>
+                      <a:headEnd type="none" w="med" len="med"/>
+                      <a:tailEnd type="none" w="med" len="med"/>
+                    </a:lnT>
+                    <a:lnB w="6350" cap="flat" cmpd="sng" algn="ctr">
+                      <a:solidFill>
+                        <a:srgbClr val="EBE7E3"/>
+                      </a:solidFill>
+                      <a:prstDash val="solid"/>
+                      <a:round/>
+                      <a:headEnd type="none" w="med" len="med"/>
+                      <a:tailEnd type="none" w="med" len="med"/>
+                    </a:lnB>
+                    <a:solidFill>
+                      <a:srgbClr val="FBEBC0"/>
+                    </a:solidFill>
+                  </a:tcPr>
+                </a:tc>
+                <a:tc>
+                  <a:txBody>
+                    <a:bodyPr/>
+                    <a:lstStyle/>
+                    <a:p>
+                      <a:pPr algn="ctr" indent="0" marL="0">
+                        <a:buNone/>
+                      </a:pPr>
+                      <a:r>
+                        <a:rPr lang="en-US" sz="1100" b="1" dirty="0">
+                          <a:solidFill>
+                            <a:srgbClr val="545814"/>
+                          </a:solidFill>
+                          <a:latin typeface="Calibri" pitchFamily="34" charset="0"/>
+                          <a:ea typeface="Calibri" pitchFamily="34" charset="-122"/>
+                          <a:cs typeface="Calibri" pitchFamily="34" charset="-120"/>
+                        </a:rPr>
+                        <a:t>✓ Sim</a:t>
+                      </a:r>
+                      <a:endParaRPr lang="en-US" sz="1100" dirty="0">
+                        <a:latin typeface="Calibri" charset="0"/>
+                        <a:ea typeface="Calibri" charset="0"/>
+                        <a:cs typeface="Calibri" charset="0"/>
+                      </a:endParaRPr>
+                    </a:p>
+                  </a:txBody>
+                  <a:tcPr marL="73152" marR="73152" marT="18288" marB="18288" anchor="ctr">
+                    <a:lnL w="6350" cap="flat" cmpd="sng" algn="ctr">
+                      <a:solidFill>
+                        <a:srgbClr val="EBE7E3"/>
+                      </a:solidFill>
+                      <a:prstDash val="solid"/>
+                      <a:round/>
+                      <a:headEnd type="none" w="med" len="med"/>
+                      <a:tailEnd type="none" w="med" len="med"/>
+                    </a:lnL>
+                    <a:lnR w="6350" cap="flat" cmpd="sng" algn="ctr">
+                      <a:solidFill>
+                        <a:srgbClr val="EBE7E3"/>
+                      </a:solidFill>
+                      <a:prstDash val="solid"/>
+                      <a:round/>
+                      <a:headEnd type="none" w="med" len="med"/>
+                      <a:tailEnd type="none" w="med" len="med"/>
+                    </a:lnR>
+                    <a:lnT w="6350" cap="flat" cmpd="sng" algn="ctr">
+                      <a:solidFill>
+                        <a:srgbClr val="EBE7E3"/>
+                      </a:solidFill>
+                      <a:prstDash val="solid"/>
+                      <a:round/>
+                      <a:headEnd type="none" w="med" len="med"/>
+                      <a:tailEnd type="none" w="med" len="med"/>
+                    </a:lnT>
+                    <a:lnB w="6350" cap="flat" cmpd="sng" algn="ctr">
+                      <a:solidFill>
+                        <a:srgbClr val="EBE7E3"/>
+                      </a:solidFill>
+                      <a:prstDash val="solid"/>
+                      <a:round/>
+                      <a:headEnd type="none" w="med" len="med"/>
+                      <a:tailEnd type="none" w="med" len="med"/>
+                    </a:lnB>
+                    <a:solidFill>
+                      <a:srgbClr val="E4E6C3"/>
+                    </a:solidFill>
+                  </a:tcPr>
+                </a:tc>
+              </a:tr>
+              <a:tr h="347472">
+                <a:tc>
+                  <a:txBody>
+                    <a:bodyPr/>
+                    <a:lstStyle/>
+                    <a:p>
+                      <a:pPr indent="0" marL="0">
+                        <a:buNone/>
+                      </a:pPr>
+                      <a:r>
+                        <a:rPr lang="en-US" sz="1200" dirty="0">
+                          <a:solidFill>
+                            <a:srgbClr val="2B1E1C"/>
+                          </a:solidFill>
+                          <a:latin typeface="Calibri" pitchFamily="34" charset="0"/>
+                          <a:ea typeface="Calibri" pitchFamily="34" charset="-122"/>
+                          <a:cs typeface="Calibri" pitchFamily="34" charset="-120"/>
+                        </a:rPr>
+                        <a:t>Ver as leituras e as fotos do hidrômetro de todas as casas</a:t>
+                      </a:r>
+                      <a:endParaRPr lang="en-US" sz="1200" dirty="0">
+                        <a:latin typeface="Calibri" charset="0"/>
+                        <a:ea typeface="Calibri" charset="0"/>
+                        <a:cs typeface="Calibri" charset="0"/>
+                      </a:endParaRPr>
+                    </a:p>
+                  </a:txBody>
+                  <a:tcPr marL="73152" marR="73152" marT="18288" marB="18288" anchor="ctr">
+                    <a:lnL w="6350" cap="flat" cmpd="sng" algn="ctr">
+                      <a:solidFill>
+                        <a:srgbClr val="EBE7E3"/>
+                      </a:solidFill>
+                      <a:prstDash val="solid"/>
+                      <a:round/>
+                      <a:headEnd type="none" w="med" len="med"/>
+                      <a:tailEnd type="none" w="med" len="med"/>
+                    </a:lnL>
+                    <a:lnR w="6350" cap="flat" cmpd="sng" algn="ctr">
+                      <a:solidFill>
+                        <a:srgbClr val="EBE7E3"/>
+                      </a:solidFill>
+                      <a:prstDash val="solid"/>
+                      <a:round/>
+                      <a:headEnd type="none" w="med" len="med"/>
+                      <a:tailEnd type="none" w="med" len="med"/>
+                    </a:lnR>
+                    <a:lnT w="6350" cap="flat" cmpd="sng" algn="ctr">
+                      <a:solidFill>
+                        <a:srgbClr val="EBE7E3"/>
+                      </a:solidFill>
+                      <a:prstDash val="solid"/>
+                      <a:round/>
+                      <a:headEnd type="none" w="med" len="med"/>
+                      <a:tailEnd type="none" w="med" len="med"/>
+                    </a:lnT>
+                    <a:lnB w="6350" cap="flat" cmpd="sng" algn="ctr">
+                      <a:solidFill>
+                        <a:srgbClr val="EBE7E3"/>
+                      </a:solidFill>
+                      <a:prstDash val="solid"/>
+                      <a:round/>
+                      <a:headEnd type="none" w="med" len="med"/>
+                      <a:tailEnd type="none" w="med" len="med"/>
+                    </a:lnB>
+                  </a:tcPr>
+                </a:tc>
+                <a:tc>
+                  <a:txBody>
+                    <a:bodyPr/>
+                    <a:lstStyle/>
+                    <a:p>
+                      <a:pPr algn="ctr" indent="0" marL="0">
+                        <a:buNone/>
+                      </a:pPr>
+                      <a:r>
+                        <a:rPr lang="en-US" sz="1100" b="1" dirty="0">
+                          <a:solidFill>
+                            <a:srgbClr val="545814"/>
+                          </a:solidFill>
+                          <a:latin typeface="Calibri" pitchFamily="34" charset="0"/>
+                          <a:ea typeface="Calibri" pitchFamily="34" charset="-122"/>
+                          <a:cs typeface="Calibri" pitchFamily="34" charset="-120"/>
+                        </a:rPr>
+                        <a:t>✓ Sim</a:t>
+                      </a:r>
+                      <a:endParaRPr lang="en-US" sz="1100" dirty="0">
+                        <a:latin typeface="Calibri" charset="0"/>
+                        <a:ea typeface="Calibri" charset="0"/>
+                        <a:cs typeface="Calibri" charset="0"/>
+                      </a:endParaRPr>
+                    </a:p>
+                  </a:txBody>
+                  <a:tcPr marL="73152" marR="73152" marT="18288" marB="18288" anchor="ctr">
+                    <a:lnL w="6350" cap="flat" cmpd="sng" algn="ctr">
+                      <a:solidFill>
+                        <a:srgbClr val="EBE7E3"/>
+                      </a:solidFill>
+                      <a:prstDash val="solid"/>
+                      <a:round/>
+                      <a:headEnd type="none" w="med" len="med"/>
+                      <a:tailEnd type="none" w="med" len="med"/>
+                    </a:lnL>
+                    <a:lnR w="6350" cap="flat" cmpd="sng" algn="ctr">
+                      <a:solidFill>
+                        <a:srgbClr val="EBE7E3"/>
+                      </a:solidFill>
+                      <a:prstDash val="solid"/>
+                      <a:round/>
+                      <a:headEnd type="none" w="med" len="med"/>
+                      <a:tailEnd type="none" w="med" len="med"/>
+                    </a:lnR>
+                    <a:lnT w="6350" cap="flat" cmpd="sng" algn="ctr">
+                      <a:solidFill>
+                        <a:srgbClr val="EBE7E3"/>
+                      </a:solidFill>
+                      <a:prstDash val="solid"/>
+                      <a:round/>
+                      <a:headEnd type="none" w="med" len="med"/>
+                      <a:tailEnd type="none" w="med" len="med"/>
+                    </a:lnT>
+                    <a:lnB w="6350" cap="flat" cmpd="sng" algn="ctr">
+                      <a:solidFill>
+                        <a:srgbClr val="EBE7E3"/>
+                      </a:solidFill>
+                      <a:prstDash val="solid"/>
+                      <a:round/>
+                      <a:headEnd type="none" w="med" len="med"/>
+                      <a:tailEnd type="none" w="med" len="med"/>
+                    </a:lnB>
+                    <a:solidFill>
+                      <a:srgbClr val="E4E6C3"/>
+                    </a:solidFill>
+                  </a:tcPr>
+                </a:tc>
+                <a:tc>
+                  <a:txBody>
+                    <a:bodyPr/>
+                    <a:lstStyle/>
+                    <a:p>
+                      <a:pPr algn="ctr" indent="0" marL="0">
+                        <a:buNone/>
+                      </a:pPr>
+                      <a:r>
+                        <a:rPr lang="en-US" sz="1100" b="1" dirty="0">
+                          <a:solidFill>
+                            <a:srgbClr val="545814"/>
+                          </a:solidFill>
+                          <a:latin typeface="Calibri" pitchFamily="34" charset="0"/>
+                          <a:ea typeface="Calibri" pitchFamily="34" charset="-122"/>
+                          <a:cs typeface="Calibri" pitchFamily="34" charset="-120"/>
+                        </a:rPr>
+                        <a:t>✓ Sim</a:t>
+                      </a:r>
+                      <a:endParaRPr lang="en-US" sz="1100" dirty="0">
+                        <a:latin typeface="Calibri" charset="0"/>
+                        <a:ea typeface="Calibri" charset="0"/>
+                        <a:cs typeface="Calibri" charset="0"/>
+                      </a:endParaRPr>
+                    </a:p>
+                  </a:txBody>
+                  <a:tcPr marL="73152" marR="73152" marT="18288" marB="18288" anchor="ctr">
+                    <a:lnL w="6350" cap="flat" cmpd="sng" algn="ctr">
+                      <a:solidFill>
+                        <a:srgbClr val="EBE7E3"/>
+                      </a:solidFill>
+                      <a:prstDash val="solid"/>
+                      <a:round/>
+                      <a:headEnd type="none" w="med" len="med"/>
+                      <a:tailEnd type="none" w="med" len="med"/>
+                    </a:lnL>
+                    <a:lnR w="6350" cap="flat" cmpd="sng" algn="ctr">
+                      <a:solidFill>
+                        <a:srgbClr val="EBE7E3"/>
+                      </a:solidFill>
+                      <a:prstDash val="solid"/>
+                      <a:round/>
+                      <a:headEnd type="none" w="med" len="med"/>
+                      <a:tailEnd type="none" w="med" len="med"/>
+                    </a:lnR>
+                    <a:lnT w="6350" cap="flat" cmpd="sng" algn="ctr">
+                      <a:solidFill>
+                        <a:srgbClr val="EBE7E3"/>
+                      </a:solidFill>
+                      <a:prstDash val="solid"/>
+                      <a:round/>
+                      <a:headEnd type="none" w="med" len="med"/>
+                      <a:tailEnd type="none" w="med" len="med"/>
+                    </a:lnT>
+                    <a:lnB w="6350" cap="flat" cmpd="sng" algn="ctr">
+                      <a:solidFill>
+                        <a:srgbClr val="EBE7E3"/>
+                      </a:solidFill>
+                      <a:prstDash val="solid"/>
+                      <a:round/>
+                      <a:headEnd type="none" w="med" len="med"/>
+                      <a:tailEnd type="none" w="med" len="med"/>
+                    </a:lnB>
+                    <a:solidFill>
+                      <a:srgbClr val="E4E6C3"/>
+                    </a:solidFill>
+                  </a:tcPr>
+                </a:tc>
+                <a:tc>
+                  <a:txBody>
+                    <a:bodyPr/>
+                    <a:lstStyle/>
+                    <a:p>
+                      <a:pPr algn="ctr" indent="0" marL="0">
+                        <a:buNone/>
+                      </a:pPr>
+                      <a:r>
+                        <a:rPr lang="en-US" sz="1100" b="1" dirty="0">
+                          <a:solidFill>
+                            <a:srgbClr val="545814"/>
+                          </a:solidFill>
+                          <a:latin typeface="Calibri" pitchFamily="34" charset="0"/>
+                          <a:ea typeface="Calibri" pitchFamily="34" charset="-122"/>
+                          <a:cs typeface="Calibri" pitchFamily="34" charset="-120"/>
+                        </a:rPr>
+                        <a:t>✓ Sim</a:t>
+                      </a:r>
+                      <a:endParaRPr lang="en-US" sz="1100" dirty="0">
+                        <a:latin typeface="Calibri" charset="0"/>
+                        <a:ea typeface="Calibri" charset="0"/>
+                        <a:cs typeface="Calibri" charset="0"/>
+                      </a:endParaRPr>
+                    </a:p>
+                  </a:txBody>
+                  <a:tcPr marL="73152" marR="73152" marT="18288" marB="18288" anchor="ctr">
+                    <a:lnL w="6350" cap="flat" cmpd="sng" algn="ctr">
+                      <a:solidFill>
+                        <a:srgbClr val="EBE7E3"/>
+                      </a:solidFill>
+                      <a:prstDash val="solid"/>
+                      <a:round/>
+                      <a:headEnd type="none" w="med" len="med"/>
+                      <a:tailEnd type="none" w="med" len="med"/>
+                    </a:lnL>
+                    <a:lnR w="6350" cap="flat" cmpd="sng" algn="ctr">
+                      <a:solidFill>
+                        <a:srgbClr val="EBE7E3"/>
+                      </a:solidFill>
+                      <a:prstDash val="solid"/>
+                      <a:round/>
+                      <a:headEnd type="none" w="med" len="med"/>
+                      <a:tailEnd type="none" w="med" len="med"/>
+                    </a:lnR>
+                    <a:lnT w="6350" cap="flat" cmpd="sng" algn="ctr">
+                      <a:solidFill>
+                        <a:srgbClr val="EBE7E3"/>
+                      </a:solidFill>
+                      <a:prstDash val="solid"/>
+                      <a:round/>
+                      <a:headEnd type="none" w="med" len="med"/>
+                      <a:tailEnd type="none" w="med" len="med"/>
+                    </a:lnT>
+                    <a:lnB w="6350" cap="flat" cmpd="sng" algn="ctr">
+                      <a:solidFill>
+                        <a:srgbClr val="EBE7E3"/>
+                      </a:solidFill>
+                      <a:prstDash val="solid"/>
+                      <a:round/>
+                      <a:headEnd type="none" w="med" len="med"/>
+                      <a:tailEnd type="none" w="med" len="med"/>
+                    </a:lnB>
+                    <a:solidFill>
+                      <a:srgbClr val="E4E6C3"/>
+                    </a:solidFill>
+                  </a:tcPr>
+                </a:tc>
+                <a:tc>
+                  <a:txBody>
+                    <a:bodyPr/>
+                    <a:lstStyle/>
+                    <a:p>
+                      <a:pPr algn="ctr" indent="0" marL="0">
+                        <a:buNone/>
+                      </a:pPr>
+                      <a:r>
+                        <a:rPr lang="en-US" sz="1100" b="1" dirty="0">
+                          <a:solidFill>
+                            <a:srgbClr val="545814"/>
+                          </a:solidFill>
+                          <a:latin typeface="Calibri" pitchFamily="34" charset="0"/>
+                          <a:ea typeface="Calibri" pitchFamily="34" charset="-122"/>
+                          <a:cs typeface="Calibri" pitchFamily="34" charset="-120"/>
+                        </a:rPr>
+                        <a:t>✓ Sim</a:t>
+                      </a:r>
+                      <a:endParaRPr lang="en-US" sz="1100" dirty="0">
+                        <a:latin typeface="Calibri" charset="0"/>
+                        <a:ea typeface="Calibri" charset="0"/>
+                        <a:cs typeface="Calibri" charset="0"/>
+                      </a:endParaRPr>
+                    </a:p>
+                  </a:txBody>
+                  <a:tcPr marL="73152" marR="73152" marT="18288" marB="18288" anchor="ctr">
+                    <a:lnL w="6350" cap="flat" cmpd="sng" algn="ctr">
+                      <a:solidFill>
+                        <a:srgbClr val="EBE7E3"/>
+                      </a:solidFill>
+                      <a:prstDash val="solid"/>
+                      <a:round/>
+                      <a:headEnd type="none" w="med" len="med"/>
+                      <a:tailEnd type="none" w="med" len="med"/>
+                    </a:lnL>
+                    <a:lnR w="6350" cap="flat" cmpd="sng" algn="ctr">
+                      <a:solidFill>
+                        <a:srgbClr val="EBE7E3"/>
+                      </a:solidFill>
+                      <a:prstDash val="solid"/>
+                      <a:round/>
+                      <a:headEnd type="none" w="med" len="med"/>
+                      <a:tailEnd type="none" w="med" len="med"/>
+                    </a:lnR>
+                    <a:lnT w="6350" cap="flat" cmpd="sng" algn="ctr">
+                      <a:solidFill>
+                        <a:srgbClr val="EBE7E3"/>
+                      </a:solidFill>
+                      <a:prstDash val="solid"/>
+                      <a:round/>
+                      <a:headEnd type="none" w="med" len="med"/>
+                      <a:tailEnd type="none" w="med" len="med"/>
+                    </a:lnT>
+                    <a:lnB w="6350" cap="flat" cmpd="sng" algn="ctr">
+                      <a:solidFill>
+                        <a:srgbClr val="EBE7E3"/>
+                      </a:solidFill>
+                      <a:prstDash val="solid"/>
+                      <a:round/>
+                      <a:headEnd type="none" w="med" len="med"/>
+                      <a:tailEnd type="none" w="med" len="med"/>
+                    </a:lnB>
+                    <a:solidFill>
+                      <a:srgbClr val="E4E6C3"/>
+                    </a:solidFill>
+                  </a:tcPr>
+                </a:tc>
+                <a:tc>
+                  <a:txBody>
+                    <a:bodyPr/>
+                    <a:lstStyle/>
+                    <a:p>
+                      <a:pPr algn="ctr" indent="0" marL="0">
+                        <a:buNone/>
+                      </a:pPr>
+                      <a:r>
+                        <a:rPr lang="en-US" sz="1100" b="1" dirty="0">
+                          <a:solidFill>
+                            <a:srgbClr val="545814"/>
+                          </a:solidFill>
+                          <a:latin typeface="Calibri" pitchFamily="34" charset="0"/>
+                          <a:ea typeface="Calibri" pitchFamily="34" charset="-122"/>
+                          <a:cs typeface="Calibri" pitchFamily="34" charset="-120"/>
+                        </a:rPr>
+                        <a:t>✓ Sim</a:t>
+                      </a:r>
+                      <a:endParaRPr lang="en-US" sz="1100" dirty="0">
+                        <a:latin typeface="Calibri" charset="0"/>
+                        <a:ea typeface="Calibri" charset="0"/>
+                        <a:cs typeface="Calibri" charset="0"/>
+                      </a:endParaRPr>
+                    </a:p>
+                  </a:txBody>
+                  <a:tcPr marL="73152" marR="73152" marT="18288" marB="18288" anchor="ctr">
+                    <a:lnL w="6350" cap="flat" cmpd="sng" algn="ctr">
+                      <a:solidFill>
+                        <a:srgbClr val="EBE7E3"/>
+                      </a:solidFill>
+                      <a:prstDash val="solid"/>
+                      <a:round/>
+                      <a:headEnd type="none" w="med" len="med"/>
+                      <a:tailEnd type="none" w="med" len="med"/>
+                    </a:lnL>
+                    <a:lnR w="6350" cap="flat" cmpd="sng" algn="ctr">
+                      <a:solidFill>
+                        <a:srgbClr val="EBE7E3"/>
+                      </a:solidFill>
+                      <a:prstDash val="solid"/>
+                      <a:round/>
+                      <a:headEnd type="none" w="med" len="med"/>
+                      <a:tailEnd type="none" w="med" len="med"/>
+                    </a:lnR>
+                    <a:lnT w="6350" cap="flat" cmpd="sng" algn="ctr">
+                      <a:solidFill>
+                        <a:srgbClr val="EBE7E3"/>
+                      </a:solidFill>
+                      <a:prstDash val="solid"/>
+                      <a:round/>
+                      <a:headEnd type="none" w="med" len="med"/>
+                      <a:tailEnd type="none" w="med" len="med"/>
+                    </a:lnT>
+                    <a:lnB w="6350" cap="flat" cmpd="sng" algn="ctr">
+                      <a:solidFill>
+                        <a:srgbClr val="EBE7E3"/>
+                      </a:solidFill>
+                      <a:prstDash val="solid"/>
+                      <a:round/>
+                      <a:headEnd type="none" w="med" len="med"/>
+                      <a:tailEnd type="none" w="med" len="med"/>
+                    </a:lnB>
+                    <a:solidFill>
+                      <a:srgbClr val="E4E6C3"/>
+                    </a:solidFill>
+                  </a:tcPr>
+                </a:tc>
+                <a:tc>
+                  <a:txBody>
+                    <a:bodyPr/>
+                    <a:lstStyle/>
+                    <a:p>
+                      <a:pPr algn="ctr" indent="0" marL="0">
+                        <a:buNone/>
+                      </a:pPr>
+                      <a:r>
+                        <a:rPr lang="en-US" sz="1100" b="1" dirty="0">
+                          <a:solidFill>
+                            <a:srgbClr val="545814"/>
+                          </a:solidFill>
+                          <a:latin typeface="Calibri" pitchFamily="34" charset="0"/>
+                          <a:ea typeface="Calibri" pitchFamily="34" charset="-122"/>
+                          <a:cs typeface="Calibri" pitchFamily="34" charset="-120"/>
+                        </a:rPr>
+                        <a:t>✓ Sim</a:t>
+                      </a:r>
+                      <a:endParaRPr lang="en-US" sz="1100" dirty="0">
+                        <a:latin typeface="Calibri" charset="0"/>
+                        <a:ea typeface="Calibri" charset="0"/>
+                        <a:cs typeface="Calibri" charset="0"/>
+                      </a:endParaRPr>
+                    </a:p>
+                  </a:txBody>
+                  <a:tcPr marL="73152" marR="73152" marT="18288" marB="18288" anchor="ctr">
+                    <a:lnL w="6350" cap="flat" cmpd="sng" algn="ctr">
+                      <a:solidFill>
+                        <a:srgbClr val="EBE7E3"/>
+                      </a:solidFill>
+                      <a:prstDash val="solid"/>
+                      <a:round/>
+                      <a:headEnd type="none" w="med" len="med"/>
+                      <a:tailEnd type="none" w="med" len="med"/>
+                    </a:lnL>
+                    <a:lnR w="6350" cap="flat" cmpd="sng" algn="ctr">
+                      <a:solidFill>
+                        <a:srgbClr val="EBE7E3"/>
+                      </a:solidFill>
+                      <a:prstDash val="solid"/>
+                      <a:round/>
+                      <a:headEnd type="none" w="med" len="med"/>
+                      <a:tailEnd type="none" w="med" len="med"/>
+                    </a:lnR>
+                    <a:lnT w="6350" cap="flat" cmpd="sng" algn="ctr">
+                      <a:solidFill>
+                        <a:srgbClr val="EBE7E3"/>
+                      </a:solidFill>
+                      <a:prstDash val="solid"/>
+                      <a:round/>
+                      <a:headEnd type="none" w="med" len="med"/>
+                      <a:tailEnd type="none" w="med" len="med"/>
+                    </a:lnT>
+                    <a:lnB w="6350" cap="flat" cmpd="sng" algn="ctr">
+                      <a:solidFill>
+                        <a:srgbClr val="EBE7E3"/>
+                      </a:solidFill>
+                      <a:prstDash val="solid"/>
+                      <a:round/>
+                      <a:headEnd type="none" w="med" len="med"/>
+                      <a:tailEnd type="none" w="med" len="med"/>
+                    </a:lnB>
+                    <a:solidFill>
+                      <a:srgbClr val="E4E6C3"/>
+                    </a:solidFill>
+                  </a:tcPr>
+                </a:tc>
+              </a:tr>
+              <a:tr h="347472">
+                <a:tc>
+                  <a:txBody>
+                    <a:bodyPr/>
+                    <a:lstStyle/>
+                    <a:p>
+                      <a:pPr indent="0" marL="0">
+                        <a:buNone/>
+                      </a:pPr>
+                      <a:r>
+                        <a:rPr lang="en-US" sz="1200" dirty="0">
+                          <a:solidFill>
+                            <a:srgbClr val="2B1E1C"/>
+                          </a:solidFill>
+                          <a:latin typeface="Calibri" pitchFamily="34" charset="0"/>
+                          <a:ea typeface="Calibri" pitchFamily="34" charset="-122"/>
+                          <a:cs typeface="Calibri" pitchFamily="34" charset="-120"/>
+                        </a:rPr>
+                        <a:t>Conferir leituras e pedir nova foto</a:t>
+                      </a:r>
+                      <a:endParaRPr lang="en-US" sz="1200" dirty="0">
+                        <a:latin typeface="Calibri" charset="0"/>
+                        <a:ea typeface="Calibri" charset="0"/>
+                        <a:cs typeface="Calibri" charset="0"/>
+                      </a:endParaRPr>
+                    </a:p>
+                  </a:txBody>
+                  <a:tcPr marL="73152" marR="73152" marT="18288" marB="18288" anchor="ctr">
+                    <a:lnL w="6350" cap="flat" cmpd="sng" algn="ctr">
+                      <a:solidFill>
+                        <a:srgbClr val="EBE7E3"/>
+                      </a:solidFill>
+                      <a:prstDash val="solid"/>
+                      <a:round/>
+                      <a:headEnd type="none" w="med" len="med"/>
+                      <a:tailEnd type="none" w="med" len="med"/>
+                    </a:lnL>
+                    <a:lnR w="6350" cap="flat" cmpd="sng" algn="ctr">
+                      <a:solidFill>
+                        <a:srgbClr val="EBE7E3"/>
+                      </a:solidFill>
+                      <a:prstDash val="solid"/>
+                      <a:round/>
+                      <a:headEnd type="none" w="med" len="med"/>
+                      <a:tailEnd type="none" w="med" len="med"/>
+                    </a:lnR>
+                    <a:lnT w="6350" cap="flat" cmpd="sng" algn="ctr">
+                      <a:solidFill>
+                        <a:srgbClr val="EBE7E3"/>
+                      </a:solidFill>
+                      <a:prstDash val="solid"/>
+                      <a:round/>
+                      <a:headEnd type="none" w="med" len="med"/>
+                      <a:tailEnd type="none" w="med" len="med"/>
+                    </a:lnT>
+                    <a:lnB w="6350" cap="flat" cmpd="sng" algn="ctr">
+                      <a:solidFill>
+                        <a:srgbClr val="EBE7E3"/>
+                      </a:solidFill>
+                      <a:prstDash val="solid"/>
+                      <a:round/>
+                      <a:headEnd type="none" w="med" len="med"/>
+                      <a:tailEnd type="none" w="med" len="med"/>
+                    </a:lnB>
+                  </a:tcPr>
+                </a:tc>
+                <a:tc>
+                  <a:txBody>
+                    <a:bodyPr/>
+                    <a:lstStyle/>
+                    <a:p>
+                      <a:pPr algn="ctr" indent="0" marL="0">
+                        <a:buNone/>
+                      </a:pPr>
+                      <a:r>
+                        <a:rPr lang="en-US" sz="1100" b="1" dirty="0">
+                          <a:solidFill>
+                            <a:srgbClr val="545814"/>
+                          </a:solidFill>
+                          <a:latin typeface="Calibri" pitchFamily="34" charset="0"/>
+                          <a:ea typeface="Calibri" pitchFamily="34" charset="-122"/>
+                          <a:cs typeface="Calibri" pitchFamily="34" charset="-120"/>
+                        </a:rPr>
+                        <a:t>✓ Sim</a:t>
+                      </a:r>
+                      <a:endParaRPr lang="en-US" sz="1100" dirty="0">
+                        <a:latin typeface="Calibri" charset="0"/>
+                        <a:ea typeface="Calibri" charset="0"/>
+                        <a:cs typeface="Calibri" charset="0"/>
+                      </a:endParaRPr>
+                    </a:p>
+                  </a:txBody>
+                  <a:tcPr marL="73152" marR="73152" marT="18288" marB="18288" anchor="ctr">
+                    <a:lnL w="6350" cap="flat" cmpd="sng" algn="ctr">
+                      <a:solidFill>
+                        <a:srgbClr val="EBE7E3"/>
+                      </a:solidFill>
+                      <a:prstDash val="solid"/>
+                      <a:round/>
+                      <a:headEnd type="none" w="med" len="med"/>
+                      <a:tailEnd type="none" w="med" len="med"/>
+                    </a:lnL>
+                    <a:lnR w="6350" cap="flat" cmpd="sng" algn="ctr">
+                      <a:solidFill>
+                        <a:srgbClr val="EBE7E3"/>
+                      </a:solidFill>
+                      <a:prstDash val="solid"/>
+                      <a:round/>
+                      <a:headEnd type="none" w="med" len="med"/>
+                      <a:tailEnd type="none" w="med" len="med"/>
+                    </a:lnR>
+                    <a:lnT w="6350" cap="flat" cmpd="sng" algn="ctr">
+                      <a:solidFill>
+                        <a:srgbClr val="EBE7E3"/>
+                      </a:solidFill>
+                      <a:prstDash val="solid"/>
+                      <a:round/>
+                      <a:headEnd type="none" w="med" len="med"/>
+                      <a:tailEnd type="none" w="med" len="med"/>
+                    </a:lnT>
+                    <a:lnB w="6350" cap="flat" cmpd="sng" algn="ctr">
+                      <a:solidFill>
+                        <a:srgbClr val="EBE7E3"/>
+                      </a:solidFill>
+                      <a:prstDash val="solid"/>
+                      <a:round/>
+                      <a:headEnd type="none" w="med" len="med"/>
+                      <a:tailEnd type="none" w="med" len="med"/>
+                    </a:lnB>
+                    <a:solidFill>
+                      <a:srgbClr val="E4E6C3"/>
+                    </a:solidFill>
+                  </a:tcPr>
+                </a:tc>
+                <a:tc>
+                  <a:txBody>
+                    <a:bodyPr/>
+                    <a:lstStyle/>
+                    <a:p>
+                      <a:pPr algn="ctr" indent="0" marL="0">
+                        <a:buNone/>
+                      </a:pPr>
+                      <a:r>
+                        <a:rPr lang="en-US" sz="1100" b="1" dirty="0">
+                          <a:solidFill>
+                            <a:srgbClr val="6B4E00"/>
+                          </a:solidFill>
+                          <a:latin typeface="Calibri" pitchFamily="34" charset="0"/>
+                          <a:ea typeface="Calibri" pitchFamily="34" charset="-122"/>
+                          <a:cs typeface="Calibri" pitchFamily="34" charset="-120"/>
+                        </a:rPr>
+                        <a:t>◐ Se configurado</a:t>
+                      </a:r>
+                      <a:endParaRPr lang="en-US" sz="1100" dirty="0">
+                        <a:latin typeface="Calibri" charset="0"/>
+                        <a:ea typeface="Calibri" charset="0"/>
+                        <a:cs typeface="Calibri" charset="0"/>
+                      </a:endParaRPr>
+                    </a:p>
+                  </a:txBody>
+                  <a:tcPr marL="73152" marR="73152" marT="18288" marB="18288" anchor="ctr">
+                    <a:lnL w="6350" cap="flat" cmpd="sng" algn="ctr">
+                      <a:solidFill>
+                        <a:srgbClr val="EBE7E3"/>
+                      </a:solidFill>
+                      <a:prstDash val="solid"/>
+                      <a:round/>
+                      <a:headEnd type="none" w="med" len="med"/>
+                      <a:tailEnd type="none" w="med" len="med"/>
+                    </a:lnL>
+                    <a:lnR w="6350" cap="flat" cmpd="sng" algn="ctr">
+                      <a:solidFill>
+                        <a:srgbClr val="EBE7E3"/>
+                      </a:solidFill>
+                      <a:prstDash val="solid"/>
+                      <a:round/>
+                      <a:headEnd type="none" w="med" len="med"/>
+                      <a:tailEnd type="none" w="med" len="med"/>
+                    </a:lnR>
+                    <a:lnT w="6350" cap="flat" cmpd="sng" algn="ctr">
+                      <a:solidFill>
+                        <a:srgbClr val="EBE7E3"/>
+                      </a:solidFill>
+                      <a:prstDash val="solid"/>
+                      <a:round/>
+                      <a:headEnd type="none" w="med" len="med"/>
+                      <a:tailEnd type="none" w="med" len="med"/>
+                    </a:lnT>
+                    <a:lnB w="6350" cap="flat" cmpd="sng" algn="ctr">
+                      <a:solidFill>
+                        <a:srgbClr val="EBE7E3"/>
+                      </a:solidFill>
+                      <a:prstDash val="solid"/>
+                      <a:round/>
+                      <a:headEnd type="none" w="med" len="med"/>
+                      <a:tailEnd type="none" w="med" len="med"/>
+                    </a:lnB>
+                    <a:solidFill>
+                      <a:srgbClr val="FBEBC0"/>
+                    </a:solidFill>
+                  </a:tcPr>
+                </a:tc>
+                <a:tc>
+                  <a:txBody>
+                    <a:bodyPr/>
+                    <a:lstStyle/>
+                    <a:p>
+                      <a:pPr algn="ctr" indent="0" marL="0">
+                        <a:buNone/>
+                      </a:pPr>
+                      <a:r>
+                        <a:rPr lang="en-US" sz="1100" b="1" dirty="0">
+                          <a:solidFill>
+                            <a:srgbClr val="6B4E00"/>
+                          </a:solidFill>
+                          <a:latin typeface="Calibri" pitchFamily="34" charset="0"/>
+                          <a:ea typeface="Calibri" pitchFamily="34" charset="-122"/>
+                          <a:cs typeface="Calibri" pitchFamily="34" charset="-120"/>
+                        </a:rPr>
+                        <a:t>◐ Se configurado</a:t>
+                      </a:r>
+                      <a:endParaRPr lang="en-US" sz="1100" dirty="0">
+                        <a:latin typeface="Calibri" charset="0"/>
+                        <a:ea typeface="Calibri" charset="0"/>
+                        <a:cs typeface="Calibri" charset="0"/>
+                      </a:endParaRPr>
+                    </a:p>
+                  </a:txBody>
+                  <a:tcPr marL="73152" marR="73152" marT="18288" marB="18288" anchor="ctr">
+                    <a:lnL w="6350" cap="flat" cmpd="sng" algn="ctr">
+                      <a:solidFill>
+                        <a:srgbClr val="EBE7E3"/>
+                      </a:solidFill>
+                      <a:prstDash val="solid"/>
+                      <a:round/>
+                      <a:headEnd type="none" w="med" len="med"/>
+                      <a:tailEnd type="none" w="med" len="med"/>
+                    </a:lnL>
+                    <a:lnR w="6350" cap="flat" cmpd="sng" algn="ctr">
+                      <a:solidFill>
+                        <a:srgbClr val="EBE7E3"/>
+                      </a:solidFill>
+                      <a:prstDash val="solid"/>
+                      <a:round/>
+                      <a:headEnd type="none" w="med" len="med"/>
+                      <a:tailEnd type="none" w="med" len="med"/>
+                    </a:lnR>
+                    <a:lnT w="6350" cap="flat" cmpd="sng" algn="ctr">
+                      <a:solidFill>
+                        <a:srgbClr val="EBE7E3"/>
+                      </a:solidFill>
+                      <a:prstDash val="solid"/>
+                      <a:round/>
+                      <a:headEnd type="none" w="med" len="med"/>
+                      <a:tailEnd type="none" w="med" len="med"/>
+                    </a:lnT>
+                    <a:lnB w="6350" cap="flat" cmpd="sng" algn="ctr">
+                      <a:solidFill>
+                        <a:srgbClr val="EBE7E3"/>
+                      </a:solidFill>
+                      <a:prstDash val="solid"/>
+                      <a:round/>
+                      <a:headEnd type="none" w="med" len="med"/>
+                      <a:tailEnd type="none" w="med" len="med"/>
+                    </a:lnB>
+                    <a:solidFill>
+                      <a:srgbClr val="FBEBC0"/>
+                    </a:solidFill>
+                  </a:tcPr>
+                </a:tc>
+                <a:tc>
+                  <a:txBody>
+                    <a:bodyPr/>
+                    <a:lstStyle/>
+                    <a:p>
+                      <a:pPr algn="ctr" indent="0" marL="0">
+                        <a:buNone/>
+                      </a:pPr>
+                      <a:r>
+                        <a:rPr lang="en-US" sz="1100" b="1" dirty="0">
+                          <a:solidFill>
+                            <a:srgbClr val="6B4E00"/>
+                          </a:solidFill>
+                          <a:latin typeface="Calibri" pitchFamily="34" charset="0"/>
+                          <a:ea typeface="Calibri" pitchFamily="34" charset="-122"/>
+                          <a:cs typeface="Calibri" pitchFamily="34" charset="-120"/>
+                        </a:rPr>
+                        <a:t>◐ Se configurado</a:t>
+                      </a:r>
+                      <a:endParaRPr lang="en-US" sz="1100" dirty="0">
+                        <a:latin typeface="Calibri" charset="0"/>
+                        <a:ea typeface="Calibri" charset="0"/>
+                        <a:cs typeface="Calibri" charset="0"/>
+                      </a:endParaRPr>
+                    </a:p>
+                  </a:txBody>
+                  <a:tcPr marL="73152" marR="73152" marT="18288" marB="18288" anchor="ctr">
+                    <a:lnL w="6350" cap="flat" cmpd="sng" algn="ctr">
+                      <a:solidFill>
+                        <a:srgbClr val="EBE7E3"/>
+                      </a:solidFill>
+                      <a:prstDash val="solid"/>
+                      <a:round/>
+                      <a:headEnd type="none" w="med" len="med"/>
+                      <a:tailEnd type="none" w="med" len="med"/>
+                    </a:lnL>
+                    <a:lnR w="6350" cap="flat" cmpd="sng" algn="ctr">
+                      <a:solidFill>
+                        <a:srgbClr val="EBE7E3"/>
+                      </a:solidFill>
+                      <a:prstDash val="solid"/>
+                      <a:round/>
+                      <a:headEnd type="none" w="med" len="med"/>
+                      <a:tailEnd type="none" w="med" len="med"/>
+                    </a:lnR>
+                    <a:lnT w="6350" cap="flat" cmpd="sng" algn="ctr">
+                      <a:solidFill>
+                        <a:srgbClr val="EBE7E3"/>
+                      </a:solidFill>
+                      <a:prstDash val="solid"/>
+                      <a:round/>
+                      <a:headEnd type="none" w="med" len="med"/>
+                      <a:tailEnd type="none" w="med" len="med"/>
+                    </a:lnT>
+                    <a:lnB w="6350" cap="flat" cmpd="sng" algn="ctr">
+                      <a:solidFill>
+                        <a:srgbClr val="EBE7E3"/>
+                      </a:solidFill>
+                      <a:prstDash val="solid"/>
+                      <a:round/>
+                      <a:headEnd type="none" w="med" len="med"/>
+                      <a:tailEnd type="none" w="med" len="med"/>
+                    </a:lnB>
+                    <a:solidFill>
+                      <a:srgbClr val="FBEBC0"/>
+                    </a:solidFill>
+                  </a:tcPr>
+                </a:tc>
+                <a:tc>
+                  <a:txBody>
+                    <a:bodyPr/>
+                    <a:lstStyle/>
+                    <a:p>
+                      <a:pPr algn="ctr" indent="0" marL="0">
+                        <a:buNone/>
+                      </a:pPr>
+                      <a:r>
+                        <a:rPr lang="en-US" sz="1100" b="1" dirty="0">
+                          <a:solidFill>
+                            <a:srgbClr val="545814"/>
+                          </a:solidFill>
+                          <a:latin typeface="Calibri" pitchFamily="34" charset="0"/>
+                          <a:ea typeface="Calibri" pitchFamily="34" charset="-122"/>
+                          <a:cs typeface="Calibri" pitchFamily="34" charset="-120"/>
+                        </a:rPr>
+                        <a:t>✓ Sim</a:t>
+                      </a:r>
+                      <a:endParaRPr lang="en-US" sz="1100" dirty="0">
+                        <a:latin typeface="Calibri" charset="0"/>
+                        <a:ea typeface="Calibri" charset="0"/>
+                        <a:cs typeface="Calibri" charset="0"/>
+                      </a:endParaRPr>
+                    </a:p>
+                  </a:txBody>
+                  <a:tcPr marL="73152" marR="73152" marT="18288" marB="18288" anchor="ctr">
+                    <a:lnL w="6350" cap="flat" cmpd="sng" algn="ctr">
+                      <a:solidFill>
+                        <a:srgbClr val="EBE7E3"/>
+                      </a:solidFill>
+                      <a:prstDash val="solid"/>
+                      <a:round/>
+                      <a:headEnd type="none" w="med" len="med"/>
+                      <a:tailEnd type="none" w="med" len="med"/>
+                    </a:lnL>
+                    <a:lnR w="6350" cap="flat" cmpd="sng" algn="ctr">
+                      <a:solidFill>
+                        <a:srgbClr val="EBE7E3"/>
+                      </a:solidFill>
+                      <a:prstDash val="solid"/>
+                      <a:round/>
+                      <a:headEnd type="none" w="med" len="med"/>
+                      <a:tailEnd type="none" w="med" len="med"/>
+                    </a:lnR>
+                    <a:lnT w="6350" cap="flat" cmpd="sng" algn="ctr">
+                      <a:solidFill>
+                        <a:srgbClr val="EBE7E3"/>
+                      </a:solidFill>
+                      <a:prstDash val="solid"/>
+                      <a:round/>
+                      <a:headEnd type="none" w="med" len="med"/>
+                      <a:tailEnd type="none" w="med" len="med"/>
+                    </a:lnT>
+                    <a:lnB w="6350" cap="flat" cmpd="sng" algn="ctr">
+                      <a:solidFill>
+                        <a:srgbClr val="EBE7E3"/>
+                      </a:solidFill>
+                      <a:prstDash val="solid"/>
+                      <a:round/>
+                      <a:headEnd type="none" w="med" len="med"/>
+                      <a:tailEnd type="none" w="med" len="med"/>
+                    </a:lnB>
+                    <a:solidFill>
+                      <a:srgbClr val="E4E6C3"/>
+                    </a:solidFill>
+                  </a:tcPr>
+                </a:tc>
+                <a:tc>
+                  <a:txBody>
+                    <a:bodyPr/>
+                    <a:lstStyle/>
+                    <a:p>
+                      <a:pPr algn="ctr" indent="0" marL="0">
+                        <a:buNone/>
+                      </a:pPr>
+                      <a:r>
+                        <a:rPr lang="en-US" sz="1100" b="1" dirty="0">
+                          <a:solidFill>
+                            <a:srgbClr val="545814"/>
+                          </a:solidFill>
+                          <a:latin typeface="Calibri" pitchFamily="34" charset="0"/>
+                          <a:ea typeface="Calibri" pitchFamily="34" charset="-122"/>
+                          <a:cs typeface="Calibri" pitchFamily="34" charset="-120"/>
+                        </a:rPr>
+                        <a:t>✓ Sim</a:t>
+                      </a:r>
+                      <a:endParaRPr lang="en-US" sz="1100" dirty="0">
+                        <a:latin typeface="Calibri" charset="0"/>
+                        <a:ea typeface="Calibri" charset="0"/>
+                        <a:cs typeface="Calibri" charset="0"/>
+                      </a:endParaRPr>
+                    </a:p>
+                  </a:txBody>
+                  <a:tcPr marL="73152" marR="73152" marT="18288" marB="18288" anchor="ctr">
+                    <a:lnL w="6350" cap="flat" cmpd="sng" algn="ctr">
+                      <a:solidFill>
+                        <a:srgbClr val="EBE7E3"/>
+                      </a:solidFill>
+                      <a:prstDash val="solid"/>
+                      <a:round/>
+                      <a:headEnd type="none" w="med" len="med"/>
+                      <a:tailEnd type="none" w="med" len="med"/>
+                    </a:lnL>
+                    <a:lnR w="6350" cap="flat" cmpd="sng" algn="ctr">
+                      <a:solidFill>
+                        <a:srgbClr val="EBE7E3"/>
+                      </a:solidFill>
+                      <a:prstDash val="solid"/>
+                      <a:round/>
+                      <a:headEnd type="none" w="med" len="med"/>
+                      <a:tailEnd type="none" w="med" len="med"/>
+                    </a:lnR>
+                    <a:lnT w="6350" cap="flat" cmpd="sng" algn="ctr">
+                      <a:solidFill>
+                        <a:srgbClr val="EBE7E3"/>
+                      </a:solidFill>
+                      <a:prstDash val="solid"/>
+                      <a:round/>
+                      <a:headEnd type="none" w="med" len="med"/>
+                      <a:tailEnd type="none" w="med" len="med"/>
+                    </a:lnT>
+                    <a:lnB w="6350" cap="flat" cmpd="sng" algn="ctr">
+                      <a:solidFill>
+                        <a:srgbClr val="EBE7E3"/>
+                      </a:solidFill>
+                      <a:prstDash val="solid"/>
+                      <a:round/>
+                      <a:headEnd type="none" w="med" len="med"/>
+                      <a:tailEnd type="none" w="med" len="med"/>
+                    </a:lnB>
+                    <a:solidFill>
+                      <a:srgbClr val="E4E6C3"/>
+                    </a:solidFill>
+                  </a:tcPr>
+                </a:tc>
+              </a:tr>
+              <a:tr h="347472">
+                <a:tc>
+                  <a:txBody>
+                    <a:bodyPr/>
+                    <a:lstStyle/>
+                    <a:p>
+                      <a:pPr indent="0" marL="0">
+                        <a:buNone/>
+                      </a:pPr>
+                      <a:r>
+                        <a:rPr lang="en-US" sz="1200" dirty="0">
+                          <a:solidFill>
+                            <a:srgbClr val="2B1E1C"/>
+                          </a:solidFill>
+                          <a:latin typeface="Calibri" pitchFamily="34" charset="0"/>
+                          <a:ea typeface="Calibri" pitchFamily="34" charset="-122"/>
+                          <a:cs typeface="Calibri" pitchFamily="34" charset="-120"/>
+                        </a:rPr>
+                        <a:t>Calcular a água e exportar para o boleto</a:t>
+                      </a:r>
+                      <a:endParaRPr lang="en-US" sz="1200" dirty="0">
+                        <a:latin typeface="Calibri" charset="0"/>
+                        <a:ea typeface="Calibri" charset="0"/>
+                        <a:cs typeface="Calibri" charset="0"/>
+                      </a:endParaRPr>
+                    </a:p>
+                  </a:txBody>
+                  <a:tcPr marL="73152" marR="73152" marT="18288" marB="18288" anchor="ctr">
+                    <a:lnL w="6350" cap="flat" cmpd="sng" algn="ctr">
+                      <a:solidFill>
+                        <a:srgbClr val="EBE7E3"/>
+                      </a:solidFill>
+                      <a:prstDash val="solid"/>
+                      <a:round/>
+                      <a:headEnd type="none" w="med" len="med"/>
+                      <a:tailEnd type="none" w="med" len="med"/>
+                    </a:lnL>
+                    <a:lnR w="6350" cap="flat" cmpd="sng" algn="ctr">
+                      <a:solidFill>
+                        <a:srgbClr val="EBE7E3"/>
+                      </a:solidFill>
+                      <a:prstDash val="solid"/>
+                      <a:round/>
+                      <a:headEnd type="none" w="med" len="med"/>
+                      <a:tailEnd type="none" w="med" len="med"/>
+                    </a:lnR>
+                    <a:lnT w="6350" cap="flat" cmpd="sng" algn="ctr">
+                      <a:solidFill>
+                        <a:srgbClr val="EBE7E3"/>
+                      </a:solidFill>
+                      <a:prstDash val="solid"/>
+                      <a:round/>
+                      <a:headEnd type="none" w="med" len="med"/>
+                      <a:tailEnd type="none" w="med" len="med"/>
+                    </a:lnT>
+                    <a:lnB w="6350" cap="flat" cmpd="sng" algn="ctr">
+                      <a:solidFill>
+                        <a:srgbClr val="EBE7E3"/>
+                      </a:solidFill>
+                      <a:prstDash val="solid"/>
+                      <a:round/>
+                      <a:headEnd type="none" w="med" len="med"/>
+                      <a:tailEnd type="none" w="med" len="med"/>
+                    </a:lnB>
+                  </a:tcPr>
+                </a:tc>
+                <a:tc>
+                  <a:txBody>
+                    <a:bodyPr/>
+                    <a:lstStyle/>
+                    <a:p>
+                      <a:pPr algn="ctr" indent="0" marL="0">
+                        <a:buNone/>
+                      </a:pPr>
+                      <a:r>
+                        <a:rPr lang="en-US" sz="1100" b="1" dirty="0">
+                          <a:solidFill>
+                            <a:srgbClr val="545814"/>
+                          </a:solidFill>
+                          <a:latin typeface="Calibri" pitchFamily="34" charset="0"/>
+                          <a:ea typeface="Calibri" pitchFamily="34" charset="-122"/>
+                          <a:cs typeface="Calibri" pitchFamily="34" charset="-120"/>
+                        </a:rPr>
+                        <a:t>✓ Sim</a:t>
+                      </a:r>
+                      <a:endParaRPr lang="en-US" sz="1100" dirty="0">
+                        <a:latin typeface="Calibri" charset="0"/>
+                        <a:ea typeface="Calibri" charset="0"/>
+                        <a:cs typeface="Calibri" charset="0"/>
+                      </a:endParaRPr>
+                    </a:p>
+                  </a:txBody>
+                  <a:tcPr marL="73152" marR="73152" marT="18288" marB="18288" anchor="ctr">
+                    <a:lnL w="6350" cap="flat" cmpd="sng" algn="ctr">
+                      <a:solidFill>
+                        <a:srgbClr val="EBE7E3"/>
+                      </a:solidFill>
+                      <a:prstDash val="solid"/>
+                      <a:round/>
+                      <a:headEnd type="none" w="med" len="med"/>
+                      <a:tailEnd type="none" w="med" len="med"/>
+                    </a:lnL>
+                    <a:lnR w="6350" cap="flat" cmpd="sng" algn="ctr">
+                      <a:solidFill>
+                        <a:srgbClr val="EBE7E3"/>
+                      </a:solidFill>
+                      <a:prstDash val="solid"/>
+                      <a:round/>
+                      <a:headEnd type="none" w="med" len="med"/>
+                      <a:tailEnd type="none" w="med" len="med"/>
+                    </a:lnR>
+                    <a:lnT w="6350" cap="flat" cmpd="sng" algn="ctr">
+                      <a:solidFill>
+                        <a:srgbClr val="EBE7E3"/>
+                      </a:solidFill>
+                      <a:prstDash val="solid"/>
+                      <a:round/>
+                      <a:headEnd type="none" w="med" len="med"/>
+                      <a:tailEnd type="none" w="med" len="med"/>
+                    </a:lnT>
+                    <a:lnB w="6350" cap="flat" cmpd="sng" algn="ctr">
+                      <a:solidFill>
+                        <a:srgbClr val="EBE7E3"/>
+                      </a:solidFill>
+                      <a:prstDash val="solid"/>
+                      <a:round/>
+                      <a:headEnd type="none" w="med" len="med"/>
+                      <a:tailEnd type="none" w="med" len="med"/>
+                    </a:lnB>
+                    <a:solidFill>
+                      <a:srgbClr val="E4E6C3"/>
+                    </a:solidFill>
+                  </a:tcPr>
+                </a:tc>
+                <a:tc>
+                  <a:txBody>
+                    <a:bodyPr/>
+                    <a:lstStyle/>
+                    <a:p>
+                      <a:pPr algn="ctr" indent="0" marL="0">
+                        <a:buNone/>
+                      </a:pPr>
+                      <a:r>
+                        <a:rPr lang="en-US" sz="1100" b="1" dirty="0">
+                          <a:solidFill>
+                            <a:srgbClr val="6B4E00"/>
+                          </a:solidFill>
+                          <a:latin typeface="Calibri" pitchFamily="34" charset="0"/>
+                          <a:ea typeface="Calibri" pitchFamily="34" charset="-122"/>
+                          <a:cs typeface="Calibri" pitchFamily="34" charset="-120"/>
+                        </a:rPr>
+                        <a:t>◐ Se configurado</a:t>
+                      </a:r>
+                      <a:endParaRPr lang="en-US" sz="1100" dirty="0">
+                        <a:latin typeface="Calibri" charset="0"/>
+                        <a:ea typeface="Calibri" charset="0"/>
+                        <a:cs typeface="Calibri" charset="0"/>
+                      </a:endParaRPr>
+                    </a:p>
+                  </a:txBody>
+                  <a:tcPr marL="73152" marR="73152" marT="18288" marB="18288" anchor="ctr">
+                    <a:lnL w="6350" cap="flat" cmpd="sng" algn="ctr">
+                      <a:solidFill>
+                        <a:srgbClr val="EBE7E3"/>
+                      </a:solidFill>
+                      <a:prstDash val="solid"/>
+                      <a:round/>
+                      <a:headEnd type="none" w="med" len="med"/>
+                      <a:tailEnd type="none" w="med" len="med"/>
+                    </a:lnL>
+                    <a:lnR w="6350" cap="flat" cmpd="sng" algn="ctr">
+                      <a:solidFill>
+                        <a:srgbClr val="EBE7E3"/>
+                      </a:solidFill>
+                      <a:prstDash val="solid"/>
+                      <a:round/>
+                      <a:headEnd type="none" w="med" len="med"/>
+                      <a:tailEnd type="none" w="med" len="med"/>
+                    </a:lnR>
+                    <a:lnT w="6350" cap="flat" cmpd="sng" algn="ctr">
+                      <a:solidFill>
+                        <a:srgbClr val="EBE7E3"/>
+                      </a:solidFill>
+                      <a:prstDash val="solid"/>
+                      <a:round/>
+                      <a:headEnd type="none" w="med" len="med"/>
+                      <a:tailEnd type="none" w="med" len="med"/>
+                    </a:lnT>
+                    <a:lnB w="6350" cap="flat" cmpd="sng" algn="ctr">
+                      <a:solidFill>
+                        <a:srgbClr val="EBE7E3"/>
+                      </a:solidFill>
+                      <a:prstDash val="solid"/>
+                      <a:round/>
+                      <a:headEnd type="none" w="med" len="med"/>
+                      <a:tailEnd type="none" w="med" len="med"/>
+                    </a:lnB>
+                    <a:solidFill>
+                      <a:srgbClr val="FBEBC0"/>
+                    </a:solidFill>
+                  </a:tcPr>
+                </a:tc>
+                <a:tc>
+                  <a:txBody>
+                    <a:bodyPr/>
+                    <a:lstStyle/>
+                    <a:p>
+                      <a:pPr algn="ctr" indent="0" marL="0">
+                        <a:buNone/>
+                      </a:pPr>
+                      <a:r>
+                        <a:rPr lang="en-US" sz="1100" b="1" dirty="0">
+                          <a:solidFill>
+                            <a:srgbClr val="6B4E00"/>
+                          </a:solidFill>
+                          <a:latin typeface="Calibri" pitchFamily="34" charset="0"/>
+                          <a:ea typeface="Calibri" pitchFamily="34" charset="-122"/>
+                          <a:cs typeface="Calibri" pitchFamily="34" charset="-120"/>
+                        </a:rPr>
+                        <a:t>◐ Se configurado</a:t>
+                      </a:r>
+                      <a:endParaRPr lang="en-US" sz="1100" dirty="0">
+                        <a:latin typeface="Calibri" charset="0"/>
+                        <a:ea typeface="Calibri" charset="0"/>
+                        <a:cs typeface="Calibri" charset="0"/>
+                      </a:endParaRPr>
+                    </a:p>
+                  </a:txBody>
+                  <a:tcPr marL="73152" marR="73152" marT="18288" marB="18288" anchor="ctr">
+                    <a:lnL w="6350" cap="flat" cmpd="sng" algn="ctr">
+                      <a:solidFill>
+                        <a:srgbClr val="EBE7E3"/>
+                      </a:solidFill>
+                      <a:prstDash val="solid"/>
+                      <a:round/>
+                      <a:headEnd type="none" w="med" len="med"/>
+                      <a:tailEnd type="none" w="med" len="med"/>
+                    </a:lnL>
+                    <a:lnR w="6350" cap="flat" cmpd="sng" algn="ctr">
+                      <a:solidFill>
+                        <a:srgbClr val="EBE7E3"/>
+                      </a:solidFill>
+                      <a:prstDash val="solid"/>
+                      <a:round/>
+                      <a:headEnd type="none" w="med" len="med"/>
+                      <a:tailEnd type="none" w="med" len="med"/>
+                    </a:lnR>
+                    <a:lnT w="6350" cap="flat" cmpd="sng" algn="ctr">
+                      <a:solidFill>
+                        <a:srgbClr val="EBE7E3"/>
+                      </a:solidFill>
+                      <a:prstDash val="solid"/>
+                      <a:round/>
+                      <a:headEnd type="none" w="med" len="med"/>
+                      <a:tailEnd type="none" w="med" len="med"/>
+                    </a:lnT>
+                    <a:lnB w="6350" cap="flat" cmpd="sng" algn="ctr">
+                      <a:solidFill>
+                        <a:srgbClr val="EBE7E3"/>
+                      </a:solidFill>
+                      <a:prstDash val="solid"/>
+                      <a:round/>
+                      <a:headEnd type="none" w="med" len="med"/>
+                      <a:tailEnd type="none" w="med" len="med"/>
+                    </a:lnB>
+                    <a:solidFill>
+                      <a:srgbClr val="FBEBC0"/>
+                    </a:solidFill>
+                  </a:tcPr>
+                </a:tc>
+                <a:tc>
+                  <a:txBody>
+                    <a:bodyPr/>
+                    <a:lstStyle/>
+                    <a:p>
+                      <a:pPr algn="ctr" indent="0" marL="0">
+                        <a:buNone/>
+                      </a:pPr>
+                      <a:r>
+                        <a:rPr lang="en-US" sz="1100" b="1" dirty="0">
+                          <a:solidFill>
+                            <a:srgbClr val="6B4E00"/>
+                          </a:solidFill>
+                          <a:latin typeface="Calibri" pitchFamily="34" charset="0"/>
+                          <a:ea typeface="Calibri" pitchFamily="34" charset="-122"/>
+                          <a:cs typeface="Calibri" pitchFamily="34" charset="-120"/>
+                        </a:rPr>
+                        <a:t>◐ Se configurado</a:t>
+                      </a:r>
+                      <a:endParaRPr lang="en-US" sz="1100" dirty="0">
+                        <a:latin typeface="Calibri" charset="0"/>
+                        <a:ea typeface="Calibri" charset="0"/>
+                        <a:cs typeface="Calibri" charset="0"/>
+                      </a:endParaRPr>
+                    </a:p>
+                  </a:txBody>
+                  <a:tcPr marL="73152" marR="73152" marT="18288" marB="18288" anchor="ctr">
+                    <a:lnL w="6350" cap="flat" cmpd="sng" algn="ctr">
+                      <a:solidFill>
+                        <a:srgbClr val="EBE7E3"/>
+                      </a:solidFill>
+                      <a:prstDash val="solid"/>
+                      <a:round/>
+                      <a:headEnd type="none" w="med" len="med"/>
+                      <a:tailEnd type="none" w="med" len="med"/>
+                    </a:lnL>
+                    <a:lnR w="6350" cap="flat" cmpd="sng" algn="ctr">
+                      <a:solidFill>
+                        <a:srgbClr val="EBE7E3"/>
+                      </a:solidFill>
+                      <a:prstDash val="solid"/>
+                      <a:round/>
+                      <a:headEnd type="none" w="med" len="med"/>
+                      <a:tailEnd type="none" w="med" len="med"/>
+                    </a:lnR>
+                    <a:lnT w="6350" cap="flat" cmpd="sng" algn="ctr">
+                      <a:solidFill>
+                        <a:srgbClr val="EBE7E3"/>
+                      </a:solidFill>
+                      <a:prstDash val="solid"/>
+                      <a:round/>
+                      <a:headEnd type="none" w="med" len="med"/>
+                      <a:tailEnd type="none" w="med" len="med"/>
+                    </a:lnT>
+                    <a:lnB w="6350" cap="flat" cmpd="sng" algn="ctr">
+                      <a:solidFill>
+                        <a:srgbClr val="EBE7E3"/>
+                      </a:solidFill>
+                      <a:prstDash val="solid"/>
+                      <a:round/>
+                      <a:headEnd type="none" w="med" len="med"/>
+                      <a:tailEnd type="none" w="med" len="med"/>
+                    </a:lnB>
+                    <a:solidFill>
+                      <a:srgbClr val="FBEBC0"/>
+                    </a:solidFill>
+                  </a:tcPr>
+                </a:tc>
+                <a:tc>
+                  <a:txBody>
+                    <a:bodyPr/>
+                    <a:lstStyle/>
+                    <a:p>
+                      <a:pPr algn="ctr" indent="0" marL="0">
+                        <a:buNone/>
+                      </a:pPr>
+                      <a:r>
+                        <a:rPr lang="en-US" sz="1100" b="1" dirty="0">
+                          <a:solidFill>
+                            <a:srgbClr val="545814"/>
+                          </a:solidFill>
+                          <a:latin typeface="Calibri" pitchFamily="34" charset="0"/>
+                          <a:ea typeface="Calibri" pitchFamily="34" charset="-122"/>
+                          <a:cs typeface="Calibri" pitchFamily="34" charset="-120"/>
+                        </a:rPr>
+                        <a:t>✓ Sim</a:t>
+                      </a:r>
+                      <a:endParaRPr lang="en-US" sz="1100" dirty="0">
+                        <a:latin typeface="Calibri" charset="0"/>
+                        <a:ea typeface="Calibri" charset="0"/>
+                        <a:cs typeface="Calibri" charset="0"/>
+                      </a:endParaRPr>
+                    </a:p>
+                  </a:txBody>
+                  <a:tcPr marL="73152" marR="73152" marT="18288" marB="18288" anchor="ctr">
+                    <a:lnL w="6350" cap="flat" cmpd="sng" algn="ctr">
+                      <a:solidFill>
+                        <a:srgbClr val="EBE7E3"/>
+                      </a:solidFill>
+                      <a:prstDash val="solid"/>
+                      <a:round/>
+                      <a:headEnd type="none" w="med" len="med"/>
+                      <a:tailEnd type="none" w="med" len="med"/>
+                    </a:lnL>
+                    <a:lnR w="6350" cap="flat" cmpd="sng" algn="ctr">
+                      <a:solidFill>
+                        <a:srgbClr val="EBE7E3"/>
+                      </a:solidFill>
+                      <a:prstDash val="solid"/>
+                      <a:round/>
+                      <a:headEnd type="none" w="med" len="med"/>
+                      <a:tailEnd type="none" w="med" len="med"/>
+                    </a:lnR>
+                    <a:lnT w="6350" cap="flat" cmpd="sng" algn="ctr">
+                      <a:solidFill>
+                        <a:srgbClr val="EBE7E3"/>
+                      </a:solidFill>
+                      <a:prstDash val="solid"/>
+                      <a:round/>
+                      <a:headEnd type="none" w="med" len="med"/>
+                      <a:tailEnd type="none" w="med" len="med"/>
+                    </a:lnT>
+                    <a:lnB w="6350" cap="flat" cmpd="sng" algn="ctr">
+                      <a:solidFill>
+                        <a:srgbClr val="EBE7E3"/>
+                      </a:solidFill>
+                      <a:prstDash val="solid"/>
+                      <a:round/>
+                      <a:headEnd type="none" w="med" len="med"/>
+                      <a:tailEnd type="none" w="med" len="med"/>
+                    </a:lnB>
+                    <a:solidFill>
+                      <a:srgbClr val="E4E6C3"/>
+                    </a:solidFill>
+                  </a:tcPr>
+                </a:tc>
+                <a:tc>
+                  <a:txBody>
+                    <a:bodyPr/>
+                    <a:lstStyle/>
+                    <a:p>
+                      <a:pPr algn="ctr" indent="0" marL="0">
+                        <a:buNone/>
+                      </a:pPr>
+                      <a:r>
+                        <a:rPr lang="en-US" sz="1100" b="1" dirty="0">
+                          <a:solidFill>
+                            <a:srgbClr val="545814"/>
+                          </a:solidFill>
+                          <a:latin typeface="Calibri" pitchFamily="34" charset="0"/>
+                          <a:ea typeface="Calibri" pitchFamily="34" charset="-122"/>
+                          <a:cs typeface="Calibri" pitchFamily="34" charset="-120"/>
+                        </a:rPr>
+                        <a:t>✓ Sim</a:t>
+                      </a:r>
+                      <a:endParaRPr lang="en-US" sz="1100" dirty="0">
+                        <a:latin typeface="Calibri" charset="0"/>
+                        <a:ea typeface="Calibri" charset="0"/>
+                        <a:cs typeface="Calibri" charset="0"/>
+                      </a:endParaRPr>
+                    </a:p>
+                  </a:txBody>
+                  <a:tcPr marL="73152" marR="73152" marT="18288" marB="18288" anchor="ctr">
+                    <a:lnL w="6350" cap="flat" cmpd="sng" algn="ctr">
+                      <a:solidFill>
+                        <a:srgbClr val="EBE7E3"/>
+                      </a:solidFill>
+                      <a:prstDash val="solid"/>
+                      <a:round/>
+                      <a:headEnd type="none" w="med" len="med"/>
+                      <a:tailEnd type="none" w="med" len="med"/>
+                    </a:lnL>
+                    <a:lnR w="6350" cap="flat" cmpd="sng" algn="ctr">
+                      <a:solidFill>
+                        <a:srgbClr val="EBE7E3"/>
+                      </a:solidFill>
+                      <a:prstDash val="solid"/>
+                      <a:round/>
+                      <a:headEnd type="none" w="med" len="med"/>
+                      <a:tailEnd type="none" w="med" len="med"/>
+                    </a:lnR>
+                    <a:lnT w="6350" cap="flat" cmpd="sng" algn="ctr">
+                      <a:solidFill>
+                        <a:srgbClr val="EBE7E3"/>
+                      </a:solidFill>
+                      <a:prstDash val="solid"/>
+                      <a:round/>
+                      <a:headEnd type="none" w="med" len="med"/>
+                      <a:tailEnd type="none" w="med" len="med"/>
+                    </a:lnT>
+                    <a:lnB w="6350" cap="flat" cmpd="sng" algn="ctr">
+                      <a:solidFill>
+                        <a:srgbClr val="EBE7E3"/>
+                      </a:solidFill>
+                      <a:prstDash val="solid"/>
+                      <a:round/>
+                      <a:headEnd type="none" w="med" len="med"/>
+                      <a:tailEnd type="none" w="med" len="med"/>
+                    </a:lnB>
+                    <a:solidFill>
+                      <a:srgbClr val="E4E6C3"/>
+                    </a:solidFill>
+                  </a:tcPr>
+                </a:tc>
+              </a:tr>
+            </a:tbl>
+          </a:graphicData>
+        </a:graphic>
+      </p:graphicFrame>
+      <p:sp>
+        <p:nvSpPr>
+          <p:cNvPr id="4" name="Text 1"/>
+          <p:cNvSpPr txBox="1"/>
+          <p:nvPr/>
+        </p:nvSpPr>
+        <p:spPr>
+          <a:xfrm>
+            <a:off x="548640" y="4114800"/>
+            <a:ext cx="11094415" cy="457200"/>
+          </a:xfrm>
+          <a:prstGeom prst="rect">
+            <a:avLst/>
+          </a:prstGeom>
+          <a:noFill/>
+          <a:ln/>
+        </p:spPr>
+        <p:txBody>
+          <a:bodyPr wrap="square" lIns="0" tIns="0" rIns="0" bIns="0" rtlCol="0" anchor="t"/>
+          <a:lstStyle/>
+          <a:p>
+            <a:pPr indent="0" marL="0">
+              <a:buNone/>
+            </a:pPr>
+            <a:r>
+              <a:rPr lang="en-US" sz="1200" dirty="0">
+                <a:solidFill>
+                  <a:srgbClr val="6E5B58"/>
+                </a:solidFill>
+                <a:latin typeface="Calibri" pitchFamily="34" charset="0"/>
+                <a:ea typeface="Calibri" pitchFamily="34" charset="-122"/>
+                <a:cs typeface="Calibri" pitchFamily="34" charset="-120"/>
+              </a:rPr>
+              <a:t>Se configurado: o síndico escolhe os cargos nas configurações. Hoje, só o síndico gerencia os serviços; o síndico e a administradora conferem as leituras e calculam a água. A administradora precisa do termo assinado. Na própria casa, o morador adere aos serviços e envia a leitura (slide 9).</a:t>
+            </a:r>
+            <a:endParaRPr lang="en-US" sz="1200" dirty="0"/>
+          </a:p>
+        </p:txBody>
+      </p:sp>
+      <p:sp>
+        <p:nvSpPr>
+          <p:cNvPr id="25" name="Slide Number Placeholder 0"/>
+          <p:cNvSpPr>
+            <a:spLocks noGrp="1"/>
+          </p:cNvSpPr>
+          <p:nvPr>
+            <p:ph type="sldNum" sz="quarter" idx="4294967295"/>
+          </p:nvPr>
+        </p:nvSpPr>
+        <p:spPr>
+          <a:xfrm>
+            <a:off x="11094415" y="6400800"/>
+            <a:ext cx="548640" cy="274320"/>
+          </a:xfrm>
+          <a:prstGeom prst="rect">
+            <a:avLst/>
+          </a:prstGeom>
+          <a:extLst>
+            <a:ext uri="{C572A759-6A51-4108-AA02-DFA0A04FC94B}">
+              <ma14:wrappingTextBoxFlag xmlns:ma14="http://schemas.microsoft.com/office/mac/drawingml/2011/main" val="0"/>
+            </a:ext>
+          </a:extLst>
+        </p:spPr>
+        <p:txBody>
+          <a:bodyPr/>
+          <a:lstStyle>
+            <a:lvl1pPr>
+              <a:defRPr sz="1000">
+                <a:solidFill>
+                  <a:srgbClr val="6E5B58"/>
+                </a:solidFill>
+                <a:latin typeface="Calibri"/>
+                <a:ea typeface="Calibri"/>
+                <a:cs typeface="Calibri"/>
+              </a:defRPr>
+            </a:lvl1pPr>
+          </a:lstStyle>
+          <a:p>
+            <a:pPr algn="r"/>
+            <a:fld id="{F7021451-1387-4CA6-816F-3879F97B5CBC}" type="slidenum">
+              <a:rPr b="0" lang="en-US"/>
+              <a:t>11</a:t>
+            </a:fld>
+            <a:endParaRPr lang="en-US"/>
           </a:p>
         </p:txBody>
       </p:sp>

</xml_diff>